<commit_message>
Commit: ACL RR1 Presentation Power Point Completed
</commit_message>
<xml_diff>
--- a/Year2_Semester1_ApplicationComputationalLinguistics/RR1_Presentation_Week2/Todoran_RR1.pptx
+++ b/Year2_Semester1_ApplicationComputationalLinguistics/RR1_Presentation_Week2/Todoran_RR1.pptx
@@ -364,7 +364,7 @@
           <a:p>
             <a:fld id="{C1FF6DA9-008F-8B48-92A6-B652298478BF}" type="slidenum">
               <a:rPr lang="en-US" smtClean="0"/>
-              <a:t>‹N›</a:t>
+              <a:t>‹#›</a:t>
             </a:fld>
             <a:endParaRPr lang="en-US"/>
           </a:p>
@@ -532,7 +532,7 @@
           <a:p>
             <a:fld id="{C1FF6DA9-008F-8B48-92A6-B652298478BF}" type="slidenum">
               <a:rPr lang="en-US" smtClean="0"/>
-              <a:t>‹N›</a:t>
+              <a:t>‹#›</a:t>
             </a:fld>
             <a:endParaRPr lang="en-US"/>
           </a:p>
@@ -710,7 +710,7 @@
           <a:p>
             <a:fld id="{C1FF6DA9-008F-8B48-92A6-B652298478BF}" type="slidenum">
               <a:rPr lang="en-US" smtClean="0"/>
-              <a:t>‹N›</a:t>
+              <a:t>‹#›</a:t>
             </a:fld>
             <a:endParaRPr lang="en-US"/>
           </a:p>
@@ -878,7 +878,7 @@
           <a:p>
             <a:fld id="{C1FF6DA9-008F-8B48-92A6-B652298478BF}" type="slidenum">
               <a:rPr lang="en-US" smtClean="0"/>
-              <a:t>‹N›</a:t>
+              <a:t>‹#›</a:t>
             </a:fld>
             <a:endParaRPr lang="en-US"/>
           </a:p>
@@ -1123,7 +1123,7 @@
           <a:p>
             <a:fld id="{C1FF6DA9-008F-8B48-92A6-B652298478BF}" type="slidenum">
               <a:rPr lang="en-US" smtClean="0"/>
-              <a:t>‹N›</a:t>
+              <a:t>‹#›</a:t>
             </a:fld>
             <a:endParaRPr lang="en-US"/>
           </a:p>
@@ -1408,7 +1408,7 @@
           <a:p>
             <a:fld id="{C1FF6DA9-008F-8B48-92A6-B652298478BF}" type="slidenum">
               <a:rPr lang="en-US" smtClean="0"/>
-              <a:t>‹N›</a:t>
+              <a:t>‹#›</a:t>
             </a:fld>
             <a:endParaRPr lang="en-US"/>
           </a:p>
@@ -1827,7 +1827,7 @@
           <a:p>
             <a:fld id="{C1FF6DA9-008F-8B48-92A6-B652298478BF}" type="slidenum">
               <a:rPr lang="en-US" smtClean="0"/>
-              <a:t>‹N›</a:t>
+              <a:t>‹#›</a:t>
             </a:fld>
             <a:endParaRPr lang="en-US"/>
           </a:p>
@@ -1944,7 +1944,7 @@
           <a:p>
             <a:fld id="{C1FF6DA9-008F-8B48-92A6-B652298478BF}" type="slidenum">
               <a:rPr lang="en-US" smtClean="0"/>
-              <a:t>‹N›</a:t>
+              <a:t>‹#›</a:t>
             </a:fld>
             <a:endParaRPr lang="en-US"/>
           </a:p>
@@ -2039,7 +2039,7 @@
           <a:p>
             <a:fld id="{C1FF6DA9-008F-8B48-92A6-B652298478BF}" type="slidenum">
               <a:rPr lang="en-US" smtClean="0"/>
-              <a:t>‹N›</a:t>
+              <a:t>‹#›</a:t>
             </a:fld>
             <a:endParaRPr lang="en-US"/>
           </a:p>
@@ -2314,7 +2314,7 @@
           <a:p>
             <a:fld id="{C1FF6DA9-008F-8B48-92A6-B652298478BF}" type="slidenum">
               <a:rPr lang="en-US" smtClean="0"/>
-              <a:t>‹N›</a:t>
+              <a:t>‹#›</a:t>
             </a:fld>
             <a:endParaRPr lang="en-US"/>
           </a:p>
@@ -2566,7 +2566,7 @@
           <a:p>
             <a:fld id="{C1FF6DA9-008F-8B48-92A6-B652298478BF}" type="slidenum">
               <a:rPr lang="en-US" smtClean="0"/>
-              <a:t>‹N›</a:t>
+              <a:t>‹#›</a:t>
             </a:fld>
             <a:endParaRPr lang="en-US"/>
           </a:p>
@@ -2813,7 +2813,7 @@
           <a:p>
             <a:fld id="{C1FF6DA9-008F-8B48-92A6-B652298478BF}" type="slidenum">
               <a:rPr lang="en-US" smtClean="0"/>
-              <a:t>‹N›</a:t>
+              <a:t>‹#›</a:t>
             </a:fld>
             <a:endParaRPr lang="en-US"/>
           </a:p>
@@ -5268,8 +5268,8 @@
         </p:nvSpPr>
         <p:spPr>
           <a:xfrm>
-            <a:off x="5604569" y="2076450"/>
-            <a:ext cx="5977830" cy="895350"/>
+            <a:off x="5591249" y="1827752"/>
+            <a:ext cx="5977830" cy="1063942"/>
           </a:xfrm>
           <a:prstGeom prst="rect">
             <a:avLst/>
@@ -5313,8 +5313,8 @@
         </p:nvSpPr>
         <p:spPr>
           <a:xfrm>
-            <a:off x="5604569" y="3124200"/>
-            <a:ext cx="5977830" cy="895350"/>
+            <a:off x="5591250" y="3045998"/>
+            <a:ext cx="5977830" cy="1000126"/>
           </a:xfrm>
           <a:prstGeom prst="rect">
             <a:avLst/>
@@ -5358,8 +5358,8 @@
         </p:nvSpPr>
         <p:spPr>
           <a:xfrm>
-            <a:off x="5604569" y="4171950"/>
-            <a:ext cx="5977830" cy="895350"/>
+            <a:off x="5591250" y="4196619"/>
+            <a:ext cx="5977830" cy="1047750"/>
           </a:xfrm>
           <a:prstGeom prst="rect">
             <a:avLst/>
@@ -5403,7 +5403,7 @@
         </p:nvSpPr>
         <p:spPr>
           <a:xfrm>
-            <a:off x="5604569" y="2076450"/>
+            <a:off x="5591249" y="1827752"/>
             <a:ext cx="38100" cy="895350"/>
           </a:xfrm>
           <a:prstGeom prst="rect">
@@ -5448,7 +5448,7 @@
         </p:nvSpPr>
         <p:spPr>
           <a:xfrm>
-            <a:off x="5604569" y="3124200"/>
+            <a:off x="5591250" y="3029806"/>
             <a:ext cx="38100" cy="895350"/>
           </a:xfrm>
           <a:prstGeom prst="rect">
@@ -5493,7 +5493,7 @@
         </p:nvSpPr>
         <p:spPr>
           <a:xfrm>
-            <a:off x="5604569" y="4171950"/>
+            <a:off x="5591250" y="4196619"/>
             <a:ext cx="38100" cy="895350"/>
           </a:xfrm>
           <a:prstGeom prst="rect">
@@ -5624,7 +5624,7 @@
           <a:p>
             <a:pPr algn="l"/>
             <a:r>
-              <a:rPr sz="1050" b="0" i="0" u="none">
+              <a:rPr sz="1050" b="0" i="0" u="none" dirty="0">
                 <a:solidFill>
                   <a:srgbClr val="64748B"/>
                 </a:solidFill>
@@ -5717,8 +5717,8 @@
         </p:nvSpPr>
         <p:spPr>
           <a:xfrm>
-            <a:off x="463860" y="3666232"/>
-            <a:ext cx="4981649" cy="200025"/>
+            <a:off x="1682733" y="3527732"/>
+            <a:ext cx="2543902" cy="276999"/>
           </a:xfrm>
           <a:prstGeom prst="rect">
             <a:avLst/>
@@ -5733,7 +5733,7 @@
           <a:p>
             <a:pPr algn="ctr"/>
             <a:r>
-              <a:rPr sz="1350" b="1" i="0" u="none">
+              <a:rPr b="1" i="0" u="none" dirty="0">
                 <a:solidFill>
                   <a:srgbClr val="0F172A"/>
                 </a:solidFill>
@@ -5753,7 +5753,7 @@
         <p:spPr>
           <a:xfrm>
             <a:off x="463860" y="3942457"/>
-            <a:ext cx="4981649" cy="373260"/>
+            <a:ext cx="4981649" cy="397545"/>
           </a:xfrm>
           <a:prstGeom prst="rect">
             <a:avLst/>
@@ -5772,27 +5772,33 @@
               </a:lnSpc>
             </a:pPr>
             <a:r>
-              <a:rPr sz="1050" b="0" i="0" u="none">
+              <a:rPr b="0" i="0" u="none" dirty="0">
                 <a:solidFill>
                   <a:srgbClr val="475569"/>
                 </a:solidFill>
                 <a:latin typeface="Inter"/>
               </a:rPr>
-              <a:t>Outperforms existing state-of-the-art LLM-based matching frameworks on standard OAEI benchmarks.</a:t>
-            </a:r>
-          </a:p>
-        </p:txBody>
-      </p:sp>
-      <p:sp>
-        <p:nvSpPr>
-          <p:cNvPr id="18" name="TextBox 17"/>
+              <a:t>Outperforms existing LLM-based matching frameworks on standard OAEI benchmarks.</a:t>
+            </a:r>
+          </a:p>
+        </p:txBody>
+      </p:sp>
+      <p:sp>
+        <p:nvSpPr>
+          <p:cNvPr id="25" name="TextBox 24">
+            <a:extLst>
+              <a:ext uri="{FF2B5EF4-FFF2-40B4-BE49-F238E27FC236}">
+                <a16:creationId xmlns:a16="http://schemas.microsoft.com/office/drawing/2014/main" id="{B8B7735F-1AA8-4A22-7D67-1D8E4861C585}"/>
+              </a:ext>
+            </a:extLst>
+          </p:cNvPr>
           <p:cNvSpPr txBox="1"/>
           <p:nvPr/>
         </p:nvSpPr>
         <p:spPr>
           <a:xfrm>
-            <a:off x="5833169" y="2228850"/>
-            <a:ext cx="6358830" cy="190500"/>
+            <a:off x="5736989" y="1989677"/>
+            <a:ext cx="2701702" cy="246221"/>
           </a:xfrm>
           <a:prstGeom prst="rect">
             <a:avLst/>
@@ -5807,27 +5813,33 @@
           <a:p>
             <a:pPr algn="l"/>
             <a:r>
-              <a:rPr sz="1200" b="1" i="0" u="none">
-                <a:solidFill>
-                  <a:srgbClr val="0F172A"/>
-                </a:solidFill>
-                <a:latin typeface="Inter"/>
-              </a:rPr>
-              <a:t>Dual-Ablation Synergies</a:t>
-            </a:r>
-          </a:p>
-        </p:txBody>
-      </p:sp>
-      <p:sp>
-        <p:nvSpPr>
-          <p:cNvPr id="19" name="TextBox 18"/>
+              <a:rPr sz="1600" b="1" i="0" u="none" dirty="0">
+                <a:solidFill>
+                  <a:srgbClr val="1F2937"/>
+                </a:solidFill>
+                <a:latin typeface="Inter"/>
+              </a:rPr>
+              <a:t>Retrieval &amp; Refinement Synergy</a:t>
+            </a:r>
+          </a:p>
+        </p:txBody>
+      </p:sp>
+      <p:sp>
+        <p:nvSpPr>
+          <p:cNvPr id="27" name="TextBox 26">
+            <a:extLst>
+              <a:ext uri="{FF2B5EF4-FFF2-40B4-BE49-F238E27FC236}">
+                <a16:creationId xmlns:a16="http://schemas.microsoft.com/office/drawing/2014/main" id="{D2FCF090-1E96-13E2-310A-93311D82E09B}"/>
+              </a:ext>
+            </a:extLst>
+          </p:cNvPr>
           <p:cNvSpPr txBox="1"/>
           <p:nvPr/>
         </p:nvSpPr>
         <p:spPr>
           <a:xfrm>
-            <a:off x="5833169" y="2457450"/>
-            <a:ext cx="5653980" cy="361950"/>
+            <a:off x="5736989" y="2227802"/>
+            <a:ext cx="4868167" cy="492443"/>
           </a:xfrm>
           <a:prstGeom prst="rect">
             <a:avLst/>
@@ -5842,27 +5854,33 @@
           <a:p>
             <a:pPr algn="l"/>
             <a:r>
-              <a:rPr sz="1125" b="0" i="0" u="none">
-                <a:solidFill>
-                  <a:srgbClr val="475569"/>
-                </a:solidFill>
-                <a:latin typeface="Inter"/>
-              </a:rPr>
-              <a:t>Both external retrieval and structural checking independently provide critical precision jumps.</a:t>
-            </a:r>
-          </a:p>
-        </p:txBody>
-      </p:sp>
-      <p:sp>
-        <p:nvSpPr>
-          <p:cNvPr id="20" name="TextBox 19"/>
+              <a:rPr sz="1600" b="0" i="0" u="none" dirty="0">
+                <a:solidFill>
+                  <a:srgbClr val="4B5563"/>
+                </a:solidFill>
+                <a:latin typeface="Inter"/>
+              </a:rPr>
+              <a:t>Both external knowledge integration and parent-child validation directly boost accuracy.</a:t>
+            </a:r>
+          </a:p>
+        </p:txBody>
+      </p:sp>
+      <p:sp>
+        <p:nvSpPr>
+          <p:cNvPr id="29" name="TextBox 28">
+            <a:extLst>
+              <a:ext uri="{FF2B5EF4-FFF2-40B4-BE49-F238E27FC236}">
+                <a16:creationId xmlns:a16="http://schemas.microsoft.com/office/drawing/2014/main" id="{76D345E1-30EC-6272-B38F-576EA0111FDF}"/>
+              </a:ext>
+            </a:extLst>
+          </p:cNvPr>
           <p:cNvSpPr txBox="1"/>
           <p:nvPr/>
         </p:nvSpPr>
         <p:spPr>
           <a:xfrm>
-            <a:off x="5833169" y="3276600"/>
-            <a:ext cx="6358830" cy="190500"/>
+            <a:off x="5736990" y="3196493"/>
+            <a:ext cx="2092239" cy="246221"/>
           </a:xfrm>
           <a:prstGeom prst="rect">
             <a:avLst/>
@@ -5877,27 +5895,33 @@
           <a:p>
             <a:pPr algn="l"/>
             <a:r>
-              <a:rPr sz="1200" b="1" i="0" u="none">
-                <a:solidFill>
-                  <a:srgbClr val="0F172A"/>
-                </a:solidFill>
-                <a:latin typeface="Inter"/>
-              </a:rPr>
-              <a:t>Reasoning Trade-offs</a:t>
-            </a:r>
-          </a:p>
-        </p:txBody>
-      </p:sp>
-      <p:sp>
-        <p:nvSpPr>
-          <p:cNvPr id="21" name="TextBox 20"/>
+              <a:rPr sz="1600" b="1" i="0" u="none" dirty="0">
+                <a:solidFill>
+                  <a:srgbClr val="1F2937"/>
+                </a:solidFill>
+                <a:latin typeface="Inter"/>
+              </a:rPr>
+              <a:t>Computational Trade-off</a:t>
+            </a:r>
+          </a:p>
+        </p:txBody>
+      </p:sp>
+      <p:sp>
+        <p:nvSpPr>
+          <p:cNvPr id="31" name="TextBox 30">
+            <a:extLst>
+              <a:ext uri="{FF2B5EF4-FFF2-40B4-BE49-F238E27FC236}">
+                <a16:creationId xmlns:a16="http://schemas.microsoft.com/office/drawing/2014/main" id="{57632D59-7239-3A32-FC14-184A641FC034}"/>
+              </a:ext>
+            </a:extLst>
+          </p:cNvPr>
           <p:cNvSpPr txBox="1"/>
           <p:nvPr/>
         </p:nvSpPr>
         <p:spPr>
           <a:xfrm>
-            <a:off x="5833169" y="3505200"/>
-            <a:ext cx="5653980" cy="361950"/>
+            <a:off x="5736990" y="3434618"/>
+            <a:ext cx="4868167" cy="492443"/>
           </a:xfrm>
           <a:prstGeom prst="rect">
             <a:avLst/>
@@ -5912,45 +5936,33 @@
           <a:p>
             <a:pPr algn="l"/>
             <a:r>
-              <a:rPr sz="1125" b="0" i="0" u="none">
-                <a:solidFill>
-                  <a:srgbClr val="475569"/>
-                </a:solidFill>
-                <a:latin typeface="Inter"/>
-              </a:rPr>
-              <a:t>Multi-agent debate and extended chain-of-thought do </a:t>
-            </a:r>
-            <a:r>
-              <a:rPr sz="1125" b="0" i="1" u="none">
-                <a:solidFill>
-                  <a:srgbClr val="475569"/>
-                </a:solidFill>
-                <a:latin typeface="Inter"/>
-              </a:rPr>
-              <a:t>not</a:t>
-            </a:r>
-            <a:r>
-              <a:rPr sz="1125" b="0" i="0" u="none">
-                <a:solidFill>
-                  <a:srgbClr val="475569"/>
-                </a:solidFill>
-                <a:latin typeface="Inter"/>
-              </a:rPr>
-              <a:t> increase accuracy proportionally; they significantly inflate compute costs.</a:t>
-            </a:r>
-          </a:p>
-        </p:txBody>
-      </p:sp>
-      <p:sp>
-        <p:nvSpPr>
-          <p:cNvPr id="22" name="TextBox 21"/>
+              <a:rPr sz="1600" b="0" i="0" u="none">
+                <a:solidFill>
+                  <a:srgbClr val="4B5563"/>
+                </a:solidFill>
+                <a:latin typeface="Inter"/>
+              </a:rPr>
+              <a:t>Multi-agent debate and extended reasoning increase costs without guaranteeing accuracy gains.</a:t>
+            </a:r>
+          </a:p>
+        </p:txBody>
+      </p:sp>
+      <p:sp>
+        <p:nvSpPr>
+          <p:cNvPr id="33" name="TextBox 32">
+            <a:extLst>
+              <a:ext uri="{FF2B5EF4-FFF2-40B4-BE49-F238E27FC236}">
+                <a16:creationId xmlns:a16="http://schemas.microsoft.com/office/drawing/2014/main" id="{B1D73212-2E02-0B96-04EC-568296888ACB}"/>
+              </a:ext>
+            </a:extLst>
+          </p:cNvPr>
           <p:cNvSpPr txBox="1"/>
           <p:nvPr/>
         </p:nvSpPr>
         <p:spPr>
           <a:xfrm>
-            <a:off x="5833169" y="4324350"/>
-            <a:ext cx="6358830" cy="190500"/>
+            <a:off x="5736990" y="4358544"/>
+            <a:ext cx="2561920" cy="246221"/>
           </a:xfrm>
           <a:prstGeom prst="rect">
             <a:avLst/>
@@ -5965,27 +5977,33 @@
           <a:p>
             <a:pPr algn="l"/>
             <a:r>
-              <a:rPr sz="1200" b="1" i="0" u="none">
-                <a:solidFill>
-                  <a:srgbClr val="991B1B"/>
-                </a:solidFill>
-                <a:latin typeface="Inter"/>
-              </a:rPr>
-              <a:t>Key Limitation: Specialized Domains</a:t>
-            </a:r>
-          </a:p>
-        </p:txBody>
-      </p:sp>
-      <p:sp>
-        <p:nvSpPr>
-          <p:cNvPr id="23" name="TextBox 22"/>
+              <a:rPr sz="1600" b="1" i="0" u="none">
+                <a:solidFill>
+                  <a:srgbClr val="1F2937"/>
+                </a:solidFill>
+                <a:latin typeface="Inter"/>
+              </a:rPr>
+              <a:t>Specialized Domain Limitation</a:t>
+            </a:r>
+          </a:p>
+        </p:txBody>
+      </p:sp>
+      <p:sp>
+        <p:nvSpPr>
+          <p:cNvPr id="35" name="TextBox 34">
+            <a:extLst>
+              <a:ext uri="{FF2B5EF4-FFF2-40B4-BE49-F238E27FC236}">
+                <a16:creationId xmlns:a16="http://schemas.microsoft.com/office/drawing/2014/main" id="{862F728A-CFB1-8FB9-BC00-F6EF774F92EA}"/>
+              </a:ext>
+            </a:extLst>
+          </p:cNvPr>
           <p:cNvSpPr txBox="1"/>
           <p:nvPr/>
         </p:nvSpPr>
         <p:spPr>
           <a:xfrm>
-            <a:off x="5833169" y="4552950"/>
-            <a:ext cx="5653980" cy="361950"/>
+            <a:off x="5736990" y="4596669"/>
+            <a:ext cx="4868167" cy="492443"/>
           </a:xfrm>
           <a:prstGeom prst="rect">
             <a:avLst/>
@@ -6000,13 +6018,13 @@
           <a:p>
             <a:pPr algn="l"/>
             <a:r>
-              <a:rPr sz="1125" b="0" i="0" u="none">
-                <a:solidFill>
-                  <a:srgbClr val="7F1D1D"/>
-                </a:solidFill>
-                <a:latin typeface="Inter"/>
-              </a:rPr>
-              <a:t>Performance degrades in niche domains (e.g., materials science) where external web-scale knowledge bases lack definitions.</a:t>
+              <a:rPr sz="1600" b="0" i="0" u="none" dirty="0">
+                <a:solidFill>
+                  <a:srgbClr val="4B5563"/>
+                </a:solidFill>
+                <a:latin typeface="Inter"/>
+              </a:rPr>
+              <a:t>Performance drops in sparse knowledge domains like materials science.</a:t>
             </a:r>
           </a:p>
         </p:txBody>
@@ -6095,55 +6113,6 @@
       </p:sp>
       <p:sp>
         <p:nvSpPr>
-          <p:cNvPr id="3" name="Rounded Rectangle 2"/>
-          <p:cNvSpPr/>
-          <p:nvPr/>
-        </p:nvSpPr>
-        <p:spPr>
-          <a:xfrm>
-            <a:off x="9848850" y="614362"/>
-            <a:ext cx="1733550" cy="295275"/>
-          </a:xfrm>
-          <a:prstGeom prst="roundRect">
-            <a:avLst>
-              <a:gd name="adj" fmla="val 50000"/>
-            </a:avLst>
-          </a:prstGeom>
-          <a:solidFill>
-            <a:srgbClr val="F0FDFA"/>
-          </a:solidFill>
-          <a:ln w="9525">
-            <a:solidFill>
-              <a:srgbClr val="99F6E4"/>
-            </a:solidFill>
-          </a:ln>
-          <a:effectLst/>
-        </p:spPr>
-        <p:style>
-          <a:lnRef idx="1">
-            <a:schemeClr val="accent1"/>
-          </a:lnRef>
-          <a:fillRef idx="3">
-            <a:schemeClr val="accent1"/>
-          </a:fillRef>
-          <a:effectRef idx="2">
-            <a:schemeClr val="accent1"/>
-          </a:effectRef>
-          <a:fontRef idx="minor">
-            <a:schemeClr val="lt1"/>
-          </a:fontRef>
-        </p:style>
-        <p:txBody>
-          <a:bodyPr rtlCol="0" anchor="ctr"/>
-          <a:lstStyle/>
-          <a:p>
-            <a:pPr algn="ctr"/>
-            <a:endParaRPr/>
-          </a:p>
-        </p:txBody>
-      </p:sp>
-      <p:sp>
-        <p:nvSpPr>
           <p:cNvPr id="4" name="Rounded Rectangle 3"/>
           <p:cNvSpPr/>
           <p:nvPr/>
@@ -6246,8 +6215,8 @@
         </p:nvSpPr>
         <p:spPr>
           <a:xfrm>
-            <a:off x="7859464" y="2195512"/>
-            <a:ext cx="3722935" cy="2628900"/>
+            <a:off x="7890066" y="1938337"/>
+            <a:ext cx="3722935" cy="3143249"/>
           </a:xfrm>
           <a:prstGeom prst="roundRect">
             <a:avLst>
@@ -6351,7 +6320,7 @@
         </p:blipFill>
         <p:spPr>
           <a:xfrm>
-            <a:off x="8135689" y="2471737"/>
+            <a:off x="8116639" y="2319337"/>
             <a:ext cx="381000" cy="381000"/>
           </a:xfrm>
           <a:prstGeom prst="rect">
@@ -6399,7 +6368,7 @@
         </p:blipFill>
         <p:spPr>
           <a:xfrm>
-            <a:off x="8216651" y="2576512"/>
+            <a:off x="8197601" y="2424112"/>
             <a:ext cx="219075" cy="171450"/>
           </a:xfrm>
           <a:prstGeom prst="rect">
@@ -6407,41 +6376,6 @@
           </a:prstGeom>
         </p:spPr>
       </p:pic>
-      <p:sp>
-        <p:nvSpPr>
-          <p:cNvPr id="12" name="TextBox 11"/>
-          <p:cNvSpPr txBox="1"/>
-          <p:nvPr/>
-        </p:nvSpPr>
-        <p:spPr>
-          <a:xfrm>
-            <a:off x="9982200" y="671512"/>
-            <a:ext cx="1562100" cy="180975"/>
-          </a:xfrm>
-          <a:prstGeom prst="rect">
-            <a:avLst/>
-          </a:prstGeom>
-          <a:noFill/>
-        </p:spPr>
-        <p:txBody>
-          <a:bodyPr wrap="square" lIns="0" tIns="0" rIns="0" bIns="0" anchor="t">
-            <a:spAutoFit/>
-          </a:bodyPr>
-          <a:lstStyle/>
-          <a:p>
-            <a:pPr algn="l"/>
-            <a:r>
-              <a:rPr sz="975" b="1" i="0" u="none">
-                <a:solidFill>
-                  <a:srgbClr val="0D9488"/>
-                </a:solidFill>
-                <a:latin typeface="JetBrains Mono"/>
-              </a:rPr>
-              <a:t>Zero LLM Retraining</a:t>
-            </a:r>
-          </a:p>
-        </p:txBody>
-      </p:sp>
       <p:sp>
         <p:nvSpPr>
           <p:cNvPr id="13" name="TextBox 12"/>
@@ -6488,14 +6422,14 @@
       </p:sp>
       <p:sp>
         <p:nvSpPr>
-          <p:cNvPr id="14" name="TextBox 13"/>
+          <p:cNvPr id="16" name="TextBox 15"/>
           <p:cNvSpPr txBox="1"/>
           <p:nvPr/>
         </p:nvSpPr>
         <p:spPr>
           <a:xfrm>
-            <a:off x="609600" y="457200"/>
-            <a:ext cx="8358187" cy="171450"/>
+            <a:off x="4431534" y="3257550"/>
+            <a:ext cx="3328931" cy="247650"/>
           </a:xfrm>
           <a:prstGeom prst="rect">
             <a:avLst/>
@@ -6508,76 +6442,6 @@
           </a:bodyPr>
           <a:lstStyle/>
           <a:p>
-            <a:pPr algn="l"/>
-            <a:r>
-              <a:rPr sz="1050" b="1" i="0" u="none">
-                <a:solidFill>
-                  <a:srgbClr val="0D9488"/>
-                </a:solidFill>
-                <a:latin typeface="Space Grotesk"/>
-              </a:rPr>
-              <a:t>PAPER ANALYSIS • QIANG ET AL. (PVLDB 2024)</a:t>
-            </a:r>
-          </a:p>
-        </p:txBody>
-      </p:sp>
-      <p:sp>
-        <p:nvSpPr>
-          <p:cNvPr id="15" name="TextBox 14"/>
-          <p:cNvSpPr txBox="1"/>
-          <p:nvPr/>
-        </p:nvSpPr>
-        <p:spPr>
-          <a:xfrm>
-            <a:off x="609600" y="685800"/>
-            <a:ext cx="8776096" cy="381000"/>
-          </a:xfrm>
-          <a:prstGeom prst="rect">
-            <a:avLst/>
-          </a:prstGeom>
-          <a:noFill/>
-        </p:spPr>
-        <p:txBody>
-          <a:bodyPr wrap="none" lIns="0" tIns="0" rIns="0" bIns="0" anchor="t">
-            <a:spAutoFit/>
-          </a:bodyPr>
-          <a:lstStyle/>
-          <a:p>
-            <a:pPr algn="l"/>
-            <a:r>
-              <a:rPr sz="2400" b="1" i="0" u="none">
-                <a:solidFill>
-                  <a:srgbClr val="0F172A"/>
-                </a:solidFill>
-                <a:latin typeface="Space Grotesk"/>
-              </a:rPr>
-              <a:t>Agent-OM: Collaborative Multi-Agent System</a:t>
-            </a:r>
-          </a:p>
-        </p:txBody>
-      </p:sp>
-      <p:sp>
-        <p:nvSpPr>
-          <p:cNvPr id="16" name="TextBox 15"/>
-          <p:cNvSpPr txBox="1"/>
-          <p:nvPr/>
-        </p:nvSpPr>
-        <p:spPr>
-          <a:xfrm>
-            <a:off x="4431534" y="3257550"/>
-            <a:ext cx="3328931" cy="247650"/>
-          </a:xfrm>
-          <a:prstGeom prst="rect">
-            <a:avLst/>
-          </a:prstGeom>
-          <a:noFill/>
-        </p:spPr>
-        <p:txBody>
-          <a:bodyPr wrap="none" lIns="0" tIns="0" rIns="0" bIns="0" anchor="t">
-            <a:spAutoFit/>
-          </a:bodyPr>
-          <a:lstStyle/>
-          <a:p>
             <a:pPr algn="ctr"/>
             <a:r>
               <a:rPr sz="1500" b="1" i="0" u="none">
@@ -6600,7 +6464,7 @@
         <p:spPr>
           <a:xfrm>
             <a:off x="4510794" y="3581400"/>
-            <a:ext cx="3170411" cy="600075"/>
+            <a:ext cx="3170411" cy="625171"/>
           </a:xfrm>
           <a:prstGeom prst="rect">
             <a:avLst/>
@@ -6619,13 +6483,30 @@
               </a:lnSpc>
             </a:pPr>
             <a:r>
-              <a:rPr sz="1050" b="0" i="0" u="none">
-                <a:solidFill>
-                  <a:srgbClr val="94A3B8"/>
-                </a:solidFill>
-                <a:latin typeface="Inter"/>
-              </a:rPr>
-              <a:t>Central repository for parsed entity profiles, vector indexes, and intermediate rankings.</a:t>
+              <a:rPr b="0" i="0" u="none" dirty="0">
+                <a:solidFill>
+                  <a:schemeClr val="bg1"/>
+                </a:solidFill>
+                <a:latin typeface="Inter"/>
+              </a:rPr>
+              <a:t>Central repository for parsed entity profiles, vector indexes</a:t>
+            </a:r>
+            <a:br>
+              <a:rPr lang="en-US" b="0" i="0" u="none" dirty="0">
+                <a:solidFill>
+                  <a:schemeClr val="bg1"/>
+                </a:solidFill>
+                <a:latin typeface="Inter"/>
+              </a:rPr>
+            </a:br>
+            <a:r>
+              <a:rPr b="0" i="0" u="none" dirty="0">
+                <a:solidFill>
+                  <a:schemeClr val="bg1"/>
+                </a:solidFill>
+                <a:latin typeface="Inter"/>
+              </a:rPr>
+              <a:t>and intermediate rankings.</a:t>
             </a:r>
           </a:p>
         </p:txBody>
@@ -6728,7 +6609,7 @@
               </a:lnSpc>
             </a:pPr>
             <a:r>
-              <a:rPr sz="1125" b="1" i="0" u="none">
+              <a:rPr b="1" i="0" u="none" dirty="0">
                 <a:solidFill>
                   <a:srgbClr val="475569"/>
                 </a:solidFill>
@@ -6737,7 +6618,7 @@
               <a:t>Metadata Extraction:</a:t>
             </a:r>
             <a:r>
-              <a:rPr sz="1125" b="0" i="0" u="none">
+              <a:rPr b="0" i="0" u="none" dirty="0">
                 <a:solidFill>
                   <a:srgbClr val="475569"/>
                 </a:solidFill>
@@ -6811,7 +6692,7 @@
               </a:lnSpc>
             </a:pPr>
             <a:r>
-              <a:rPr sz="1125" b="1" i="0" u="none">
+              <a:rPr b="1" i="0" u="none" dirty="0">
                 <a:solidFill>
                   <a:srgbClr val="475569"/>
                 </a:solidFill>
@@ -6820,7 +6701,7 @@
               <a:t>Name Normalization:</a:t>
             </a:r>
             <a:r>
-              <a:rPr sz="1125" b="0" i="0" u="none">
+              <a:rPr b="0" i="0" u="none" dirty="0">
                 <a:solidFill>
                   <a:srgbClr val="475569"/>
                 </a:solidFill>
@@ -6894,7 +6775,7 @@
               </a:lnSpc>
             </a:pPr>
             <a:r>
-              <a:rPr sz="1125" b="1" i="0" u="none">
+              <a:rPr b="1" i="0" u="none">
                 <a:solidFill>
                   <a:srgbClr val="475569"/>
                 </a:solidFill>
@@ -6903,7 +6784,7 @@
               <a:t>Semantic Synthesis:</a:t>
             </a:r>
             <a:r>
-              <a:rPr sz="1125" b="0" i="0" u="none">
+              <a:rPr b="0" i="0" u="none">
                 <a:solidFill>
                   <a:srgbClr val="475569"/>
                 </a:solidFill>
@@ -6977,7 +6858,7 @@
               </a:lnSpc>
             </a:pPr>
             <a:r>
-              <a:rPr sz="1125" b="1" i="0" u="none">
+              <a:rPr b="1" i="0" u="none">
                 <a:solidFill>
                   <a:srgbClr val="475569"/>
                 </a:solidFill>
@@ -6986,7 +6867,7 @@
               <a:t>Vector Construction:</a:t>
             </a:r>
             <a:r>
-              <a:rPr sz="1125" b="0" i="0" u="none">
+              <a:rPr b="0" i="0" u="none">
                 <a:solidFill>
                   <a:srgbClr val="475569"/>
                 </a:solidFill>
@@ -7005,7 +6886,7 @@
         </p:nvSpPr>
         <p:spPr>
           <a:xfrm>
-            <a:off x="8630989" y="2538412"/>
+            <a:off x="8611939" y="2386012"/>
             <a:ext cx="1950243" cy="247650"/>
           </a:xfrm>
           <a:prstGeom prst="rect">
@@ -7040,7 +6921,7 @@
         </p:nvSpPr>
         <p:spPr>
           <a:xfrm>
-            <a:off x="8230939" y="3005137"/>
+            <a:off x="8223288" y="2849165"/>
             <a:ext cx="76200" cy="257175"/>
           </a:xfrm>
           <a:prstGeom prst="rect">
@@ -7056,7 +6937,7 @@
           <a:p>
             <a:pPr algn="l"/>
             <a:r>
-              <a:rPr sz="1125" b="0" i="0" u="none">
+              <a:rPr sz="1125" b="0" i="0" u="none" dirty="0">
                 <a:solidFill>
                   <a:srgbClr val="475569"/>
                 </a:solidFill>
@@ -7075,7 +6956,7 @@
         </p:nvSpPr>
         <p:spPr>
           <a:xfrm>
-            <a:off x="8307139" y="3005137"/>
+            <a:off x="8326188" y="2821981"/>
             <a:ext cx="3094285" cy="514350"/>
           </a:xfrm>
           <a:prstGeom prst="rect">
@@ -7095,7 +6976,7 @@
               </a:lnSpc>
             </a:pPr>
             <a:r>
-              <a:rPr sz="1125" b="1" i="0" u="none">
+              <a:rPr b="1" i="0" u="none" dirty="0">
                 <a:solidFill>
                   <a:srgbClr val="475569"/>
                 </a:solidFill>
@@ -7104,7 +6985,7 @@
               <a:t>Candidate Retrieval:</a:t>
             </a:r>
             <a:r>
-              <a:rPr sz="1125" b="0" i="0" u="none">
+              <a:rPr b="0" i="0" u="none" dirty="0">
                 <a:solidFill>
                   <a:srgbClr val="475569"/>
                 </a:solidFill>
@@ -7123,7 +7004,7 @@
         </p:nvSpPr>
         <p:spPr>
           <a:xfrm>
-            <a:off x="8230939" y="3519487"/>
+            <a:off x="8230939" y="3354950"/>
             <a:ext cx="76200" cy="257175"/>
           </a:xfrm>
           <a:prstGeom prst="rect">
@@ -7139,7 +7020,7 @@
           <a:p>
             <a:pPr algn="l"/>
             <a:r>
-              <a:rPr sz="1125" b="0" i="0" u="none">
+              <a:rPr sz="1125" b="0" i="0" u="none" dirty="0">
                 <a:solidFill>
                   <a:srgbClr val="475569"/>
                 </a:solidFill>
@@ -7158,8 +7039,8 @@
         </p:nvSpPr>
         <p:spPr>
           <a:xfrm>
-            <a:off x="8307139" y="3519487"/>
-            <a:ext cx="3748794" cy="257175"/>
+            <a:off x="8307139" y="3326705"/>
+            <a:ext cx="3094285" cy="512961"/>
           </a:xfrm>
           <a:prstGeom prst="rect">
             <a:avLst/>
@@ -7167,7 +7048,7 @@
           <a:noFill/>
         </p:spPr>
         <p:txBody>
-          <a:bodyPr wrap="none" lIns="76200" tIns="0" rIns="0" bIns="0" anchor="t">
+          <a:bodyPr wrap="square" lIns="76200" tIns="0" rIns="0" bIns="0" anchor="t">
             <a:spAutoFit/>
           </a:bodyPr>
           <a:lstStyle/>
@@ -7178,7 +7059,7 @@
               </a:lnSpc>
             </a:pPr>
             <a:r>
-              <a:rPr sz="1125" b="1" i="0" u="none">
+              <a:rPr b="1" i="0" u="none" dirty="0">
                 <a:solidFill>
                   <a:srgbClr val="475569"/>
                 </a:solidFill>
@@ -7187,7 +7068,7 @@
               <a:t>Rank Fusion:</a:t>
             </a:r>
             <a:r>
-              <a:rPr sz="1125" b="0" i="0" u="none">
+              <a:rPr b="0" i="0" u="none" dirty="0">
                 <a:solidFill>
                   <a:srgbClr val="475569"/>
                 </a:solidFill>
@@ -7206,7 +7087,7 @@
         </p:nvSpPr>
         <p:spPr>
           <a:xfrm>
-            <a:off x="8230939" y="3776662"/>
+            <a:off x="8223288" y="3859411"/>
             <a:ext cx="76200" cy="257175"/>
           </a:xfrm>
           <a:prstGeom prst="rect">
@@ -7222,7 +7103,7 @@
           <a:p>
             <a:pPr algn="l"/>
             <a:r>
-              <a:rPr sz="1125" b="0" i="0" u="none">
+              <a:rPr sz="1125" b="0" i="0" u="none" dirty="0">
                 <a:solidFill>
                   <a:srgbClr val="475569"/>
                 </a:solidFill>
@@ -7241,8 +7122,8 @@
         </p:nvSpPr>
         <p:spPr>
           <a:xfrm>
-            <a:off x="8307139" y="3776662"/>
-            <a:ext cx="3748794" cy="257175"/>
+            <a:off x="8326188" y="3834459"/>
+            <a:ext cx="3094285" cy="512961"/>
           </a:xfrm>
           <a:prstGeom prst="rect">
             <a:avLst/>
@@ -7250,7 +7131,7 @@
           <a:noFill/>
         </p:spPr>
         <p:txBody>
-          <a:bodyPr wrap="none" lIns="76200" tIns="0" rIns="0" bIns="0" anchor="t">
+          <a:bodyPr wrap="square" lIns="76200" tIns="0" rIns="0" bIns="0" anchor="t">
             <a:spAutoFit/>
           </a:bodyPr>
           <a:lstStyle/>
@@ -7261,7 +7142,7 @@
               </a:lnSpc>
             </a:pPr>
             <a:r>
-              <a:rPr sz="1125" b="1" i="0" u="none">
+              <a:rPr b="1" i="0" u="none" dirty="0">
                 <a:solidFill>
                   <a:srgbClr val="475569"/>
                 </a:solidFill>
@@ -7270,7 +7151,7 @@
               <a:t>LLM Validation:</a:t>
             </a:r>
             <a:r>
-              <a:rPr sz="1125" b="0" i="0" u="none">
+              <a:rPr b="0" i="0" u="none" dirty="0">
                 <a:solidFill>
                   <a:srgbClr val="475569"/>
                 </a:solidFill>
@@ -7289,7 +7170,7 @@
         </p:nvSpPr>
         <p:spPr>
           <a:xfrm>
-            <a:off x="8230939" y="4033837"/>
+            <a:off x="8230939" y="4319587"/>
             <a:ext cx="76200" cy="257175"/>
           </a:xfrm>
           <a:prstGeom prst="rect">
@@ -7305,7 +7186,7 @@
           <a:p>
             <a:pPr algn="l"/>
             <a:r>
-              <a:rPr sz="1125" b="0" i="0" u="none">
+              <a:rPr sz="1125" b="0" i="0" u="none" dirty="0">
                 <a:solidFill>
                   <a:srgbClr val="475569"/>
                 </a:solidFill>
@@ -7324,7 +7205,7 @@
         </p:nvSpPr>
         <p:spPr>
           <a:xfrm>
-            <a:off x="8307139" y="4033837"/>
+            <a:off x="8326187" y="4319587"/>
             <a:ext cx="3094285" cy="514350"/>
           </a:xfrm>
           <a:prstGeom prst="rect">
@@ -7344,7 +7225,7 @@
               </a:lnSpc>
             </a:pPr>
             <a:r>
-              <a:rPr sz="1125" b="1" i="0" u="none">
+              <a:rPr b="1" i="0" u="none" dirty="0">
                 <a:solidFill>
                   <a:srgbClr val="475569"/>
                 </a:solidFill>
@@ -7353,13 +7234,71 @@
               <a:t>Bidirectional Agreement:</a:t>
             </a:r>
             <a:r>
-              <a:rPr sz="1125" b="0" i="0" u="none">
+              <a:rPr b="0" i="0" u="none" dirty="0">
                 <a:solidFill>
                   <a:srgbClr val="475569"/>
                 </a:solidFill>
                 <a:latin typeface="Inter"/>
               </a:rPr>
               <a:t> Ensures 2-way consistency.</a:t>
+            </a:r>
+          </a:p>
+        </p:txBody>
+      </p:sp>
+      <p:sp>
+        <p:nvSpPr>
+          <p:cNvPr id="37" name="TextBox 36">
+            <a:extLst>
+              <a:ext uri="{FF2B5EF4-FFF2-40B4-BE49-F238E27FC236}">
+                <a16:creationId xmlns:a16="http://schemas.microsoft.com/office/drawing/2014/main" id="{0D00E616-A549-3A76-EFA4-A0EB706A328E}"/>
+              </a:ext>
+            </a:extLst>
+          </p:cNvPr>
+          <p:cNvSpPr txBox="1"/>
+          <p:nvPr/>
+        </p:nvSpPr>
+        <p:spPr>
+          <a:xfrm>
+            <a:off x="647700" y="558403"/>
+            <a:ext cx="10934700" cy="1231106"/>
+          </a:xfrm>
+          <a:prstGeom prst="rect">
+            <a:avLst/>
+          </a:prstGeom>
+          <a:noFill/>
+        </p:spPr>
+        <p:txBody>
+          <a:bodyPr wrap="square" lIns="0" tIns="0" rIns="0" bIns="0" anchor="t">
+            <a:spAutoFit/>
+          </a:bodyPr>
+          <a:lstStyle/>
+          <a:p>
+            <a:pPr algn="ctr"/>
+            <a:r>
+              <a:rPr lang="en-US" sz="4000" b="1" i="0" u="none" dirty="0">
+                <a:solidFill>
+                  <a:srgbClr val="0284C7"/>
+                </a:solidFill>
+                <a:latin typeface="Space Grotesk"/>
+              </a:rPr>
+              <a:t>Agent-OM: Leveraging LLM Agents</a:t>
+            </a:r>
+            <a:br>
+              <a:rPr lang="en-US" sz="4000" b="1" i="0" u="none" dirty="0">
+                <a:solidFill>
+                  <a:srgbClr val="0284C7"/>
+                </a:solidFill>
+                <a:latin typeface="Space Grotesk"/>
+              </a:rPr>
+            </a:br>
+            <a:r>
+              <a:rPr lang="en-US" sz="4000" b="1" i="0" u="none" dirty="0">
+                <a:solidFill>
+                  <a:srgbClr val="0284C7"/>
+                </a:solidFill>
+                <a:latin typeface="Space Grotesk"/>
+              </a:rPr>
+              <a:t>for Ontology Matching</a:t>
             </a:r>
           </a:p>
         </p:txBody>
@@ -7405,8 +7344,8 @@
         </p:nvSpPr>
         <p:spPr>
           <a:xfrm>
-            <a:off x="609600" y="3889176"/>
-            <a:ext cx="10972800" cy="2000250"/>
+            <a:off x="609600" y="3707427"/>
+            <a:ext cx="10972800" cy="2496765"/>
           </a:xfrm>
           <a:prstGeom prst="roundRect">
             <a:avLst>
@@ -7550,11 +7489,17 @@
           <p:cNvGraphicFramePr>
             <a:graphicFrameLocks noGrp="1"/>
           </p:cNvGraphicFramePr>
-          <p:nvPr/>
+          <p:nvPr>
+            <p:extLst>
+              <p:ext uri="{D42A27DB-BD31-4B8C-83A1-F6EECF244321}">
+                <p14:modId xmlns:p14="http://schemas.microsoft.com/office/powerpoint/2010/main" val="2175256881"/>
+              </p:ext>
+            </p:extLst>
+          </p:nvPr>
         </p:nvGraphicFramePr>
         <p:xfrm>
-          <a:off x="809625" y="4394001"/>
-          <a:ext cx="10572748" cy="1295400"/>
+          <a:off x="803530" y="4177763"/>
+          <a:ext cx="10572748" cy="1849120"/>
         </p:xfrm>
         <a:graphic>
           <a:graphicData uri="http://schemas.openxmlformats.org/drawingml/2006/table">
@@ -7590,15 +7535,12 @@
                     <a:lstStyle/>
                     <a:p>
                       <a:pPr algn="l"/>
-                      <a:r>
-                        <a:rPr sz="1050" b="1" i="0" u="none">
-                          <a:solidFill>
-                            <a:srgbClr val="64748B"/>
-                          </a:solidFill>
-                          <a:latin typeface="Inter"/>
-                        </a:rPr>
-                        <a:t>Dimension</a:t>
-                      </a:r>
+                      <a:endParaRPr sz="1800" b="1" i="0" u="none" dirty="0">
+                        <a:solidFill>
+                          <a:srgbClr val="64748B"/>
+                        </a:solidFill>
+                        <a:latin typeface="Inter"/>
+                      </a:endParaRPr>
                     </a:p>
                   </a:txBody>
                   <a:tcPr marL="63500" marR="63500" marT="25400" marB="25400" anchor="ctr">
@@ -7626,7 +7568,7 @@
                     <a:p>
                       <a:pPr algn="l"/>
                       <a:r>
-                        <a:rPr sz="1050" b="1" i="0" u="none">
+                        <a:rPr sz="1800" b="1" i="0" u="none">
                           <a:solidFill>
                             <a:srgbClr val="0284C7"/>
                           </a:solidFill>
@@ -7661,7 +7603,7 @@
                     <a:p>
                       <a:pPr algn="l"/>
                       <a:r>
-                        <a:rPr sz="1050" b="1" i="0" u="none">
+                        <a:rPr sz="1800" b="1" i="0" u="none">
                           <a:solidFill>
                             <a:srgbClr val="0D9488"/>
                           </a:solidFill>
@@ -7703,7 +7645,7 @@
                     <a:p>
                       <a:pPr algn="l"/>
                       <a:r>
-                        <a:rPr sz="1050" b="1" i="0" u="none">
+                        <a:rPr sz="1800" b="1" i="0" u="none" dirty="0">
                           <a:solidFill>
                             <a:srgbClr val="000000"/>
                           </a:solidFill>
@@ -7738,7 +7680,7 @@
                     <a:p>
                       <a:pPr algn="l"/>
                       <a:r>
-                        <a:rPr sz="1050" b="0" i="0" u="none">
+                        <a:rPr sz="1800" b="0" i="0" u="none">
                           <a:solidFill>
                             <a:srgbClr val="000000"/>
                           </a:solidFill>
@@ -7773,7 +7715,7 @@
                     <a:p>
                       <a:pPr algn="l"/>
                       <a:r>
-                        <a:rPr sz="1050" b="0" i="0" u="none">
+                        <a:rPr sz="1800" b="0" i="0" u="none">
                           <a:solidFill>
                             <a:srgbClr val="000000"/>
                           </a:solidFill>
@@ -7815,7 +7757,7 @@
                     <a:p>
                       <a:pPr algn="l"/>
                       <a:r>
-                        <a:rPr sz="1050" b="1" i="0" u="none">
+                        <a:rPr sz="1800" b="1" i="0" u="none">
                           <a:solidFill>
                             <a:srgbClr val="000000"/>
                           </a:solidFill>
@@ -7850,7 +7792,7 @@
                     <a:p>
                       <a:pPr algn="l"/>
                       <a:r>
-                        <a:rPr sz="1050" b="0" i="0" u="none">
+                        <a:rPr sz="1800" b="0" i="0" u="none">
                           <a:solidFill>
                             <a:srgbClr val="000000"/>
                           </a:solidFill>
@@ -7885,7 +7827,7 @@
                     <a:p>
                       <a:pPr algn="l"/>
                       <a:r>
-                        <a:rPr sz="1050" b="0" i="0" u="none">
+                        <a:rPr sz="1800" b="0" i="0" u="none">
                           <a:solidFill>
                             <a:srgbClr val="000000"/>
                           </a:solidFill>
@@ -7927,7 +7869,7 @@
                     <a:p>
                       <a:pPr algn="l"/>
                       <a:r>
-                        <a:rPr sz="1050" b="1" i="0" u="none">
+                        <a:rPr sz="1800" b="1" i="0" u="none" dirty="0">
                           <a:solidFill>
                             <a:srgbClr val="000000"/>
                           </a:solidFill>
@@ -7962,7 +7904,7 @@
                     <a:p>
                       <a:pPr algn="l"/>
                       <a:r>
-                        <a:rPr sz="1050" b="0" i="0" u="none">
+                        <a:rPr sz="1800" b="0" i="0" u="none" dirty="0">
                           <a:solidFill>
                             <a:srgbClr val="000000"/>
                           </a:solidFill>
@@ -7997,7 +7939,7 @@
                     <a:p>
                       <a:pPr algn="l"/>
                       <a:r>
-                        <a:rPr sz="1050" b="0" i="0" u="none">
+                        <a:rPr sz="1800" b="0" i="0" u="none" dirty="0">
                           <a:solidFill>
                             <a:srgbClr val="000000"/>
                           </a:solidFill>
@@ -8037,41 +7979,6 @@
       </p:graphicFrame>
       <p:sp>
         <p:nvSpPr>
-          <p:cNvPr id="6" name="TextBox 5"/>
-          <p:cNvSpPr txBox="1"/>
-          <p:nvPr/>
-        </p:nvSpPr>
-        <p:spPr>
-          <a:xfrm>
-            <a:off x="609600" y="6238577"/>
-            <a:ext cx="11582400" cy="161925"/>
-          </a:xfrm>
-          <a:prstGeom prst="rect">
-            <a:avLst/>
-          </a:prstGeom>
-          <a:noFill/>
-        </p:spPr>
-        <p:txBody>
-          <a:bodyPr wrap="none" lIns="0" tIns="0" rIns="0" bIns="0" anchor="ctr">
-            <a:spAutoFit/>
-          </a:bodyPr>
-          <a:lstStyle/>
-          <a:p>
-            <a:pPr algn="l"/>
-            <a:r>
-              <a:rPr sz="1050" b="0" i="0" u="none">
-                <a:solidFill>
-                  <a:srgbClr val="64748B"/>
-                </a:solidFill>
-                <a:latin typeface="Inter"/>
-              </a:rPr>
-              <a:t>Key Takeaway: Synthesis of both approaches provides high precision with low token consumption.</a:t>
-            </a:r>
-          </a:p>
-        </p:txBody>
-      </p:sp>
-      <p:sp>
-        <p:nvSpPr>
           <p:cNvPr id="7" name="TextBox 6"/>
           <p:cNvSpPr txBox="1"/>
           <p:nvPr/>
@@ -8094,7 +8001,7 @@
           <a:p>
             <a:pPr algn="l"/>
             <a:r>
-              <a:rPr sz="1050" b="1" i="0" u="none">
+              <a:rPr sz="1050" b="1" i="0" u="none" dirty="0">
                 <a:solidFill>
                   <a:srgbClr val="0D9488"/>
                 </a:solidFill>
@@ -8148,8 +8055,8 @@
         </p:nvSpPr>
         <p:spPr>
           <a:xfrm>
-            <a:off x="809625" y="4089201"/>
-            <a:ext cx="11382375" cy="190500"/>
+            <a:off x="803529" y="3840003"/>
+            <a:ext cx="3397853" cy="276999"/>
           </a:xfrm>
           <a:prstGeom prst="rect">
             <a:avLst/>
@@ -8164,7 +8071,7 @@
           <a:p>
             <a:pPr algn="l"/>
             <a:r>
-              <a:rPr sz="1200" b="1" i="0" u="none">
+              <a:rPr b="1" i="0" u="none" dirty="0">
                 <a:solidFill>
                   <a:srgbClr val="0F172A"/>
                 </a:solidFill>
@@ -8434,8 +8341,8 @@
         </p:nvSpPr>
         <p:spPr>
           <a:xfrm>
-            <a:off x="609600" y="2649140"/>
-            <a:ext cx="2628900" cy="1260871"/>
+            <a:off x="609600" y="2159091"/>
+            <a:ext cx="2628900" cy="1785700"/>
           </a:xfrm>
           <a:prstGeom prst="roundRect">
             <a:avLst>
@@ -8483,8 +8390,8 @@
         </p:nvSpPr>
         <p:spPr>
           <a:xfrm>
-            <a:off x="3390900" y="2649140"/>
-            <a:ext cx="2628900" cy="1260871"/>
+            <a:off x="3390900" y="2159091"/>
+            <a:ext cx="2628900" cy="1785700"/>
           </a:xfrm>
           <a:prstGeom prst="roundRect">
             <a:avLst>
@@ -8532,8 +8439,8 @@
         </p:nvSpPr>
         <p:spPr>
           <a:xfrm>
-            <a:off x="6172200" y="2649140"/>
-            <a:ext cx="2628900" cy="1260871"/>
+            <a:off x="6172200" y="2159091"/>
+            <a:ext cx="2628900" cy="1785700"/>
           </a:xfrm>
           <a:prstGeom prst="roundRect">
             <a:avLst>
@@ -8581,8 +8488,8 @@
         </p:nvSpPr>
         <p:spPr>
           <a:xfrm>
-            <a:off x="8953500" y="2649140"/>
-            <a:ext cx="2628900" cy="1260871"/>
+            <a:off x="8953500" y="2159091"/>
+            <a:ext cx="2628900" cy="1785700"/>
           </a:xfrm>
           <a:prstGeom prst="roundRect">
             <a:avLst>
@@ -8630,8 +8537,8 @@
         </p:nvSpPr>
         <p:spPr>
           <a:xfrm>
-            <a:off x="609600" y="5492353"/>
-            <a:ext cx="5372100" cy="908446"/>
+            <a:off x="609600" y="4484287"/>
+            <a:ext cx="5372100" cy="1197864"/>
           </a:xfrm>
           <a:prstGeom prst="roundRect">
             <a:avLst>
@@ -8679,8 +8586,8 @@
         </p:nvSpPr>
         <p:spPr>
           <a:xfrm>
-            <a:off x="6210300" y="5492353"/>
-            <a:ext cx="5372100" cy="908446"/>
+            <a:off x="6210300" y="4484287"/>
+            <a:ext cx="5372100" cy="1197864"/>
           </a:xfrm>
           <a:prstGeom prst="roundRect">
             <a:avLst>
@@ -8798,8 +8705,8 @@
         </p:nvSpPr>
         <p:spPr>
           <a:xfrm>
-            <a:off x="800100" y="2839640"/>
-            <a:ext cx="2343150" cy="879871"/>
+            <a:off x="800100" y="2349591"/>
+            <a:ext cx="2343150" cy="276999"/>
           </a:xfrm>
           <a:prstGeom prst="rect">
             <a:avLst/>
@@ -8814,7 +8721,7 @@
           <a:p>
             <a:pPr algn="l"/>
             <a:r>
-              <a:rPr sz="900" b="1" i="0" u="none">
+              <a:rPr b="1" i="0" u="none">
                 <a:solidFill>
                   <a:srgbClr val="6366F1"/>
                 </a:solidFill>
@@ -8833,8 +8740,8 @@
         </p:nvSpPr>
         <p:spPr>
           <a:xfrm>
-            <a:off x="3581400" y="2839640"/>
-            <a:ext cx="2343150" cy="879871"/>
+            <a:off x="3581400" y="2349591"/>
+            <a:ext cx="2343150" cy="276999"/>
           </a:xfrm>
           <a:prstGeom prst="rect">
             <a:avLst/>
@@ -8849,7 +8756,7 @@
           <a:p>
             <a:pPr algn="l"/>
             <a:r>
-              <a:rPr sz="900" b="1" i="0" u="none">
+              <a:rPr b="1" i="0" u="none">
                 <a:solidFill>
                   <a:srgbClr val="6366F1"/>
                 </a:solidFill>
@@ -8868,8 +8775,8 @@
         </p:nvSpPr>
         <p:spPr>
           <a:xfrm>
-            <a:off x="6362700" y="2839640"/>
-            <a:ext cx="2343150" cy="879871"/>
+            <a:off x="6362700" y="2349591"/>
+            <a:ext cx="2343150" cy="276999"/>
           </a:xfrm>
           <a:prstGeom prst="rect">
             <a:avLst/>
@@ -8884,7 +8791,7 @@
           <a:p>
             <a:pPr algn="l"/>
             <a:r>
-              <a:rPr sz="900" b="1" i="0" u="none">
+              <a:rPr b="1" i="0" u="none">
                 <a:solidFill>
                   <a:srgbClr val="6366F1"/>
                 </a:solidFill>
@@ -8903,8 +8810,8 @@
         </p:nvSpPr>
         <p:spPr>
           <a:xfrm>
-            <a:off x="9144000" y="2839640"/>
-            <a:ext cx="2343150" cy="879871"/>
+            <a:off x="9144000" y="2349591"/>
+            <a:ext cx="2343150" cy="276999"/>
           </a:xfrm>
           <a:prstGeom prst="rect">
             <a:avLst/>
@@ -8919,7 +8826,7 @@
           <a:p>
             <a:pPr algn="l"/>
             <a:r>
-              <a:rPr sz="900" b="1" i="0" u="none">
+              <a:rPr b="1" i="0" u="none">
                 <a:solidFill>
                   <a:srgbClr val="4338CA"/>
                 </a:solidFill>
@@ -8938,8 +8845,8 @@
         </p:nvSpPr>
         <p:spPr>
           <a:xfrm>
-            <a:off x="809625" y="3115865"/>
-            <a:ext cx="2925365" cy="190500"/>
+            <a:off x="809626" y="2625816"/>
+            <a:ext cx="2324100" cy="276999"/>
           </a:xfrm>
           <a:prstGeom prst="rect">
             <a:avLst/>
@@ -8947,14 +8854,14 @@
           <a:noFill/>
         </p:spPr>
         <p:txBody>
-          <a:bodyPr wrap="none" lIns="0" tIns="0" rIns="0" bIns="0" anchor="t">
+          <a:bodyPr wrap="square" lIns="0" tIns="0" rIns="0" bIns="0" anchor="t">
             <a:spAutoFit/>
           </a:bodyPr>
           <a:lstStyle/>
           <a:p>
             <a:pPr algn="l"/>
             <a:r>
-              <a:rPr sz="1200" b="1" i="0" u="none">
+              <a:rPr b="1" i="0" u="none">
                 <a:solidFill>
                   <a:srgbClr val="0F172A"/>
                 </a:solidFill>
@@ -8973,8 +8880,8 @@
         </p:nvSpPr>
         <p:spPr>
           <a:xfrm>
-            <a:off x="809625" y="3363515"/>
-            <a:ext cx="2324100" cy="346471"/>
+            <a:off x="819150" y="2960250"/>
+            <a:ext cx="2324100" cy="734175"/>
           </a:xfrm>
           <a:prstGeom prst="rect">
             <a:avLst/>
@@ -8993,7 +8900,7 @@
               </a:lnSpc>
             </a:pPr>
             <a:r>
-              <a:rPr sz="975" b="0" i="0" u="none">
+              <a:rPr b="0" i="0" u="none" dirty="0">
                 <a:solidFill>
                   <a:srgbClr val="475569"/>
                 </a:solidFill>
@@ -9012,8 +8919,8 @@
         </p:nvSpPr>
         <p:spPr>
           <a:xfrm>
-            <a:off x="3590925" y="3115865"/>
-            <a:ext cx="2925365" cy="190500"/>
+            <a:off x="3590925" y="2625816"/>
+            <a:ext cx="2275285" cy="276999"/>
           </a:xfrm>
           <a:prstGeom prst="rect">
             <a:avLst/>
@@ -9021,14 +8928,14 @@
           <a:noFill/>
         </p:spPr>
         <p:txBody>
-          <a:bodyPr wrap="none" lIns="0" tIns="0" rIns="0" bIns="0" anchor="t">
+          <a:bodyPr wrap="square" lIns="0" tIns="0" rIns="0" bIns="0" anchor="t">
             <a:spAutoFit/>
           </a:bodyPr>
           <a:lstStyle/>
           <a:p>
             <a:pPr algn="l"/>
             <a:r>
-              <a:rPr sz="1200" b="1" i="0" u="none">
+              <a:rPr b="1" i="0" u="none" dirty="0">
                 <a:solidFill>
                   <a:srgbClr val="0F172A"/>
                 </a:solidFill>
@@ -9047,8 +8954,8 @@
         </p:nvSpPr>
         <p:spPr>
           <a:xfrm>
-            <a:off x="3590925" y="3363515"/>
-            <a:ext cx="2324100" cy="346471"/>
+            <a:off x="3590925" y="2917793"/>
+            <a:ext cx="2324100" cy="554639"/>
           </a:xfrm>
           <a:prstGeom prst="rect">
             <a:avLst/>
@@ -9067,7 +8974,7 @@
               </a:lnSpc>
             </a:pPr>
             <a:r>
-              <a:rPr sz="975" b="0" i="0" u="none">
+              <a:rPr b="0" i="0" u="none" dirty="0">
                 <a:solidFill>
                   <a:srgbClr val="475569"/>
                 </a:solidFill>
@@ -9086,8 +8993,8 @@
         </p:nvSpPr>
         <p:spPr>
           <a:xfrm>
-            <a:off x="6372225" y="3115865"/>
-            <a:ext cx="2925365" cy="190500"/>
+            <a:off x="6372225" y="2625816"/>
+            <a:ext cx="2333625" cy="276999"/>
           </a:xfrm>
           <a:prstGeom prst="rect">
             <a:avLst/>
@@ -9095,14 +9002,14 @@
           <a:noFill/>
         </p:spPr>
         <p:txBody>
-          <a:bodyPr wrap="none" lIns="0" tIns="0" rIns="0" bIns="0" anchor="t">
+          <a:bodyPr wrap="square" lIns="0" tIns="0" rIns="0" bIns="0" anchor="t">
             <a:spAutoFit/>
           </a:bodyPr>
           <a:lstStyle/>
           <a:p>
             <a:pPr algn="l"/>
             <a:r>
-              <a:rPr sz="1200" b="1" i="0" u="none">
+              <a:rPr b="1" i="0" u="none" dirty="0">
                 <a:solidFill>
                   <a:srgbClr val="0F172A"/>
                 </a:solidFill>
@@ -9121,8 +9028,8 @@
         </p:nvSpPr>
         <p:spPr>
           <a:xfrm>
-            <a:off x="6372225" y="3363515"/>
-            <a:ext cx="2324100" cy="346471"/>
+            <a:off x="6372225" y="2975088"/>
+            <a:ext cx="2324100" cy="734175"/>
           </a:xfrm>
           <a:prstGeom prst="rect">
             <a:avLst/>
@@ -9141,7 +9048,7 @@
               </a:lnSpc>
             </a:pPr>
             <a:r>
-              <a:rPr sz="975" b="0" i="0" u="none">
+              <a:rPr b="0" i="0" u="none" dirty="0">
                 <a:solidFill>
                   <a:srgbClr val="475569"/>
                 </a:solidFill>
@@ -9160,8 +9067,8 @@
         </p:nvSpPr>
         <p:spPr>
           <a:xfrm>
-            <a:off x="9153525" y="3115865"/>
-            <a:ext cx="2925365" cy="190500"/>
+            <a:off x="9153525" y="2625816"/>
+            <a:ext cx="2238375" cy="276999"/>
           </a:xfrm>
           <a:prstGeom prst="rect">
             <a:avLst/>
@@ -9169,14 +9076,14 @@
           <a:noFill/>
         </p:spPr>
         <p:txBody>
-          <a:bodyPr wrap="none" lIns="0" tIns="0" rIns="0" bIns="0" anchor="t">
+          <a:bodyPr wrap="square" lIns="0" tIns="0" rIns="0" bIns="0" anchor="t">
             <a:spAutoFit/>
           </a:bodyPr>
           <a:lstStyle/>
           <a:p>
             <a:pPr algn="l"/>
             <a:r>
-              <a:rPr sz="1200" b="1" i="0" u="none">
+              <a:rPr b="1" i="0" u="none">
                 <a:solidFill>
                   <a:srgbClr val="0F172A"/>
                 </a:solidFill>
@@ -9195,8 +9102,8 @@
         </p:nvSpPr>
         <p:spPr>
           <a:xfrm>
-            <a:off x="9153525" y="3363515"/>
-            <a:ext cx="2324100" cy="346471"/>
+            <a:off x="9144000" y="2951224"/>
+            <a:ext cx="2324100" cy="554639"/>
           </a:xfrm>
           <a:prstGeom prst="rect">
             <a:avLst/>
@@ -9215,7 +9122,7 @@
               </a:lnSpc>
             </a:pPr>
             <a:r>
-              <a:rPr sz="975" b="0" i="0" u="none">
+              <a:rPr b="0" i="0" u="none" dirty="0">
                 <a:solidFill>
                   <a:srgbClr val="3730A3"/>
                 </a:solidFill>
@@ -9234,8 +9141,8 @@
         </p:nvSpPr>
         <p:spPr>
           <a:xfrm>
-            <a:off x="809625" y="5654278"/>
-            <a:ext cx="6525815" cy="161925"/>
+            <a:off x="800100" y="4593170"/>
+            <a:ext cx="1774268" cy="276999"/>
           </a:xfrm>
           <a:prstGeom prst="rect">
             <a:avLst/>
@@ -9250,7 +9157,7 @@
           <a:p>
             <a:pPr algn="l"/>
             <a:r>
-              <a:rPr sz="1050" b="1" i="0" u="none">
+              <a:rPr b="1" i="0" u="none" dirty="0">
                 <a:solidFill>
                   <a:srgbClr val="0F172A"/>
                 </a:solidFill>
@@ -9269,8 +9176,8 @@
         </p:nvSpPr>
         <p:spPr>
           <a:xfrm>
-            <a:off x="809625" y="5892403"/>
-            <a:ext cx="5067300" cy="346471"/>
+            <a:off x="809625" y="5020796"/>
+            <a:ext cx="5067300" cy="375103"/>
           </a:xfrm>
           <a:prstGeom prst="rect">
             <a:avLst/>
@@ -9289,7 +9196,7 @@
               </a:lnSpc>
             </a:pPr>
             <a:r>
-              <a:rPr sz="975" b="1" i="0" u="none">
+              <a:rPr b="1" i="0" u="none" dirty="0">
                 <a:solidFill>
                   <a:srgbClr val="475569"/>
                 </a:solidFill>
@@ -9298,7 +9205,7 @@
               <a:t>Precision, Recall, F1-Score</a:t>
             </a:r>
             <a:r>
-              <a:rPr sz="975" b="0" i="0" u="none">
+              <a:rPr b="0" i="0" u="none" dirty="0">
                 <a:solidFill>
                   <a:srgbClr val="475569"/>
                 </a:solidFill>
@@ -9307,11 +9214,12 @@
               <a:t> against OAEI Ground Truth. </a:t>
             </a:r>
             <a:r>
+              <a:rPr dirty="0"/>
               <a:t>
 </a:t>
             </a:r>
             <a:r>
-              <a:rPr sz="975" b="1" i="0" u="none">
+              <a:rPr b="1" i="0" u="none" dirty="0">
                 <a:solidFill>
                   <a:srgbClr val="475569"/>
                 </a:solidFill>
@@ -9320,7 +9228,7 @@
               <a:t>Efficiency:</a:t>
             </a:r>
             <a:r>
-              <a:rPr sz="975" b="0" i="0" u="none">
+              <a:rPr b="0" i="0" u="none" dirty="0">
                 <a:solidFill>
                   <a:srgbClr val="475569"/>
                 </a:solidFill>
@@ -9339,8 +9247,8 @@
         </p:nvSpPr>
         <p:spPr>
           <a:xfrm>
-            <a:off x="6410325" y="5654278"/>
-            <a:ext cx="5781675" cy="161925"/>
+            <a:off x="6400800" y="4593170"/>
+            <a:ext cx="2176943" cy="276999"/>
           </a:xfrm>
           <a:prstGeom prst="rect">
             <a:avLst/>
@@ -9355,7 +9263,7 @@
           <a:p>
             <a:pPr algn="l"/>
             <a:r>
-              <a:rPr sz="1050" b="1" i="0" u="none">
+              <a:rPr b="1" i="0" u="none">
                 <a:solidFill>
                   <a:srgbClr val="0F172A"/>
                 </a:solidFill>
@@ -9374,8 +9282,8 @@
         </p:nvSpPr>
         <p:spPr>
           <a:xfrm>
-            <a:off x="6410325" y="5892403"/>
-            <a:ext cx="5067300" cy="346471"/>
+            <a:off x="6410325" y="5020796"/>
+            <a:ext cx="5067300" cy="554639"/>
           </a:xfrm>
           <a:prstGeom prst="rect">
             <a:avLst/>
@@ -9394,7 +9302,7 @@
               </a:lnSpc>
             </a:pPr>
             <a:r>
-              <a:rPr sz="975" b="0" i="0" u="none">
+              <a:rPr b="0" i="0" u="none">
                 <a:solidFill>
                   <a:srgbClr val="475569"/>
                 </a:solidFill>
@@ -9490,7 +9398,7 @@
         <p:spPr>
           <a:xfrm>
             <a:off x="609600" y="2400300"/>
-            <a:ext cx="4899273" cy="1800225"/>
+            <a:ext cx="4899273" cy="2329201"/>
           </a:xfrm>
           <a:prstGeom prst="roundRect">
             <a:avLst>
@@ -9539,7 +9447,7 @@
         <p:spPr>
           <a:xfrm>
             <a:off x="5813673" y="2400300"/>
-            <a:ext cx="5768726" cy="2009775"/>
+            <a:ext cx="5768726" cy="2711196"/>
           </a:xfrm>
           <a:prstGeom prst="roundRect">
             <a:avLst>
@@ -9785,7 +9693,7 @@
         <p:spPr>
           <a:xfrm>
             <a:off x="885825" y="2676525"/>
-            <a:ext cx="5705205" cy="219075"/>
+            <a:ext cx="1477840" cy="276999"/>
           </a:xfrm>
           <a:prstGeom prst="rect">
             <a:avLst/>
@@ -9800,7 +9708,7 @@
           <a:p>
             <a:pPr algn="l"/>
             <a:r>
-              <a:rPr sz="1350" b="1" i="0" u="none">
+              <a:rPr b="1" i="0" u="none">
                 <a:solidFill>
                   <a:srgbClr val="38BDF8"/>
                 </a:solidFill>
@@ -9820,7 +9728,7 @@
         <p:spPr>
           <a:xfrm>
             <a:off x="885825" y="3009900"/>
-            <a:ext cx="4442073" cy="914400"/>
+            <a:ext cx="4442073" cy="1388201"/>
           </a:xfrm>
           <a:prstGeom prst="rect">
             <a:avLst/>
@@ -9839,7 +9747,7 @@
               </a:lnSpc>
             </a:pPr>
             <a:r>
-              <a:rPr sz="1125" b="0" i="0" u="none">
+              <a:rPr b="0" i="0" u="none" dirty="0">
                 <a:solidFill>
                   <a:srgbClr val="CBD5E1"/>
                 </a:solidFill>
@@ -9848,7 +9756,7 @@
               <a:t>Combining </a:t>
             </a:r>
             <a:r>
-              <a:rPr sz="1125" b="1" i="0" u="none">
+              <a:rPr b="1" i="0" u="none" dirty="0">
                 <a:solidFill>
                   <a:srgbClr val="CBD5E1"/>
                 </a:solidFill>
@@ -9857,7 +9765,7 @@
               <a:t>semantic retrieval</a:t>
             </a:r>
             <a:r>
-              <a:rPr sz="1125" b="0" i="0" u="none">
+              <a:rPr b="0" i="0" u="none" dirty="0">
                 <a:solidFill>
                   <a:srgbClr val="CBD5E1"/>
                 </a:solidFill>
@@ -9866,7 +9774,7 @@
               <a:t> with </a:t>
             </a:r>
             <a:r>
-              <a:rPr sz="1125" b="1" i="0" u="none">
+              <a:rPr b="1" i="0" u="none" dirty="0">
                 <a:solidFill>
                   <a:srgbClr val="CBD5E1"/>
                 </a:solidFill>
@@ -9875,13 +9783,31 @@
               <a:t>structural validation</a:t>
             </a:r>
             <a:r>
-              <a:rPr sz="1125" b="0" i="0" u="none">
+              <a:rPr b="0" i="0" u="none" dirty="0">
                 <a:solidFill>
                   <a:srgbClr val="CBD5E1"/>
                 </a:solidFill>
                 <a:latin typeface="Inter"/>
               </a:rPr>
-              <a:t> optimizes the balance between accuracy and token expenditure in LLM-assisted ontology matching—preventing unnecessary LLM calls while ensuring graph-level consistency.</a:t>
+              <a:t> optimizes the balance between accuracy and token expenditure in LLM-assisted ontology matching</a:t>
+            </a:r>
+            <a:r>
+              <a:rPr lang="en-US" b="0" i="0" u="none" dirty="0">
+                <a:solidFill>
+                  <a:srgbClr val="CBD5E1"/>
+                </a:solidFill>
+                <a:latin typeface="Inter"/>
+              </a:rPr>
+              <a:t>, </a:t>
+            </a:r>
+            <a:r>
+              <a:rPr b="0" i="0" u="none" dirty="0">
+                <a:solidFill>
+                  <a:srgbClr val="CBD5E1"/>
+                </a:solidFill>
+                <a:latin typeface="Inter"/>
+              </a:rPr>
+              <a:t>preventing unnecessary LLM calls while ensuring graph-level consistency.</a:t>
             </a:r>
           </a:p>
         </p:txBody>
@@ -9895,7 +9821,7 @@
         <p:spPr>
           <a:xfrm>
             <a:off x="6089898" y="2676525"/>
-            <a:ext cx="6102101" cy="219075"/>
+            <a:ext cx="1853649" cy="276999"/>
           </a:xfrm>
           <a:prstGeom prst="rect">
             <a:avLst/>
@@ -9910,7 +9836,7 @@
           <a:p>
             <a:pPr algn="l"/>
             <a:r>
-              <a:rPr sz="1350" b="1" i="0" u="none">
+              <a:rPr b="1" i="0" u="none">
                 <a:solidFill>
                   <a:srgbClr val="38BDF8"/>
                 </a:solidFill>
@@ -9945,7 +9871,7 @@
           <a:p>
             <a:pPr algn="l"/>
             <a:r>
-              <a:rPr sz="1800" b="1" i="0" u="none">
+              <a:rPr sz="1800" b="1" i="0" u="none" dirty="0">
                 <a:solidFill>
                   <a:srgbClr val="FFFFFF"/>
                 </a:solidFill>
@@ -9980,7 +9906,7 @@
           <a:p>
             <a:pPr algn="l"/>
             <a:r>
-              <a:rPr sz="1050" b="0" i="0" u="none">
+              <a:rPr sz="1050" b="0" i="0" u="none" dirty="0">
                 <a:solidFill>
                   <a:srgbClr val="64748B"/>
                 </a:solidFill>
@@ -10000,7 +9926,7 @@
         <p:spPr>
           <a:xfrm>
             <a:off x="6089898" y="3009900"/>
-            <a:ext cx="6102101" cy="161925"/>
+            <a:ext cx="2343270" cy="276999"/>
           </a:xfrm>
           <a:prstGeom prst="rect">
             <a:avLst/>
@@ -10015,7 +9941,7 @@
           <a:p>
             <a:pPr algn="l"/>
             <a:r>
-              <a:rPr sz="1050" b="1" i="0" u="none">
+              <a:rPr b="1" i="0" u="none">
                 <a:solidFill>
                   <a:srgbClr val="F8FAFC"/>
                 </a:solidFill>
@@ -10034,8 +9960,8 @@
         </p:nvSpPr>
         <p:spPr>
           <a:xfrm>
-            <a:off x="6089898" y="3190875"/>
-            <a:ext cx="5311526" cy="304800"/>
+            <a:off x="6089898" y="3263093"/>
+            <a:ext cx="5311526" cy="553998"/>
           </a:xfrm>
           <a:prstGeom prst="rect">
             <a:avLst/>
@@ -10050,7 +9976,7 @@
           <a:p>
             <a:pPr algn="l"/>
             <a:r>
-              <a:rPr sz="975" b="0" i="0" u="none">
+              <a:rPr b="0" i="0" u="none" dirty="0">
                 <a:solidFill>
                   <a:srgbClr val="94A3B8"/>
                 </a:solidFill>
@@ -10059,7 +9985,7 @@
               <a:t>Nguyen et al. </a:t>
             </a:r>
             <a:r>
-              <a:rPr sz="975" b="0" i="1" u="none">
+              <a:rPr b="0" i="1" u="none" dirty="0">
                 <a:solidFill>
                   <a:srgbClr val="94A3B8"/>
                 </a:solidFill>
@@ -10078,8 +10004,8 @@
         </p:nvSpPr>
         <p:spPr>
           <a:xfrm>
-            <a:off x="6089898" y="3648075"/>
-            <a:ext cx="6102101" cy="161925"/>
+            <a:off x="6089898" y="3795374"/>
+            <a:ext cx="3941144" cy="276999"/>
           </a:xfrm>
           <a:prstGeom prst="rect">
             <a:avLst/>
@@ -10094,7 +10020,7 @@
           <a:p>
             <a:pPr algn="l"/>
             <a:r>
-              <a:rPr sz="1050" b="1" i="0" u="none">
+              <a:rPr b="1" i="0" u="none" dirty="0">
                 <a:solidFill>
                   <a:srgbClr val="F8FAFC"/>
                 </a:solidFill>
@@ -10113,8 +10039,8 @@
         </p:nvSpPr>
         <p:spPr>
           <a:xfrm>
-            <a:off x="6089898" y="3829050"/>
-            <a:ext cx="5311526" cy="304800"/>
+            <a:off x="6089898" y="4058424"/>
+            <a:ext cx="5311526" cy="553998"/>
           </a:xfrm>
           <a:prstGeom prst="rect">
             <a:avLst/>
@@ -10129,7 +10055,7 @@
           <a:p>
             <a:pPr algn="l"/>
             <a:r>
-              <a:rPr sz="975" b="0" i="0" u="none">
+              <a:rPr b="0" i="0" u="none" dirty="0">
                 <a:solidFill>
                   <a:srgbClr val="94A3B8"/>
                 </a:solidFill>
@@ -10138,7 +10064,7 @@
               <a:t>Qiang, Wang, and Taylor. </a:t>
             </a:r>
             <a:r>
-              <a:rPr sz="975" b="0" i="1" u="none">
+              <a:rPr b="0" i="1" u="none" dirty="0">
                 <a:solidFill>
                   <a:srgbClr val="94A3B8"/>
                 </a:solidFill>
@@ -10146,15 +10072,12 @@
               </a:rPr>
               <a:t>"Agent-OM: Leveraging LLM Agents for Efficient Ontology Matching."</a:t>
             </a:r>
-            <a:r>
-              <a:rPr sz="975" b="0" i="0" u="none">
-                <a:solidFill>
-                  <a:srgbClr val="94A3B8"/>
-                </a:solidFill>
-                <a:latin typeface="Inter"/>
-              </a:rPr>
-              <a:t> Proceedings of the VLDB Endowment.</a:t>
-            </a:r>
+            <a:endParaRPr b="0" i="0" u="none" dirty="0">
+              <a:solidFill>
+                <a:srgbClr val="94A3B8"/>
+              </a:solidFill>
+              <a:latin typeface="Inter"/>
+            </a:endParaRPr>
           </a:p>
         </p:txBody>
       </p:sp>

</xml_diff>

<commit_message>
Commit: ACL RR1 Presentation Backup
</commit_message>
<xml_diff>
--- a/Year2_Semester1_ApplicationComputationalLinguistics/RR1_Presentation_Week2/Todoran_RR1.pptx
+++ b/Year2_Semester1_ApplicationComputationalLinguistics/RR1_Presentation_Week2/Todoran_RR1.pptx
@@ -6,27 +6,28 @@
   </p:sldMasterIdLst>
   <p:sldIdLst>
     <p:sldId id="256" r:id="rId2"/>
-    <p:sldId id="257" r:id="rId3"/>
-    <p:sldId id="258" r:id="rId4"/>
-    <p:sldId id="259" r:id="rId5"/>
-    <p:sldId id="260" r:id="rId6"/>
-    <p:sldId id="261" r:id="rId7"/>
-    <p:sldId id="262" r:id="rId8"/>
+    <p:sldId id="263" r:id="rId3"/>
+    <p:sldId id="257" r:id="rId4"/>
+    <p:sldId id="258" r:id="rId5"/>
+    <p:sldId id="259" r:id="rId6"/>
+    <p:sldId id="260" r:id="rId7"/>
+    <p:sldId id="261" r:id="rId8"/>
+    <p:sldId id="262" r:id="rId9"/>
   </p:sldIdLst>
   <p:sldSz cx="12192000" cy="6858000"/>
   <p:notesSz cx="6858000" cy="9144000"/>
   <p:embeddedFontLst>
     <p:embeddedFont>
       <p:font typeface="Inter"/>
-      <p:italic r:id="rId9"/>
+      <p:italic r:id="rId10"/>
     </p:embeddedFont>
     <p:embeddedFont>
       <p:font typeface="JetBrains Mono"/>
-      <p:bold r:id="rId10"/>
+      <p:bold r:id="rId11"/>
     </p:embeddedFont>
     <p:embeddedFont>
       <p:font typeface="Space Grotesk"/>
-      <p:bold r:id="rId11"/>
+      <p:bold r:id="rId12"/>
     </p:embeddedFont>
   </p:embeddedFontLst>
   <p:defaultTextStyle>
@@ -322,7 +323,7 @@
           <a:p>
             <a:fld id="{5BCAD085-E8A6-8845-BD4E-CB4CCA059FC4}" type="datetimeFigureOut">
               <a:rPr lang="en-US" smtClean="0"/>
-              <a:t>10/22/2026</a:t>
+              <a:t>23/10/2026</a:t>
             </a:fld>
             <a:endParaRPr lang="en-US"/>
           </a:p>
@@ -490,7 +491,7 @@
           <a:p>
             <a:fld id="{5BCAD085-E8A6-8845-BD4E-CB4CCA059FC4}" type="datetimeFigureOut">
               <a:rPr lang="en-US" smtClean="0"/>
-              <a:t>10/22/2026</a:t>
+              <a:t>23/10/2026</a:t>
             </a:fld>
             <a:endParaRPr lang="en-US"/>
           </a:p>
@@ -668,7 +669,7 @@
           <a:p>
             <a:fld id="{5BCAD085-E8A6-8845-BD4E-CB4CCA059FC4}" type="datetimeFigureOut">
               <a:rPr lang="en-US" smtClean="0"/>
-              <a:t>10/22/2026</a:t>
+              <a:t>23/10/2026</a:t>
             </a:fld>
             <a:endParaRPr lang="en-US"/>
           </a:p>
@@ -836,7 +837,7 @@
           <a:p>
             <a:fld id="{5BCAD085-E8A6-8845-BD4E-CB4CCA059FC4}" type="datetimeFigureOut">
               <a:rPr lang="en-US" smtClean="0"/>
-              <a:t>10/22/2026</a:t>
+              <a:t>23/10/2026</a:t>
             </a:fld>
             <a:endParaRPr lang="en-US"/>
           </a:p>
@@ -1081,7 +1082,7 @@
           <a:p>
             <a:fld id="{5BCAD085-E8A6-8845-BD4E-CB4CCA059FC4}" type="datetimeFigureOut">
               <a:rPr lang="en-US" smtClean="0"/>
-              <a:t>10/22/2026</a:t>
+              <a:t>23/10/2026</a:t>
             </a:fld>
             <a:endParaRPr lang="en-US"/>
           </a:p>
@@ -1366,7 +1367,7 @@
           <a:p>
             <a:fld id="{5BCAD085-E8A6-8845-BD4E-CB4CCA059FC4}" type="datetimeFigureOut">
               <a:rPr lang="en-US" smtClean="0"/>
-              <a:t>10/22/2026</a:t>
+              <a:t>23/10/2026</a:t>
             </a:fld>
             <a:endParaRPr lang="en-US"/>
           </a:p>
@@ -1785,7 +1786,7 @@
           <a:p>
             <a:fld id="{5BCAD085-E8A6-8845-BD4E-CB4CCA059FC4}" type="datetimeFigureOut">
               <a:rPr lang="en-US" smtClean="0"/>
-              <a:t>10/22/2026</a:t>
+              <a:t>23/10/2026</a:t>
             </a:fld>
             <a:endParaRPr lang="en-US"/>
           </a:p>
@@ -1902,7 +1903,7 @@
           <a:p>
             <a:fld id="{5BCAD085-E8A6-8845-BD4E-CB4CCA059FC4}" type="datetimeFigureOut">
               <a:rPr lang="en-US" smtClean="0"/>
-              <a:t>10/22/2026</a:t>
+              <a:t>23/10/2026</a:t>
             </a:fld>
             <a:endParaRPr lang="en-US"/>
           </a:p>
@@ -1997,7 +1998,7 @@
           <a:p>
             <a:fld id="{5BCAD085-E8A6-8845-BD4E-CB4CCA059FC4}" type="datetimeFigureOut">
               <a:rPr lang="en-US" smtClean="0"/>
-              <a:t>10/22/2026</a:t>
+              <a:t>23/10/2026</a:t>
             </a:fld>
             <a:endParaRPr lang="en-US"/>
           </a:p>
@@ -2272,7 +2273,7 @@
           <a:p>
             <a:fld id="{5BCAD085-E8A6-8845-BD4E-CB4CCA059FC4}" type="datetimeFigureOut">
               <a:rPr lang="en-US" smtClean="0"/>
-              <a:t>10/22/2026</a:t>
+              <a:t>23/10/2026</a:t>
             </a:fld>
             <a:endParaRPr lang="en-US"/>
           </a:p>
@@ -2524,7 +2525,7 @@
           <a:p>
             <a:fld id="{5BCAD085-E8A6-8845-BD4E-CB4CCA059FC4}" type="datetimeFigureOut">
               <a:rPr lang="en-US" smtClean="0"/>
-              <a:t>10/22/2026</a:t>
+              <a:t>23/10/2026</a:t>
             </a:fld>
             <a:endParaRPr lang="en-US"/>
           </a:p>
@@ -2735,7 +2736,7 @@
           <a:p>
             <a:fld id="{5BCAD085-E8A6-8845-BD4E-CB4CCA059FC4}" type="datetimeFigureOut">
               <a:rPr lang="en-US" smtClean="0"/>
-              <a:t>10/22/2026</a:t>
+              <a:t>23/10/2026</a:t>
             </a:fld>
             <a:endParaRPr lang="en-US"/>
           </a:p>
@@ -3126,8 +3127,8 @@
         </p:nvSpPr>
         <p:spPr>
           <a:xfrm>
-            <a:off x="604838" y="3138119"/>
-            <a:ext cx="10972800" cy="1932211"/>
+            <a:off x="648177" y="2654400"/>
+            <a:ext cx="10972800" cy="2849562"/>
           </a:xfrm>
           <a:prstGeom prst="roundRect">
             <a:avLst>
@@ -3218,7 +3219,7 @@
         </p:nvSpPr>
         <p:spPr>
           <a:xfrm>
-            <a:off x="6086476" y="3513829"/>
+            <a:off x="6129815" y="3030110"/>
             <a:ext cx="9525" cy="457200"/>
           </a:xfrm>
           <a:prstGeom prst="rect">
@@ -3263,7 +3264,7 @@
         </p:nvSpPr>
         <p:spPr>
           <a:xfrm>
-            <a:off x="609600" y="5867400"/>
+            <a:off x="652940" y="6031381"/>
             <a:ext cx="10972800" cy="9525"/>
           </a:xfrm>
           <a:prstGeom prst="rect">
@@ -3587,8 +3588,8 @@
         </p:nvSpPr>
         <p:spPr>
           <a:xfrm>
-            <a:off x="919164" y="3390004"/>
-            <a:ext cx="1525161" cy="307777"/>
+            <a:off x="962503" y="2906285"/>
+            <a:ext cx="981038" cy="307777"/>
           </a:xfrm>
           <a:prstGeom prst="rect">
             <a:avLst/>
@@ -3603,14 +3604,20 @@
           <a:p>
             <a:pPr algn="l"/>
             <a:r>
-              <a:rPr sz="2000" b="1" i="0" u="none" dirty="0">
+              <a:rPr lang="en-US" sz="2000" b="1" i="0" u="none" dirty="0" err="1">
                 <a:solidFill>
                   <a:srgbClr val="38BDF8"/>
                 </a:solidFill>
                 <a:latin typeface="Space Grotesk"/>
               </a:rPr>
-              <a:t>THE PROBLEM</a:t>
-            </a:r>
+              <a:t>Deinition</a:t>
+            </a:r>
+            <a:endParaRPr sz="2000" b="1" i="0" u="none" dirty="0">
+              <a:solidFill>
+                <a:srgbClr val="38BDF8"/>
+              </a:solidFill>
+              <a:latin typeface="Space Grotesk"/>
+            </a:endParaRPr>
           </a:p>
         </p:txBody>
       </p:sp>
@@ -3622,8 +3629,8 @@
         </p:nvSpPr>
         <p:spPr>
           <a:xfrm>
-            <a:off x="919163" y="3930495"/>
-            <a:ext cx="4957762" cy="933332"/>
+            <a:off x="962502" y="3446776"/>
+            <a:ext cx="4957762" cy="1625830"/>
           </a:xfrm>
           <a:prstGeom prst="rect">
             <a:avLst/>
@@ -3642,174 +3649,264 @@
               </a:lnSpc>
             </a:pPr>
             <a:r>
-              <a:rPr sz="2000" b="1" i="0" u="none" dirty="0">
+              <a:rPr lang="en-US" sz="2000" b="1" i="0" u="none" dirty="0">
                 <a:solidFill>
                   <a:srgbClr val="E2E8F0"/>
                 </a:solidFill>
                 <a:latin typeface="Inter"/>
               </a:rPr>
-              <a:t>Traditional OM:</a:t>
-            </a:r>
-            <a:r>
-              <a:rPr sz="2000" b="0" i="0" u="none" dirty="0">
+              <a:t>Ontology matching </a:t>
+            </a:r>
+            <a:r>
+              <a:rPr lang="en-US" sz="2000" i="0" u="none" dirty="0">
                 <a:solidFill>
                   <a:srgbClr val="E2E8F0"/>
                 </a:solidFill>
                 <a:latin typeface="Inter"/>
               </a:rPr>
-              <a:t> Relies on fixed rules and manual features. </a:t>
-            </a:r>
-            <a:r>
-              <a:rPr sz="2000" dirty="0"/>
-              <a:t>
-</a:t>
-            </a:r>
-            <a:r>
-              <a:rPr sz="2000" b="1" i="0" u="none" dirty="0">
-                <a:solidFill>
-                  <a:srgbClr val="E2E8F0"/>
-                </a:solidFill>
-                <a:latin typeface="Inter"/>
-              </a:rPr>
-              <a:t>Direct Prompting:</a:t>
-            </a:r>
-            <a:r>
-              <a:rPr sz="2000" b="0" i="0" u="none" dirty="0">
-                <a:solidFill>
-                  <a:srgbClr val="E2E8F0"/>
-                </a:solidFill>
-                <a:latin typeface="Inter"/>
-              </a:rPr>
-              <a:t> High token costs, hallucinations, scale limits.</a:t>
-            </a:r>
-          </a:p>
-        </p:txBody>
-      </p:sp>
-      <p:sp>
-        <p:nvSpPr>
-          <p:cNvPr id="16" name="TextBox 15"/>
-          <p:cNvSpPr txBox="1"/>
-          <p:nvPr/>
-        </p:nvSpPr>
-        <p:spPr>
-          <a:xfrm>
-            <a:off x="6400801" y="3390004"/>
-            <a:ext cx="2298321" cy="307777"/>
-          </a:xfrm>
-          <a:prstGeom prst="rect">
-            <a:avLst/>
-          </a:prstGeom>
-          <a:noFill/>
-        </p:spPr>
-        <p:txBody>
-          <a:bodyPr wrap="none" lIns="0" tIns="0" rIns="0" bIns="0" anchor="t">
-            <a:spAutoFit/>
-          </a:bodyPr>
-          <a:lstStyle/>
-          <a:p>
-            <a:pPr algn="l"/>
-            <a:r>
-              <a:rPr sz="2000" b="1" i="0" u="none" dirty="0">
-                <a:solidFill>
-                  <a:srgbClr val="38BDF8"/>
-                </a:solidFill>
-                <a:latin typeface="Space Grotesk"/>
-              </a:rPr>
-              <a:t>RESEARCH OBJECTIVE</a:t>
-            </a:r>
-          </a:p>
-        </p:txBody>
-      </p:sp>
-      <p:sp>
-        <p:nvSpPr>
-          <p:cNvPr id="17" name="TextBox 16"/>
-          <p:cNvSpPr txBox="1"/>
-          <p:nvPr/>
-        </p:nvSpPr>
-        <p:spPr>
-          <a:xfrm>
-            <a:off x="6401087" y="4026532"/>
-            <a:ext cx="4957762" cy="702500"/>
-          </a:xfrm>
-          <a:prstGeom prst="rect">
-            <a:avLst/>
-          </a:prstGeom>
-          <a:noFill/>
-        </p:spPr>
-        <p:txBody>
-          <a:bodyPr wrap="square" lIns="0" tIns="0" rIns="0" bIns="0" anchor="t">
-            <a:spAutoFit/>
-          </a:bodyPr>
-          <a:lstStyle/>
+              <a:t>is the process of identifying concepts in two different ontologies that represent the same or similar real-world meaning.</a:t>
+            </a:r>
+          </a:p>
           <a:p>
             <a:pPr algn="l">
               <a:lnSpc>
                 <a:spcPts val="1800"/>
               </a:lnSpc>
             </a:pPr>
-            <a:r>
-              <a:rPr sz="2000" b="0" i="0" u="none" dirty="0">
+            <a:endParaRPr lang="en-US" sz="2000" dirty="0">
+              <a:solidFill>
+                <a:srgbClr val="E2E8F0"/>
+              </a:solidFill>
+              <a:latin typeface="Inter"/>
+            </a:endParaRPr>
+          </a:p>
+          <a:p>
+            <a:pPr>
+              <a:lnSpc>
+                <a:spcPts val="1800"/>
+              </a:lnSpc>
+            </a:pPr>
+            <a:r>
+              <a:rPr lang="en-US" sz="2000" b="1" dirty="0">
                 <a:solidFill>
                   <a:srgbClr val="E2E8F0"/>
                 </a:solidFill>
                 <a:latin typeface="Inter"/>
               </a:rPr>
-              <a:t>Investigate how </a:t>
-            </a:r>
-            <a:r>
-              <a:rPr sz="2000" b="1" i="0" u="none" dirty="0">
+              <a:t>Ontology matching </a:t>
+            </a:r>
+            <a:r>
+              <a:rPr lang="en-US" sz="2000" dirty="0">
                 <a:solidFill>
                   <a:srgbClr val="E2E8F0"/>
                 </a:solidFill>
                 <a:latin typeface="Inter"/>
               </a:rPr>
-              <a:t>external retrieval</a:t>
-            </a:r>
-            <a:r>
-              <a:rPr sz="2000" b="0" i="0" u="none" dirty="0">
+              <a:t>(in short):</a:t>
+            </a:r>
+            <a:br>
+              <a:rPr lang="en-US" sz="2000" b="1" dirty="0">
                 <a:solidFill>
                   <a:srgbClr val="E2E8F0"/>
                 </a:solidFill>
                 <a:latin typeface="Inter"/>
               </a:rPr>
-              <a:t>, </a:t>
-            </a:r>
-            <a:r>
-              <a:rPr sz="2000" b="1" i="0" u="none" dirty="0">
+            </a:br>
+            <a:r>
+              <a:rPr lang="en-US" sz="2000" dirty="0">
                 <a:solidFill>
                   <a:srgbClr val="E2E8F0"/>
                 </a:solidFill>
                 <a:latin typeface="Inter"/>
               </a:rPr>
-              <a:t>semantic context</a:t>
-            </a:r>
-            <a:r>
-              <a:rPr sz="2000" b="0" i="0" u="none" dirty="0">
+              <a:t>Find semantically equivalent concepts</a:t>
+            </a:r>
+            <a:endParaRPr sz="2000" i="0" u="none" dirty="0">
+              <a:solidFill>
+                <a:srgbClr val="E2E8F0"/>
+              </a:solidFill>
+              <a:latin typeface="Inter"/>
+            </a:endParaRPr>
+          </a:p>
+        </p:txBody>
+      </p:sp>
+      <p:sp>
+        <p:nvSpPr>
+          <p:cNvPr id="16" name="TextBox 15"/>
+          <p:cNvSpPr txBox="1"/>
+          <p:nvPr/>
+        </p:nvSpPr>
+        <p:spPr>
+          <a:xfrm>
+            <a:off x="6444140" y="2906285"/>
+            <a:ext cx="787075" cy="307777"/>
+          </a:xfrm>
+          <a:prstGeom prst="rect">
+            <a:avLst/>
+          </a:prstGeom>
+          <a:noFill/>
+        </p:spPr>
+        <p:txBody>
+          <a:bodyPr wrap="none" lIns="0" tIns="0" rIns="0" bIns="0" anchor="t">
+            <a:spAutoFit/>
+          </a:bodyPr>
+          <a:lstStyle/>
+          <a:p>
+            <a:pPr algn="l"/>
+            <a:r>
+              <a:rPr lang="en-US" sz="2000" b="1" i="0" u="none" dirty="0">
+                <a:solidFill>
+                  <a:srgbClr val="38BDF8"/>
+                </a:solidFill>
+                <a:latin typeface="Space Grotesk"/>
+              </a:rPr>
+              <a:t>Sample</a:t>
+            </a:r>
+            <a:endParaRPr sz="2000" b="1" i="0" u="none" dirty="0">
+              <a:solidFill>
+                <a:srgbClr val="38BDF8"/>
+              </a:solidFill>
+              <a:latin typeface="Space Grotesk"/>
+            </a:endParaRPr>
+          </a:p>
+        </p:txBody>
+      </p:sp>
+      <p:sp>
+        <p:nvSpPr>
+          <p:cNvPr id="17" name="TextBox 16"/>
+          <p:cNvSpPr txBox="1"/>
+          <p:nvPr/>
+        </p:nvSpPr>
+        <p:spPr>
+          <a:xfrm>
+            <a:off x="6444425" y="3446776"/>
+            <a:ext cx="5080349" cy="1625830"/>
+          </a:xfrm>
+          <a:prstGeom prst="rect">
+            <a:avLst/>
+          </a:prstGeom>
+          <a:noFill/>
+        </p:spPr>
+        <p:txBody>
+          <a:bodyPr wrap="square" lIns="0" tIns="0" rIns="0" bIns="0" anchor="t">
+            <a:spAutoFit/>
+          </a:bodyPr>
+          <a:lstStyle/>
+          <a:p>
+            <a:pPr algn="l">
+              <a:lnSpc>
+                <a:spcPts val="1800"/>
+              </a:lnSpc>
+            </a:pPr>
+            <a:r>
+              <a:rPr lang="en-US" sz="2000" b="0" i="0" u="none" dirty="0">
                 <a:solidFill>
                   <a:srgbClr val="E2E8F0"/>
                 </a:solidFill>
                 <a:latin typeface="Inter"/>
               </a:rPr>
-              <a:t> and </a:t>
-            </a:r>
-            <a:r>
-              <a:rPr sz="2000" b="1" i="0" u="none" dirty="0">
+              <a:t>Ontology A — University A</a:t>
+            </a:r>
+            <a:br>
+              <a:rPr lang="en-US" sz="2000" b="0" i="0" u="none" dirty="0">
                 <a:solidFill>
                   <a:srgbClr val="E2E8F0"/>
                 </a:solidFill>
                 <a:latin typeface="Inter"/>
               </a:rPr>
-              <a:t>structural validation</a:t>
-            </a:r>
-            <a:r>
-              <a:rPr sz="2000" b="0" i="0" u="none" dirty="0">
+            </a:br>
+            <a:r>
+              <a:rPr lang="en-US" sz="2000" b="0" i="0" u="none" dirty="0">
                 <a:solidFill>
                   <a:srgbClr val="E2E8F0"/>
                 </a:solidFill>
                 <a:latin typeface="Inter"/>
               </a:rPr>
-              <a:t> refine LLM-based entity matching.</a:t>
-            </a:r>
+              <a:t>Student : person enrolled at a university</a:t>
+            </a:r>
+          </a:p>
+          <a:p>
+            <a:pPr algn="l">
+              <a:lnSpc>
+                <a:spcPts val="1800"/>
+              </a:lnSpc>
+            </a:pPr>
+            <a:r>
+              <a:rPr lang="en-US" sz="2000" b="0" i="0" u="none" dirty="0">
+                <a:solidFill>
+                  <a:srgbClr val="E2E8F0"/>
+                </a:solidFill>
+                <a:latin typeface="Inter"/>
+              </a:rPr>
+              <a:t>Course : An educational unit</a:t>
+            </a:r>
+          </a:p>
+          <a:p>
+            <a:pPr algn="l">
+              <a:lnSpc>
+                <a:spcPts val="1800"/>
+              </a:lnSpc>
+            </a:pPr>
+            <a:endParaRPr lang="en-US" sz="2000" dirty="0">
+              <a:solidFill>
+                <a:srgbClr val="E2E8F0"/>
+              </a:solidFill>
+              <a:latin typeface="Inter"/>
+            </a:endParaRPr>
+          </a:p>
+          <a:p>
+            <a:pPr algn="l">
+              <a:lnSpc>
+                <a:spcPts val="1800"/>
+              </a:lnSpc>
+            </a:pPr>
+            <a:r>
+              <a:rPr lang="en-US" sz="2000" b="0" i="0" u="none" dirty="0">
+                <a:solidFill>
+                  <a:srgbClr val="E2E8F0"/>
+                </a:solidFill>
+                <a:latin typeface="Inter"/>
+              </a:rPr>
+              <a:t>Ontology B — University B</a:t>
+            </a:r>
+          </a:p>
+          <a:p>
+            <a:pPr algn="l">
+              <a:lnSpc>
+                <a:spcPts val="1800"/>
+              </a:lnSpc>
+            </a:pPr>
+            <a:r>
+              <a:rPr lang="en-US" sz="2000" b="0" i="0" u="none" dirty="0">
+                <a:solidFill>
+                  <a:srgbClr val="E2E8F0"/>
+                </a:solidFill>
+                <a:latin typeface="Inter"/>
+              </a:rPr>
+              <a:t>Learner : person enrolled educational program</a:t>
+            </a:r>
+          </a:p>
+          <a:p>
+            <a:pPr algn="l">
+              <a:lnSpc>
+                <a:spcPts val="1800"/>
+              </a:lnSpc>
+            </a:pPr>
+            <a:r>
+              <a:rPr lang="en-US" sz="2000" b="0" i="0" u="none" dirty="0">
+                <a:solidFill>
+                  <a:srgbClr val="E2E8F0"/>
+                </a:solidFill>
+                <a:latin typeface="Inter"/>
+              </a:rPr>
+              <a:t>Module : unit of academic study</a:t>
+            </a:r>
+            <a:endParaRPr sz="2000" b="0" i="0" u="none" dirty="0">
+              <a:solidFill>
+                <a:srgbClr val="E2E8F0"/>
+              </a:solidFill>
+              <a:latin typeface="Inter"/>
+            </a:endParaRPr>
           </a:p>
         </p:txBody>
       </p:sp>
@@ -3827,14 +3924,20 @@
     <p:bg>
       <p:bgPr>
         <a:solidFill>
-          <a:srgbClr val="FFFFFF"/>
+          <a:srgbClr val="090D16"/>
         </a:solidFill>
         <a:effectLst/>
       </p:bgPr>
     </p:bg>
     <p:spTree>
       <p:nvGrpSpPr>
-        <p:cNvPr id="1" name=""/>
+        <p:cNvPr id="1" name="">
+          <a:extLst>
+            <a:ext uri="{FF2B5EF4-FFF2-40B4-BE49-F238E27FC236}">
+              <a16:creationId xmlns:a16="http://schemas.microsoft.com/office/drawing/2014/main" id="{ACAD50D7-4AC5-566E-72E3-62E0A590FC0C}"/>
+            </a:ext>
+          </a:extLst>
+        </p:cNvPr>
         <p:cNvGrpSpPr/>
         <p:nvPr/>
       </p:nvGrpSpPr>
@@ -3848,26 +3951,32 @@
       </p:grpSpPr>
       <p:sp>
         <p:nvSpPr>
-          <p:cNvPr id="2" name="Rounded Rectangle 1"/>
+          <p:cNvPr id="2" name="Rounded Rectangle 1">
+            <a:extLst>
+              <a:ext uri="{FF2B5EF4-FFF2-40B4-BE49-F238E27FC236}">
+                <a16:creationId xmlns:a16="http://schemas.microsoft.com/office/drawing/2014/main" id="{EB829169-8569-82F1-F4F9-DD27158F5C9A}"/>
+              </a:ext>
+            </a:extLst>
+          </p:cNvPr>
           <p:cNvSpPr/>
           <p:nvPr/>
         </p:nvSpPr>
         <p:spPr>
           <a:xfrm>
-            <a:off x="609600" y="5715000"/>
-            <a:ext cx="10972800" cy="685800"/>
+            <a:off x="604838" y="3138119"/>
+            <a:ext cx="10972800" cy="1932211"/>
           </a:xfrm>
           <a:prstGeom prst="roundRect">
             <a:avLst>
-              <a:gd name="adj" fmla="val 13888"/>
+              <a:gd name="adj" fmla="val 11428"/>
             </a:avLst>
           </a:prstGeom>
           <a:solidFill>
-            <a:srgbClr val="FFFBE0"/>
+            <a:srgbClr val="1E293B"/>
           </a:solidFill>
           <a:ln w="9525">
             <a:solidFill>
-              <a:srgbClr val="FDE047"/>
+              <a:srgbClr val="334155"/>
             </a:solidFill>
           </a:ln>
           <a:effectLst/>
@@ -3897,27 +4006,27 @@
       </p:sp>
       <p:sp>
         <p:nvSpPr>
-          <p:cNvPr id="4" name="Rounded Rectangle 3"/>
+          <p:cNvPr id="3" name="Rectangle 2">
+            <a:extLst>
+              <a:ext uri="{FF2B5EF4-FFF2-40B4-BE49-F238E27FC236}">
+                <a16:creationId xmlns:a16="http://schemas.microsoft.com/office/drawing/2014/main" id="{DC5EBB99-5484-C6FC-BE2B-C0D77E469BB0}"/>
+              </a:ext>
+            </a:extLst>
+          </p:cNvPr>
           <p:cNvSpPr/>
           <p:nvPr/>
         </p:nvSpPr>
         <p:spPr>
           <a:xfrm>
-            <a:off x="609600" y="2200275"/>
-            <a:ext cx="2600325" cy="3352800"/>
-          </a:xfrm>
-          <a:prstGeom prst="roundRect">
-            <a:avLst>
-              <a:gd name="adj" fmla="val 4395"/>
-            </a:avLst>
-          </a:prstGeom>
-          <a:solidFill>
-            <a:srgbClr val="F8FAFC"/>
-          </a:solidFill>
-          <a:ln w="9525">
-            <a:solidFill>
-              <a:srgbClr val="E2E8F0"/>
-            </a:solidFill>
+            <a:off x="609600" y="5867400"/>
+            <a:ext cx="10972800" cy="381000"/>
+          </a:xfrm>
+          <a:prstGeom prst="rect">
+            <a:avLst/>
+          </a:prstGeom>
+          <a:noFill/>
+          <a:ln>
+            <a:noFill/>
           </a:ln>
           <a:effectLst/>
         </p:spPr>
@@ -3946,27 +4055,29 @@
       </p:sp>
       <p:sp>
         <p:nvSpPr>
-          <p:cNvPr id="5" name="Rounded Rectangle 4"/>
+          <p:cNvPr id="5" name="Rectangle 4">
+            <a:extLst>
+              <a:ext uri="{FF2B5EF4-FFF2-40B4-BE49-F238E27FC236}">
+                <a16:creationId xmlns:a16="http://schemas.microsoft.com/office/drawing/2014/main" id="{4BC8A2C9-D2DE-B1E2-ED76-06EB2335F9CC}"/>
+              </a:ext>
+            </a:extLst>
+          </p:cNvPr>
           <p:cNvSpPr/>
           <p:nvPr/>
         </p:nvSpPr>
         <p:spPr>
           <a:xfrm>
-            <a:off x="3400425" y="2200275"/>
-            <a:ext cx="2600325" cy="3352800"/>
-          </a:xfrm>
-          <a:prstGeom prst="roundRect">
-            <a:avLst>
-              <a:gd name="adj" fmla="val 4395"/>
-            </a:avLst>
+            <a:off x="6086476" y="3513829"/>
+            <a:ext cx="9525" cy="457200"/>
+          </a:xfrm>
+          <a:prstGeom prst="rect">
+            <a:avLst/>
           </a:prstGeom>
           <a:solidFill>
-            <a:srgbClr val="F8FAFC"/>
+            <a:srgbClr val="334155"/>
           </a:solidFill>
-          <a:ln w="9525">
-            <a:solidFill>
-              <a:srgbClr val="E2E8F0"/>
-            </a:solidFill>
+          <a:ln>
+            <a:noFill/>
           </a:ln>
           <a:effectLst/>
         </p:spPr>
@@ -3995,27 +4106,29 @@
       </p:sp>
       <p:sp>
         <p:nvSpPr>
-          <p:cNvPr id="6" name="Rounded Rectangle 5"/>
+          <p:cNvPr id="6" name="Rectangle 5">
+            <a:extLst>
+              <a:ext uri="{FF2B5EF4-FFF2-40B4-BE49-F238E27FC236}">
+                <a16:creationId xmlns:a16="http://schemas.microsoft.com/office/drawing/2014/main" id="{AAC362AC-FDCD-63AD-06B7-64DC6C27700B}"/>
+              </a:ext>
+            </a:extLst>
+          </p:cNvPr>
           <p:cNvSpPr/>
           <p:nvPr/>
         </p:nvSpPr>
         <p:spPr>
           <a:xfrm>
-            <a:off x="6191250" y="2200275"/>
-            <a:ext cx="2600325" cy="3352800"/>
-          </a:xfrm>
-          <a:prstGeom prst="roundRect">
-            <a:avLst>
-              <a:gd name="adj" fmla="val 4395"/>
-            </a:avLst>
+            <a:off x="609600" y="5867400"/>
+            <a:ext cx="10972800" cy="9525"/>
+          </a:xfrm>
+          <a:prstGeom prst="rect">
+            <a:avLst/>
           </a:prstGeom>
           <a:solidFill>
-            <a:srgbClr val="F8FAFC"/>
+            <a:srgbClr val="1E293B"/>
           </a:solidFill>
-          <a:ln w="9525">
-            <a:solidFill>
-              <a:srgbClr val="E2E8F0"/>
-            </a:solidFill>
+          <a:ln>
+            <a:noFill/>
           </a:ln>
           <a:effectLst/>
         </p:spPr>
@@ -4044,475 +4157,132 @@
       </p:sp>
       <p:sp>
         <p:nvSpPr>
-          <p:cNvPr id="7" name="Rounded Rectangle 6"/>
-          <p:cNvSpPr/>
-          <p:nvPr/>
-        </p:nvSpPr>
-        <p:spPr>
-          <a:xfrm>
-            <a:off x="8982075" y="2200275"/>
-            <a:ext cx="2600325" cy="3352800"/>
-          </a:xfrm>
-          <a:prstGeom prst="roundRect">
-            <a:avLst>
-              <a:gd name="adj" fmla="val 4395"/>
-            </a:avLst>
-          </a:prstGeom>
-          <a:solidFill>
-            <a:srgbClr val="F8FAFC"/>
-          </a:solidFill>
-          <a:ln w="9525">
-            <a:solidFill>
-              <a:srgbClr val="E2E8F0"/>
-            </a:solidFill>
-          </a:ln>
-          <a:effectLst/>
-        </p:spPr>
-        <p:style>
-          <a:lnRef idx="1">
-            <a:schemeClr val="accent1"/>
-          </a:lnRef>
-          <a:fillRef idx="3">
-            <a:schemeClr val="accent1"/>
-          </a:fillRef>
-          <a:effectRef idx="2">
-            <a:schemeClr val="accent1"/>
-          </a:effectRef>
-          <a:fontRef idx="minor">
-            <a:schemeClr val="lt1"/>
-          </a:fontRef>
-        </p:style>
-        <p:txBody>
-          <a:bodyPr rtlCol="0" anchor="ctr"/>
-          <a:lstStyle/>
-          <a:p>
-            <a:pPr algn="ctr"/>
-            <a:endParaRPr/>
-          </a:p>
-        </p:txBody>
-      </p:sp>
-      <p:sp>
-        <p:nvSpPr>
-          <p:cNvPr id="8" name="Rounded Rectangle 7"/>
-          <p:cNvSpPr/>
-          <p:nvPr/>
-        </p:nvSpPr>
-        <p:spPr>
-          <a:xfrm>
-            <a:off x="847725" y="5122920"/>
-            <a:ext cx="2124075" cy="285750"/>
-          </a:xfrm>
-          <a:prstGeom prst="roundRect">
-            <a:avLst>
-              <a:gd name="adj" fmla="val 20000"/>
-            </a:avLst>
-          </a:prstGeom>
-          <a:solidFill>
-            <a:srgbClr val="FFFFFF"/>
-          </a:solidFill>
-          <a:ln w="9525">
-            <a:solidFill>
-              <a:srgbClr val="E2E8F0"/>
-            </a:solidFill>
-          </a:ln>
-          <a:effectLst/>
-        </p:spPr>
-        <p:style>
-          <a:lnRef idx="1">
-            <a:schemeClr val="accent1"/>
-          </a:lnRef>
-          <a:fillRef idx="3">
-            <a:schemeClr val="accent1"/>
-          </a:fillRef>
-          <a:effectRef idx="2">
-            <a:schemeClr val="accent1"/>
-          </a:effectRef>
-          <a:fontRef idx="minor">
-            <a:schemeClr val="lt1"/>
-          </a:fontRef>
-        </p:style>
-        <p:txBody>
-          <a:bodyPr rtlCol="0" anchor="ctr"/>
-          <a:lstStyle/>
-          <a:p>
-            <a:pPr algn="ctr"/>
-            <a:endParaRPr/>
-          </a:p>
-        </p:txBody>
-      </p:sp>
-      <p:sp>
-        <p:nvSpPr>
-          <p:cNvPr id="9" name="Rounded Rectangle 8"/>
-          <p:cNvSpPr/>
-          <p:nvPr/>
-        </p:nvSpPr>
-        <p:spPr>
-          <a:xfrm>
-            <a:off x="3638550" y="5122920"/>
-            <a:ext cx="2124075" cy="285750"/>
-          </a:xfrm>
-          <a:prstGeom prst="roundRect">
-            <a:avLst>
-              <a:gd name="adj" fmla="val 20000"/>
-            </a:avLst>
-          </a:prstGeom>
-          <a:solidFill>
-            <a:srgbClr val="FFFFFF"/>
-          </a:solidFill>
-          <a:ln w="9525">
-            <a:solidFill>
-              <a:srgbClr val="E2E8F0"/>
-            </a:solidFill>
-          </a:ln>
-          <a:effectLst/>
-        </p:spPr>
-        <p:style>
-          <a:lnRef idx="1">
-            <a:schemeClr val="accent1"/>
-          </a:lnRef>
-          <a:fillRef idx="3">
-            <a:schemeClr val="accent1"/>
-          </a:fillRef>
-          <a:effectRef idx="2">
-            <a:schemeClr val="accent1"/>
-          </a:effectRef>
-          <a:fontRef idx="minor">
-            <a:schemeClr val="lt1"/>
-          </a:fontRef>
-        </p:style>
-        <p:txBody>
-          <a:bodyPr rtlCol="0" anchor="ctr"/>
-          <a:lstStyle/>
-          <a:p>
-            <a:pPr algn="ctr"/>
-            <a:endParaRPr/>
-          </a:p>
-        </p:txBody>
-      </p:sp>
-      <p:sp>
-        <p:nvSpPr>
-          <p:cNvPr id="10" name="Rounded Rectangle 9"/>
-          <p:cNvSpPr/>
-          <p:nvPr/>
-        </p:nvSpPr>
-        <p:spPr>
-          <a:xfrm>
-            <a:off x="6429375" y="5122920"/>
-            <a:ext cx="2124075" cy="285750"/>
-          </a:xfrm>
-          <a:prstGeom prst="roundRect">
-            <a:avLst>
-              <a:gd name="adj" fmla="val 20000"/>
-            </a:avLst>
-          </a:prstGeom>
-          <a:solidFill>
-            <a:srgbClr val="FFFFFF"/>
-          </a:solidFill>
-          <a:ln w="9525">
-            <a:solidFill>
-              <a:srgbClr val="E2E8F0"/>
-            </a:solidFill>
-          </a:ln>
-          <a:effectLst/>
-        </p:spPr>
-        <p:style>
-          <a:lnRef idx="1">
-            <a:schemeClr val="accent1"/>
-          </a:lnRef>
-          <a:fillRef idx="3">
-            <a:schemeClr val="accent1"/>
-          </a:fillRef>
-          <a:effectRef idx="2">
-            <a:schemeClr val="accent1"/>
-          </a:effectRef>
-          <a:fontRef idx="minor">
-            <a:schemeClr val="lt1"/>
-          </a:fontRef>
-        </p:style>
-        <p:txBody>
-          <a:bodyPr rtlCol="0" anchor="ctr"/>
-          <a:lstStyle/>
-          <a:p>
-            <a:pPr algn="ctr"/>
-            <a:endParaRPr/>
-          </a:p>
-        </p:txBody>
-      </p:sp>
-      <p:sp>
-        <p:nvSpPr>
-          <p:cNvPr id="11" name="Rounded Rectangle 10"/>
-          <p:cNvSpPr/>
-          <p:nvPr/>
-        </p:nvSpPr>
-        <p:spPr>
-          <a:xfrm>
-            <a:off x="9220200" y="5122920"/>
-            <a:ext cx="2124075" cy="285750"/>
-          </a:xfrm>
-          <a:prstGeom prst="roundRect">
-            <a:avLst>
-              <a:gd name="adj" fmla="val 20000"/>
-            </a:avLst>
-          </a:prstGeom>
-          <a:solidFill>
-            <a:srgbClr val="FFFFFF"/>
-          </a:solidFill>
-          <a:ln w="9525">
-            <a:solidFill>
-              <a:srgbClr val="E2E8F0"/>
-            </a:solidFill>
-          </a:ln>
-          <a:effectLst/>
-        </p:spPr>
-        <p:style>
-          <a:lnRef idx="1">
-            <a:schemeClr val="accent1"/>
-          </a:lnRef>
-          <a:fillRef idx="3">
-            <a:schemeClr val="accent1"/>
-          </a:fillRef>
-          <a:effectRef idx="2">
-            <a:schemeClr val="accent1"/>
-          </a:effectRef>
-          <a:fontRef idx="minor">
-            <a:schemeClr val="lt1"/>
-          </a:fontRef>
-        </p:style>
-        <p:txBody>
-          <a:bodyPr rtlCol="0" anchor="ctr"/>
-          <a:lstStyle/>
-          <a:p>
-            <a:pPr algn="ctr"/>
-            <a:endParaRPr/>
-          </a:p>
-        </p:txBody>
-      </p:sp>
-      <p:pic>
-        <p:nvPicPr>
-          <p:cNvPr id="12" name="Picture 11" descr="image.png"/>
-          <p:cNvPicPr>
-            <a:picLocks noChangeAspect="1"/>
-          </p:cNvPicPr>
-          <p:nvPr/>
-        </p:nvPicPr>
-        <p:blipFill>
-          <a:blip r:embed="rId2"/>
-          <a:stretch>
-            <a:fillRect/>
-          </a:stretch>
-        </p:blipFill>
-        <p:spPr>
-          <a:xfrm>
-            <a:off x="847725" y="5962650"/>
-            <a:ext cx="142875" cy="190500"/>
-          </a:xfrm>
-          <a:prstGeom prst="rect">
-            <a:avLst/>
-          </a:prstGeom>
-        </p:spPr>
-      </p:pic>
-      <p:pic>
-        <p:nvPicPr>
-          <p:cNvPr id="13" name="Picture 12" descr="image.png"/>
-          <p:cNvPicPr>
-            <a:picLocks noChangeAspect="1"/>
-          </p:cNvPicPr>
-          <p:nvPr/>
-        </p:nvPicPr>
-        <p:blipFill>
-          <a:blip r:embed="rId3"/>
-          <a:stretch>
-            <a:fillRect/>
-          </a:stretch>
-        </p:blipFill>
-        <p:spPr>
-          <a:xfrm>
-            <a:off x="847725" y="2438400"/>
-            <a:ext cx="381000" cy="381000"/>
-          </a:xfrm>
-          <a:prstGeom prst="rect">
-            <a:avLst/>
-          </a:prstGeom>
-        </p:spPr>
-      </p:pic>
-      <p:pic>
-        <p:nvPicPr>
-          <p:cNvPr id="14" name="Picture 13" descr="image.png"/>
-          <p:cNvPicPr>
-            <a:picLocks noChangeAspect="1"/>
-          </p:cNvPicPr>
-          <p:nvPr/>
-        </p:nvPicPr>
-        <p:blipFill>
-          <a:blip r:embed="rId4"/>
-          <a:stretch>
-            <a:fillRect/>
-          </a:stretch>
-        </p:blipFill>
-        <p:spPr>
-          <a:xfrm>
-            <a:off x="3638550" y="2438400"/>
-            <a:ext cx="381000" cy="381000"/>
-          </a:xfrm>
-          <a:prstGeom prst="rect">
-            <a:avLst/>
-          </a:prstGeom>
-        </p:spPr>
-      </p:pic>
-      <p:pic>
-        <p:nvPicPr>
-          <p:cNvPr id="15" name="Picture 14" descr="image.png"/>
-          <p:cNvPicPr>
-            <a:picLocks noChangeAspect="1"/>
-          </p:cNvPicPr>
-          <p:nvPr/>
-        </p:nvPicPr>
-        <p:blipFill>
-          <a:blip r:embed="rId3"/>
-          <a:stretch>
-            <a:fillRect/>
-          </a:stretch>
-        </p:blipFill>
-        <p:spPr>
-          <a:xfrm>
-            <a:off x="6429375" y="2438400"/>
-            <a:ext cx="381000" cy="381000"/>
-          </a:xfrm>
-          <a:prstGeom prst="rect">
-            <a:avLst/>
-          </a:prstGeom>
-        </p:spPr>
-      </p:pic>
-      <p:pic>
-        <p:nvPicPr>
-          <p:cNvPr id="16" name="Picture 15" descr="image.png"/>
-          <p:cNvPicPr>
-            <a:picLocks noChangeAspect="1"/>
-          </p:cNvPicPr>
-          <p:nvPr/>
-        </p:nvPicPr>
-        <p:blipFill>
-          <a:blip r:embed="rId4"/>
-          <a:stretch>
-            <a:fillRect/>
-          </a:stretch>
-        </p:blipFill>
-        <p:spPr>
-          <a:xfrm>
-            <a:off x="9220200" y="2438400"/>
-            <a:ext cx="381000" cy="381000"/>
-          </a:xfrm>
-          <a:prstGeom prst="rect">
-            <a:avLst/>
-          </a:prstGeom>
-        </p:spPr>
-      </p:pic>
-      <p:pic>
-        <p:nvPicPr>
-          <p:cNvPr id="17" name="Picture 16" descr="image.png"/>
-          <p:cNvPicPr>
-            <a:picLocks noChangeAspect="1"/>
-          </p:cNvPicPr>
-          <p:nvPr/>
-        </p:nvPicPr>
-        <p:blipFill>
-          <a:blip r:embed="rId5"/>
-          <a:stretch>
-            <a:fillRect/>
-          </a:stretch>
-        </p:blipFill>
-        <p:spPr>
-          <a:xfrm>
-            <a:off x="962025" y="2543175"/>
-            <a:ext cx="152400" cy="171450"/>
-          </a:xfrm>
-          <a:prstGeom prst="rect">
-            <a:avLst/>
-          </a:prstGeom>
-        </p:spPr>
-      </p:pic>
-      <p:pic>
-        <p:nvPicPr>
-          <p:cNvPr id="18" name="Picture 17" descr="image.png"/>
-          <p:cNvPicPr>
-            <a:picLocks noChangeAspect="1"/>
-          </p:cNvPicPr>
-          <p:nvPr/>
-        </p:nvPicPr>
-        <p:blipFill>
-          <a:blip r:embed="rId6"/>
-          <a:stretch>
-            <a:fillRect/>
-          </a:stretch>
-        </p:blipFill>
-        <p:spPr>
-          <a:xfrm>
-            <a:off x="3733800" y="2543175"/>
-            <a:ext cx="190500" cy="171450"/>
-          </a:xfrm>
-          <a:prstGeom prst="rect">
-            <a:avLst/>
-          </a:prstGeom>
-        </p:spPr>
-      </p:pic>
-      <p:pic>
-        <p:nvPicPr>
-          <p:cNvPr id="19" name="Picture 18" descr="image.png"/>
-          <p:cNvPicPr>
-            <a:picLocks noChangeAspect="1"/>
-          </p:cNvPicPr>
-          <p:nvPr/>
-        </p:nvPicPr>
-        <p:blipFill>
-          <a:blip r:embed="rId7"/>
-          <a:stretch>
-            <a:fillRect/>
-          </a:stretch>
-        </p:blipFill>
-        <p:spPr>
-          <a:xfrm>
-            <a:off x="6534150" y="2543175"/>
-            <a:ext cx="171450" cy="171450"/>
-          </a:xfrm>
-          <a:prstGeom prst="rect">
-            <a:avLst/>
-          </a:prstGeom>
-        </p:spPr>
-      </p:pic>
-      <p:pic>
-        <p:nvPicPr>
-          <p:cNvPr id="20" name="Picture 19" descr="image.png"/>
-          <p:cNvPicPr>
-            <a:picLocks noChangeAspect="1"/>
-          </p:cNvPicPr>
-          <p:nvPr/>
-        </p:nvPicPr>
-        <p:blipFill>
-          <a:blip r:embed="rId8"/>
-          <a:stretch>
-            <a:fillRect/>
-          </a:stretch>
-        </p:blipFill>
-        <p:spPr>
-          <a:xfrm>
-            <a:off x="9315450" y="2543175"/>
-            <a:ext cx="190500" cy="171450"/>
-          </a:xfrm>
-          <a:prstGeom prst="rect">
-            <a:avLst/>
-          </a:prstGeom>
-        </p:spPr>
-      </p:pic>
-      <p:sp>
-        <p:nvSpPr>
-          <p:cNvPr id="22" name="TextBox 21"/>
+          <p:cNvPr id="7" name="TextBox 6">
+            <a:extLst>
+              <a:ext uri="{FF2B5EF4-FFF2-40B4-BE49-F238E27FC236}">
+                <a16:creationId xmlns:a16="http://schemas.microsoft.com/office/drawing/2014/main" id="{ED267760-8A83-77A2-3689-F7CF40F7E36F}"/>
+              </a:ext>
+            </a:extLst>
+          </p:cNvPr>
           <p:cNvSpPr txBox="1"/>
           <p:nvPr/>
         </p:nvSpPr>
         <p:spPr>
           <a:xfrm>
-            <a:off x="1143000" y="5876925"/>
-            <a:ext cx="10296525" cy="361950"/>
+            <a:off x="609600" y="6067425"/>
+            <a:ext cx="2781467" cy="276999"/>
+          </a:xfrm>
+          <a:prstGeom prst="rect">
+            <a:avLst/>
+          </a:prstGeom>
+          <a:noFill/>
+        </p:spPr>
+        <p:txBody>
+          <a:bodyPr wrap="none" lIns="0" tIns="0" rIns="0" bIns="0" anchor="t">
+            <a:spAutoFit/>
+          </a:bodyPr>
+          <a:lstStyle/>
+          <a:p>
+            <a:pPr algn="l"/>
+            <a:r>
+              <a:rPr b="0" i="0" u="none" dirty="0">
+                <a:solidFill>
+                  <a:srgbClr val="CBD5E1"/>
+                </a:solidFill>
+                <a:latin typeface="Inter"/>
+              </a:rPr>
+              <a:t>Presenter: </a:t>
+            </a:r>
+            <a:r>
+              <a:rPr lang="en-US" b="0" i="0" u="none" dirty="0">
+                <a:solidFill>
+                  <a:srgbClr val="CBD5E1"/>
+                </a:solidFill>
+                <a:latin typeface="Inter"/>
+              </a:rPr>
+              <a:t>Todoran C. Bogdan</a:t>
+            </a:r>
+            <a:endParaRPr b="0" i="0" u="none" dirty="0">
+              <a:solidFill>
+                <a:srgbClr val="CBD5E1"/>
+              </a:solidFill>
+              <a:latin typeface="Inter"/>
+            </a:endParaRPr>
+          </a:p>
+        </p:txBody>
+      </p:sp>
+      <p:sp>
+        <p:nvSpPr>
+          <p:cNvPr id="9" name="TextBox 8">
+            <a:extLst>
+              <a:ext uri="{FF2B5EF4-FFF2-40B4-BE49-F238E27FC236}">
+                <a16:creationId xmlns:a16="http://schemas.microsoft.com/office/drawing/2014/main" id="{CDCBF468-DD51-C753-3183-9304112824D7}"/>
+              </a:ext>
+            </a:extLst>
+          </p:cNvPr>
+          <p:cNvSpPr txBox="1"/>
+          <p:nvPr/>
+        </p:nvSpPr>
+        <p:spPr>
+          <a:xfrm>
+            <a:off x="143256" y="88392"/>
+            <a:ext cx="2811091" cy="184666"/>
+          </a:xfrm>
+          <a:prstGeom prst="rect">
+            <a:avLst/>
+          </a:prstGeom>
+          <a:noFill/>
+        </p:spPr>
+        <p:txBody>
+          <a:bodyPr wrap="none" lIns="0" tIns="0" rIns="0" bIns="0" anchor="t">
+            <a:spAutoFit/>
+          </a:bodyPr>
+          <a:lstStyle/>
+          <a:p>
+            <a:pPr algn="l"/>
+            <a:r>
+              <a:rPr sz="1200" b="1" i="0" u="none" dirty="0">
+                <a:solidFill>
+                  <a:srgbClr val="38BDF8"/>
+                </a:solidFill>
+                <a:latin typeface="Space Grotesk"/>
+              </a:rPr>
+              <a:t>ACL COURSE • RR1 PRELIMINARY RESEARC</a:t>
+            </a:r>
+            <a:r>
+              <a:rPr lang="en-US" sz="1200" b="1" i="0" u="none" dirty="0">
+                <a:solidFill>
+                  <a:srgbClr val="38BDF8"/>
+                </a:solidFill>
+                <a:latin typeface="Space Grotesk"/>
+              </a:rPr>
+              <a:t>H</a:t>
+            </a:r>
+            <a:endParaRPr sz="1200" b="1" i="0" u="none" dirty="0">
+              <a:solidFill>
+                <a:srgbClr val="38BDF8"/>
+              </a:solidFill>
+              <a:latin typeface="Space Grotesk"/>
+            </a:endParaRPr>
+          </a:p>
+        </p:txBody>
+      </p:sp>
+      <p:sp>
+        <p:nvSpPr>
+          <p:cNvPr id="10" name="TextBox 9">
+            <a:extLst>
+              <a:ext uri="{FF2B5EF4-FFF2-40B4-BE49-F238E27FC236}">
+                <a16:creationId xmlns:a16="http://schemas.microsoft.com/office/drawing/2014/main" id="{BCA7C08E-BB96-9462-F5EA-C023A90ED3CA}"/>
+              </a:ext>
+            </a:extLst>
+          </p:cNvPr>
+          <p:cNvSpPr txBox="1"/>
+          <p:nvPr/>
+        </p:nvSpPr>
+        <p:spPr>
+          <a:xfrm>
+            <a:off x="648177" y="1210590"/>
+            <a:ext cx="10876598" cy="577081"/>
           </a:xfrm>
           <a:prstGeom prst="rect">
             <a:avLst/>
@@ -4525,38 +4295,226 @@
           </a:bodyPr>
           <a:lstStyle/>
           <a:p>
+            <a:pPr algn="ctr">
+              <a:lnSpc>
+                <a:spcPts val="4484"/>
+              </a:lnSpc>
+            </a:pPr>
+            <a:r>
+              <a:rPr sz="4000" b="1" i="0" u="none" dirty="0">
+                <a:solidFill>
+                  <a:srgbClr val="F8FAFC"/>
+                </a:solidFill>
+                <a:latin typeface="Space Grotesk"/>
+              </a:rPr>
+              <a:t>Ontology Matching</a:t>
+            </a:r>
+            <a:r>
+              <a:rPr lang="en-US" sz="4000" b="1" dirty="0">
+                <a:solidFill>
+                  <a:srgbClr val="F8FAFC"/>
+                </a:solidFill>
+                <a:latin typeface="Space Grotesk"/>
+              </a:rPr>
+              <a:t> </a:t>
+            </a:r>
+            <a:r>
+              <a:rPr sz="4000" b="1" i="0" u="none" dirty="0">
+                <a:solidFill>
+                  <a:srgbClr val="F8FAFC"/>
+                </a:solidFill>
+                <a:latin typeface="Space Grotesk"/>
+              </a:rPr>
+              <a:t>with Large Language Models</a:t>
+            </a:r>
+          </a:p>
+        </p:txBody>
+      </p:sp>
+      <p:sp>
+        <p:nvSpPr>
+          <p:cNvPr id="11" name="TextBox 10">
+            <a:extLst>
+              <a:ext uri="{FF2B5EF4-FFF2-40B4-BE49-F238E27FC236}">
+                <a16:creationId xmlns:a16="http://schemas.microsoft.com/office/drawing/2014/main" id="{894B1C31-DDC6-8455-31B6-BC1F4A7F5385}"/>
+              </a:ext>
+            </a:extLst>
+          </p:cNvPr>
+          <p:cNvSpPr txBox="1"/>
+          <p:nvPr/>
+        </p:nvSpPr>
+        <p:spPr>
+          <a:xfrm>
+            <a:off x="1774270" y="1843332"/>
+            <a:ext cx="8624412" cy="307777"/>
+          </a:xfrm>
+          <a:prstGeom prst="rect">
+            <a:avLst/>
+          </a:prstGeom>
+          <a:noFill/>
+        </p:spPr>
+        <p:txBody>
+          <a:bodyPr wrap="none" lIns="0" tIns="0" rIns="0" bIns="0" anchor="t">
+            <a:spAutoFit/>
+          </a:bodyPr>
+          <a:lstStyle/>
+          <a:p>
             <a:pPr algn="l"/>
             <a:r>
-              <a:rPr sz="1125" b="1" i="0" u="none">
-                <a:solidFill>
-                  <a:srgbClr val="854D0E"/>
-                </a:solidFill>
-                <a:latin typeface="Inter"/>
-              </a:rPr>
-              <a:t>Core Architecture Principle:</a:t>
-            </a:r>
-            <a:r>
-              <a:rPr sz="1125" b="0" i="0" u="none">
-                <a:solidFill>
-                  <a:srgbClr val="854D0E"/>
-                </a:solidFill>
-                <a:latin typeface="Inter"/>
-              </a:rPr>
-              <a:t> Embeddings isolate candidate search space; structural post-processing guarantees graph logic consistency without increasing LLM prompt overhead.</a:t>
-            </a:r>
-          </a:p>
-        </p:txBody>
-      </p:sp>
-      <p:sp>
-        <p:nvSpPr>
-          <p:cNvPr id="23" name="TextBox 22"/>
+              <a:rPr sz="2000" b="0" i="0" u="none" dirty="0">
+                <a:solidFill>
+                  <a:srgbClr val="94A3B8"/>
+                </a:solidFill>
+                <a:latin typeface="Inter"/>
+              </a:rPr>
+              <a:t>A Comparative Analysis of </a:t>
+            </a:r>
+            <a:r>
+              <a:rPr lang="en-US" sz="2000" b="0" i="0" u="none" dirty="0">
+                <a:solidFill>
+                  <a:srgbClr val="94A3B8"/>
+                </a:solidFill>
+                <a:latin typeface="Inter"/>
+              </a:rPr>
+              <a:t>"</a:t>
+            </a:r>
+            <a:r>
+              <a:rPr sz="2000" b="0" i="0" u="none" dirty="0">
+                <a:solidFill>
+                  <a:srgbClr val="94A3B8"/>
+                </a:solidFill>
+                <a:latin typeface="Inter"/>
+              </a:rPr>
+              <a:t>KROMA</a:t>
+            </a:r>
+            <a:r>
+              <a:rPr lang="en-US" sz="2000" b="0" i="0" u="none" dirty="0">
+                <a:solidFill>
+                  <a:srgbClr val="94A3B8"/>
+                </a:solidFill>
+                <a:latin typeface="Inter"/>
+              </a:rPr>
+              <a:t>"</a:t>
+            </a:r>
+            <a:r>
+              <a:rPr sz="2000" b="0" i="0" u="none" dirty="0">
+                <a:solidFill>
+                  <a:srgbClr val="94A3B8"/>
+                </a:solidFill>
+                <a:latin typeface="Inter"/>
+              </a:rPr>
+              <a:t> and </a:t>
+            </a:r>
+            <a:r>
+              <a:rPr lang="en-US" sz="2000" b="0" i="0" u="none" dirty="0">
+                <a:solidFill>
+                  <a:srgbClr val="94A3B8"/>
+                </a:solidFill>
+                <a:latin typeface="Inter"/>
+              </a:rPr>
+              <a:t>"</a:t>
+            </a:r>
+            <a:r>
+              <a:rPr sz="2000" b="0" i="0" u="none" dirty="0">
+                <a:solidFill>
+                  <a:srgbClr val="94A3B8"/>
+                </a:solidFill>
+                <a:latin typeface="Inter"/>
+              </a:rPr>
+              <a:t>Agent-</a:t>
+            </a:r>
+            <a:r>
+              <a:rPr lang="en-GB" sz="2000" b="0" i="0" u="none" dirty="0">
+                <a:solidFill>
+                  <a:srgbClr val="94A3B8"/>
+                </a:solidFill>
+                <a:latin typeface="Inter"/>
+              </a:rPr>
+              <a:t>Ontology Matching </a:t>
+            </a:r>
+            <a:r>
+              <a:rPr sz="2000" b="0" i="0" u="none" dirty="0">
+                <a:solidFill>
+                  <a:srgbClr val="94A3B8"/>
+                </a:solidFill>
+                <a:latin typeface="Inter"/>
+              </a:rPr>
+              <a:t>Architectures</a:t>
+            </a:r>
+            <a:r>
+              <a:rPr lang="en-US" sz="2000" b="0" i="0" u="none" dirty="0">
+                <a:solidFill>
+                  <a:srgbClr val="94A3B8"/>
+                </a:solidFill>
+                <a:latin typeface="Inter"/>
+              </a:rPr>
+              <a:t>"</a:t>
+            </a:r>
+            <a:endParaRPr sz="2000" b="0" i="0" u="none" dirty="0">
+              <a:solidFill>
+                <a:srgbClr val="94A3B8"/>
+              </a:solidFill>
+              <a:latin typeface="Inter"/>
+            </a:endParaRPr>
+          </a:p>
+        </p:txBody>
+      </p:sp>
+      <p:sp>
+        <p:nvSpPr>
+          <p:cNvPr id="14" name="TextBox 13">
+            <a:extLst>
+              <a:ext uri="{FF2B5EF4-FFF2-40B4-BE49-F238E27FC236}">
+                <a16:creationId xmlns:a16="http://schemas.microsoft.com/office/drawing/2014/main" id="{C11BD3A7-BB05-1D95-A52E-4E75CCC9E956}"/>
+              </a:ext>
+            </a:extLst>
+          </p:cNvPr>
           <p:cNvSpPr txBox="1"/>
           <p:nvPr/>
         </p:nvSpPr>
         <p:spPr>
           <a:xfrm>
-            <a:off x="609600" y="625220"/>
-            <a:ext cx="10972800" cy="1231106"/>
+            <a:off x="919164" y="3390004"/>
+            <a:ext cx="1525161" cy="307777"/>
+          </a:xfrm>
+          <a:prstGeom prst="rect">
+            <a:avLst/>
+          </a:prstGeom>
+          <a:noFill/>
+        </p:spPr>
+        <p:txBody>
+          <a:bodyPr wrap="none" lIns="0" tIns="0" rIns="0" bIns="0" anchor="t">
+            <a:spAutoFit/>
+          </a:bodyPr>
+          <a:lstStyle/>
+          <a:p>
+            <a:pPr algn="l"/>
+            <a:r>
+              <a:rPr sz="2000" b="1" i="0" u="none" dirty="0">
+                <a:solidFill>
+                  <a:srgbClr val="38BDF8"/>
+                </a:solidFill>
+                <a:latin typeface="Space Grotesk"/>
+              </a:rPr>
+              <a:t>THE PROBLEM</a:t>
+            </a:r>
+          </a:p>
+        </p:txBody>
+      </p:sp>
+      <p:sp>
+        <p:nvSpPr>
+          <p:cNvPr id="15" name="TextBox 14">
+            <a:extLst>
+              <a:ext uri="{FF2B5EF4-FFF2-40B4-BE49-F238E27FC236}">
+                <a16:creationId xmlns:a16="http://schemas.microsoft.com/office/drawing/2014/main" id="{C53789EE-0C2A-D68B-D0DB-587F1B38B73B}"/>
+              </a:ext>
+            </a:extLst>
+          </p:cNvPr>
+          <p:cNvSpPr txBox="1"/>
+          <p:nvPr/>
+        </p:nvSpPr>
+        <p:spPr>
+          <a:xfrm>
+            <a:off x="919163" y="3930495"/>
+            <a:ext cx="4957762" cy="933332"/>
           </a:xfrm>
           <a:prstGeom prst="rect">
             <a:avLst/>
@@ -4569,47 +4527,112 @@
           </a:bodyPr>
           <a:lstStyle/>
           <a:p>
-            <a:pPr algn="ctr"/>
-            <a:r>
-              <a:rPr lang="en-US" sz="4000" b="1" i="0" u="none" dirty="0">
-                <a:solidFill>
-                  <a:srgbClr val="0284C7"/>
+            <a:pPr algn="l">
+              <a:lnSpc>
+                <a:spcPts val="1800"/>
+              </a:lnSpc>
+            </a:pPr>
+            <a:r>
+              <a:rPr sz="2000" b="1" i="0" u="none" dirty="0">
+                <a:solidFill>
+                  <a:srgbClr val="E2E8F0"/>
+                </a:solidFill>
+                <a:latin typeface="Inter"/>
+              </a:rPr>
+              <a:t>Traditional OM:</a:t>
+            </a:r>
+            <a:r>
+              <a:rPr sz="2000" b="0" i="0" u="none" dirty="0">
+                <a:solidFill>
+                  <a:srgbClr val="E2E8F0"/>
+                </a:solidFill>
+                <a:latin typeface="Inter"/>
+              </a:rPr>
+              <a:t> Relies on fixed rules and manual features. </a:t>
+            </a:r>
+            <a:r>
+              <a:rPr sz="2000" dirty="0"/>
+              <a:t>
+</a:t>
+            </a:r>
+            <a:r>
+              <a:rPr sz="2000" b="1" i="0" u="none" dirty="0">
+                <a:solidFill>
+                  <a:srgbClr val="E2E8F0"/>
+                </a:solidFill>
+                <a:latin typeface="Inter"/>
+              </a:rPr>
+              <a:t>Direct Prompting:</a:t>
+            </a:r>
+            <a:r>
+              <a:rPr sz="2000" b="0" i="0" u="none" dirty="0">
+                <a:solidFill>
+                  <a:srgbClr val="E2E8F0"/>
+                </a:solidFill>
+                <a:latin typeface="Inter"/>
+              </a:rPr>
+              <a:t> High token costs, hallucinations, scale limits.</a:t>
+            </a:r>
+          </a:p>
+        </p:txBody>
+      </p:sp>
+      <p:sp>
+        <p:nvSpPr>
+          <p:cNvPr id="16" name="TextBox 15">
+            <a:extLst>
+              <a:ext uri="{FF2B5EF4-FFF2-40B4-BE49-F238E27FC236}">
+                <a16:creationId xmlns:a16="http://schemas.microsoft.com/office/drawing/2014/main" id="{81AFE09A-5A3E-CCB8-80E8-2CF9083BBF2B}"/>
+              </a:ext>
+            </a:extLst>
+          </p:cNvPr>
+          <p:cNvSpPr txBox="1"/>
+          <p:nvPr/>
+        </p:nvSpPr>
+        <p:spPr>
+          <a:xfrm>
+            <a:off x="6400801" y="3390004"/>
+            <a:ext cx="2298321" cy="307777"/>
+          </a:xfrm>
+          <a:prstGeom prst="rect">
+            <a:avLst/>
+          </a:prstGeom>
+          <a:noFill/>
+        </p:spPr>
+        <p:txBody>
+          <a:bodyPr wrap="none" lIns="0" tIns="0" rIns="0" bIns="0" anchor="t">
+            <a:spAutoFit/>
+          </a:bodyPr>
+          <a:lstStyle/>
+          <a:p>
+            <a:pPr algn="l"/>
+            <a:r>
+              <a:rPr sz="2000" b="1" i="0" u="none" dirty="0">
+                <a:solidFill>
+                  <a:srgbClr val="38BDF8"/>
                 </a:solidFill>
                 <a:latin typeface="Space Grotesk"/>
               </a:rPr>
-              <a:t>KROMA: Ontology Matching with Knowledge</a:t>
-            </a:r>
-          </a:p>
-          <a:p>
-            <a:pPr algn="ctr"/>
-            <a:r>
-              <a:rPr lang="en-US" sz="4000" b="1" i="0" u="none" dirty="0">
-                <a:solidFill>
-                  <a:srgbClr val="0284C7"/>
-                </a:solidFill>
-                <a:latin typeface="Space Grotesk"/>
-              </a:rPr>
-              <a:t>Retrieval and Large Language Models</a:t>
-            </a:r>
-            <a:endParaRPr sz="4000" b="1" i="0" u="none" dirty="0">
-              <a:solidFill>
-                <a:srgbClr val="0284C7"/>
-              </a:solidFill>
-              <a:latin typeface="Space Grotesk"/>
-            </a:endParaRPr>
-          </a:p>
-        </p:txBody>
-      </p:sp>
-      <p:sp>
-        <p:nvSpPr>
-          <p:cNvPr id="25" name="TextBox 24"/>
+              <a:t>RESEARCH OBJECTIVE</a:t>
+            </a:r>
+          </a:p>
+        </p:txBody>
+      </p:sp>
+      <p:sp>
+        <p:nvSpPr>
+          <p:cNvPr id="17" name="TextBox 16">
+            <a:extLst>
+              <a:ext uri="{FF2B5EF4-FFF2-40B4-BE49-F238E27FC236}">
+                <a16:creationId xmlns:a16="http://schemas.microsoft.com/office/drawing/2014/main" id="{867A2EBF-C123-3FDE-CE9E-9BBFAF724D4C}"/>
+              </a:ext>
+            </a:extLst>
+          </p:cNvPr>
           <p:cNvSpPr txBox="1"/>
           <p:nvPr/>
         </p:nvSpPr>
         <p:spPr>
           <a:xfrm>
-            <a:off x="942975" y="5180070"/>
-            <a:ext cx="2028825" cy="215444"/>
+            <a:off x="6401087" y="4026532"/>
+            <a:ext cx="4957762" cy="702500"/>
           </a:xfrm>
           <a:prstGeom prst="rect">
             <a:avLst/>
@@ -4622,475 +4645,83 @@
           </a:bodyPr>
           <a:lstStyle/>
           <a:p>
-            <a:pPr algn="l"/>
-            <a:r>
-              <a:rPr sz="1400" b="0" i="0" u="none" dirty="0">
-                <a:solidFill>
-                  <a:srgbClr val="0284C7"/>
-                </a:solidFill>
-                <a:latin typeface="JetBrains Mono"/>
-              </a:rPr>
-              <a:t>Context Enrichment</a:t>
-            </a:r>
-          </a:p>
-        </p:txBody>
-      </p:sp>
-      <p:sp>
-        <p:nvSpPr>
-          <p:cNvPr id="26" name="TextBox 25"/>
-          <p:cNvSpPr txBox="1"/>
-          <p:nvPr/>
-        </p:nvSpPr>
-        <p:spPr>
-          <a:xfrm>
-            <a:off x="3733800" y="5180070"/>
-            <a:ext cx="2028825" cy="215444"/>
-          </a:xfrm>
-          <a:prstGeom prst="rect">
-            <a:avLst/>
-          </a:prstGeom>
-          <a:noFill/>
-        </p:spPr>
-        <p:txBody>
-          <a:bodyPr wrap="square" lIns="0" tIns="0" rIns="0" bIns="0" anchor="t">
-            <a:spAutoFit/>
-          </a:bodyPr>
-          <a:lstStyle/>
-          <a:p>
-            <a:pPr algn="l"/>
-            <a:r>
-              <a:rPr sz="1400" b="0" i="0" u="none">
-                <a:solidFill>
-                  <a:srgbClr val="0284C7"/>
-                </a:solidFill>
-                <a:latin typeface="JetBrains Mono"/>
-              </a:rPr>
-              <a:t>Text + Graph Embeddings</a:t>
-            </a:r>
-          </a:p>
-        </p:txBody>
-      </p:sp>
-      <p:sp>
-        <p:nvSpPr>
-          <p:cNvPr id="27" name="TextBox 26"/>
-          <p:cNvSpPr txBox="1"/>
-          <p:nvPr/>
-        </p:nvSpPr>
-        <p:spPr>
-          <a:xfrm>
-            <a:off x="6524625" y="5180070"/>
-            <a:ext cx="2028825" cy="215444"/>
-          </a:xfrm>
-          <a:prstGeom prst="rect">
-            <a:avLst/>
-          </a:prstGeom>
-          <a:noFill/>
-        </p:spPr>
-        <p:txBody>
-          <a:bodyPr wrap="square" lIns="0" tIns="0" rIns="0" bIns="0" anchor="t">
-            <a:spAutoFit/>
-          </a:bodyPr>
-          <a:lstStyle/>
-          <a:p>
-            <a:pPr algn="l"/>
-            <a:r>
-              <a:rPr sz="1400" b="0" i="0" u="none">
-                <a:solidFill>
-                  <a:srgbClr val="0284C7"/>
-                </a:solidFill>
-                <a:latin typeface="JetBrains Mono"/>
-              </a:rPr>
-              <a:t>Semantic Reasoning</a:t>
-            </a:r>
-          </a:p>
-        </p:txBody>
-      </p:sp>
-      <p:sp>
-        <p:nvSpPr>
-          <p:cNvPr id="28" name="TextBox 27"/>
-          <p:cNvSpPr txBox="1"/>
-          <p:nvPr/>
-        </p:nvSpPr>
-        <p:spPr>
-          <a:xfrm>
-            <a:off x="9315450" y="5180070"/>
-            <a:ext cx="2028825" cy="215444"/>
-          </a:xfrm>
-          <a:prstGeom prst="rect">
-            <a:avLst/>
-          </a:prstGeom>
-          <a:noFill/>
-        </p:spPr>
-        <p:txBody>
-          <a:bodyPr wrap="square" lIns="0" tIns="0" rIns="0" bIns="0" anchor="t">
-            <a:spAutoFit/>
-          </a:bodyPr>
-          <a:lstStyle/>
-          <a:p>
-            <a:pPr algn="l"/>
-            <a:r>
-              <a:rPr sz="1400" b="0" i="0" u="none">
-                <a:solidFill>
-                  <a:srgbClr val="0284C7"/>
-                </a:solidFill>
-                <a:latin typeface="JetBrains Mono"/>
-              </a:rPr>
-              <a:t>Hierarchy Consistency</a:t>
-            </a:r>
-          </a:p>
-        </p:txBody>
-      </p:sp>
-      <p:sp>
-        <p:nvSpPr>
-          <p:cNvPr id="29" name="TextBox 28"/>
-          <p:cNvSpPr txBox="1"/>
-          <p:nvPr/>
-        </p:nvSpPr>
-        <p:spPr>
-          <a:xfrm>
-            <a:off x="847725" y="2933700"/>
-            <a:ext cx="2219325" cy="276999"/>
-          </a:xfrm>
-          <a:prstGeom prst="rect">
-            <a:avLst/>
-          </a:prstGeom>
-          <a:noFill/>
-        </p:spPr>
-        <p:txBody>
-          <a:bodyPr wrap="square" lIns="0" tIns="0" rIns="0" bIns="0" anchor="t">
-            <a:spAutoFit/>
-          </a:bodyPr>
-          <a:lstStyle/>
-          <a:p>
-            <a:pPr algn="l"/>
-            <a:r>
-              <a:rPr b="1" i="0" u="none" dirty="0">
-                <a:solidFill>
-                  <a:srgbClr val="0F172A"/>
-                </a:solidFill>
-                <a:latin typeface="Space Grotesk"/>
-              </a:rPr>
-              <a:t>1. Knowledge Retrieval</a:t>
-            </a:r>
-          </a:p>
-        </p:txBody>
-      </p:sp>
-      <p:sp>
-        <p:nvSpPr>
-          <p:cNvPr id="30" name="TextBox 29"/>
-          <p:cNvSpPr txBox="1"/>
-          <p:nvPr/>
-        </p:nvSpPr>
-        <p:spPr>
-          <a:xfrm>
-            <a:off x="919162" y="3541006"/>
-            <a:ext cx="2219325" cy="1240724"/>
-          </a:xfrm>
-          <a:prstGeom prst="rect">
-            <a:avLst/>
-          </a:prstGeom>
-          <a:noFill/>
-        </p:spPr>
-        <p:txBody>
-          <a:bodyPr wrap="square" lIns="0" tIns="0" rIns="0" bIns="0" anchor="t">
-            <a:spAutoFit/>
-          </a:bodyPr>
-          <a:lstStyle/>
-          <a:p>
             <a:pPr algn="l">
               <a:lnSpc>
-                <a:spcPts val="1575"/>
+                <a:spcPts val="1800"/>
               </a:lnSpc>
             </a:pPr>
             <a:r>
-              <a:rPr b="0" i="0" u="none" dirty="0">
-                <a:solidFill>
-                  <a:srgbClr val="475569"/>
-                </a:solidFill>
-                <a:latin typeface="Inter"/>
-              </a:rPr>
-              <a:t>Fetches definitions, synonyms</a:t>
-            </a:r>
-            <a:r>
-              <a:rPr lang="en-US" dirty="0">
-                <a:solidFill>
-                  <a:srgbClr val="475569"/>
-                </a:solidFill>
-                <a:latin typeface="Inter"/>
-              </a:rPr>
-              <a:t> </a:t>
-            </a:r>
-            <a:r>
-              <a:rPr b="0" i="0" u="none" dirty="0">
-                <a:solidFill>
-                  <a:srgbClr val="475569"/>
-                </a:solidFill>
-                <a:latin typeface="Inter"/>
-              </a:rPr>
-              <a:t>and domain contexts from external knowledge bases to enrich concept descriptions.</a:t>
-            </a:r>
-          </a:p>
-        </p:txBody>
-      </p:sp>
-      <p:sp>
-        <p:nvSpPr>
-          <p:cNvPr id="31" name="TextBox 30"/>
-          <p:cNvSpPr txBox="1"/>
-          <p:nvPr/>
-        </p:nvSpPr>
-        <p:spPr>
-          <a:xfrm>
-            <a:off x="3638550" y="2933700"/>
-            <a:ext cx="2219325" cy="276999"/>
-          </a:xfrm>
-          <a:prstGeom prst="rect">
-            <a:avLst/>
-          </a:prstGeom>
-          <a:noFill/>
-        </p:spPr>
-        <p:txBody>
-          <a:bodyPr wrap="square" lIns="0" tIns="0" rIns="0" bIns="0" anchor="t">
-            <a:spAutoFit/>
-          </a:bodyPr>
-          <a:lstStyle/>
-          <a:p>
-            <a:pPr algn="l"/>
-            <a:r>
-              <a:rPr b="1" i="0" u="none" dirty="0">
-                <a:solidFill>
-                  <a:srgbClr val="0F172A"/>
-                </a:solidFill>
-                <a:latin typeface="Space Grotesk"/>
-              </a:rPr>
-              <a:t>2. Candidate Selection</a:t>
-            </a:r>
-          </a:p>
-        </p:txBody>
-      </p:sp>
-      <p:sp>
-        <p:nvSpPr>
-          <p:cNvPr id="32" name="TextBox 31"/>
-          <p:cNvSpPr txBox="1"/>
-          <p:nvPr/>
-        </p:nvSpPr>
-        <p:spPr>
-          <a:xfrm>
-            <a:off x="3638549" y="3541006"/>
-            <a:ext cx="2219325" cy="830356"/>
-          </a:xfrm>
-          <a:prstGeom prst="rect">
-            <a:avLst/>
-          </a:prstGeom>
-          <a:noFill/>
-        </p:spPr>
-        <p:txBody>
-          <a:bodyPr wrap="square" lIns="0" tIns="0" rIns="0" bIns="0" anchor="t">
-            <a:spAutoFit/>
-          </a:bodyPr>
-          <a:lstStyle/>
-          <a:p>
-            <a:pPr algn="l">
-              <a:lnSpc>
-                <a:spcPts val="1575"/>
-              </a:lnSpc>
-            </a:pPr>
-            <a:r>
-              <a:rPr b="0" i="0" u="none" dirty="0">
-                <a:solidFill>
-                  <a:srgbClr val="475569"/>
-                </a:solidFill>
-                <a:latin typeface="Inter"/>
-              </a:rPr>
-              <a:t>Fuses text embeddings with graph embeddings to prune non-matching pairs efficiently.</a:t>
-            </a:r>
-          </a:p>
-        </p:txBody>
-      </p:sp>
-      <p:sp>
-        <p:nvSpPr>
-          <p:cNvPr id="33" name="TextBox 32"/>
-          <p:cNvSpPr txBox="1"/>
-          <p:nvPr/>
-        </p:nvSpPr>
-        <p:spPr>
-          <a:xfrm>
-            <a:off x="6429375" y="2933700"/>
-            <a:ext cx="2219325" cy="276999"/>
-          </a:xfrm>
-          <a:prstGeom prst="rect">
-            <a:avLst/>
-          </a:prstGeom>
-          <a:noFill/>
-        </p:spPr>
-        <p:txBody>
-          <a:bodyPr wrap="square" lIns="0" tIns="0" rIns="0" bIns="0" anchor="t">
-            <a:spAutoFit/>
-          </a:bodyPr>
-          <a:lstStyle/>
-          <a:p>
-            <a:pPr algn="l"/>
-            <a:r>
-              <a:rPr b="1" i="0" u="none" dirty="0">
-                <a:solidFill>
-                  <a:srgbClr val="0F172A"/>
-                </a:solidFill>
-                <a:latin typeface="Space Grotesk"/>
-              </a:rPr>
-              <a:t>3. LLM Verification</a:t>
-            </a:r>
-          </a:p>
-        </p:txBody>
-      </p:sp>
-      <p:sp>
-        <p:nvSpPr>
-          <p:cNvPr id="34" name="TextBox 33"/>
-          <p:cNvSpPr txBox="1"/>
-          <p:nvPr/>
-        </p:nvSpPr>
-        <p:spPr>
-          <a:xfrm>
-            <a:off x="6429375" y="3539446"/>
-            <a:ext cx="2219325" cy="830356"/>
-          </a:xfrm>
-          <a:prstGeom prst="rect">
-            <a:avLst/>
-          </a:prstGeom>
-          <a:noFill/>
-        </p:spPr>
-        <p:txBody>
-          <a:bodyPr wrap="square" lIns="0" tIns="0" rIns="0" bIns="0" anchor="t">
-            <a:spAutoFit/>
-          </a:bodyPr>
-          <a:lstStyle/>
-          <a:p>
-            <a:pPr algn="l">
-              <a:lnSpc>
-                <a:spcPts val="1575"/>
-              </a:lnSpc>
-            </a:pPr>
-            <a:r>
-              <a:rPr b="0" i="0" u="none" dirty="0">
-                <a:solidFill>
-                  <a:srgbClr val="475569"/>
-                </a:solidFill>
-                <a:latin typeface="Inter"/>
-              </a:rPr>
-              <a:t>Evaluates candidate pairs through deep contextual reasoning using LLMs.</a:t>
-            </a:r>
-          </a:p>
-        </p:txBody>
-      </p:sp>
-      <p:sp>
-        <p:nvSpPr>
-          <p:cNvPr id="35" name="TextBox 34"/>
-          <p:cNvSpPr txBox="1"/>
-          <p:nvPr/>
-        </p:nvSpPr>
-        <p:spPr>
-          <a:xfrm>
-            <a:off x="9220200" y="2933700"/>
-            <a:ext cx="2219325" cy="261610"/>
-          </a:xfrm>
-          <a:prstGeom prst="rect">
-            <a:avLst/>
-          </a:prstGeom>
-          <a:noFill/>
-        </p:spPr>
-        <p:txBody>
-          <a:bodyPr wrap="square" lIns="0" tIns="0" rIns="0" bIns="0" anchor="t">
-            <a:spAutoFit/>
-          </a:bodyPr>
-          <a:lstStyle/>
-          <a:p>
-            <a:pPr algn="l"/>
-            <a:r>
-              <a:rPr sz="1700" b="1" i="0" u="none" dirty="0">
-                <a:solidFill>
-                  <a:srgbClr val="0F172A"/>
-                </a:solidFill>
-                <a:latin typeface="Space Grotesk"/>
-              </a:rPr>
-              <a:t>4. Structural</a:t>
-            </a:r>
-            <a:r>
-              <a:rPr lang="en-US" sz="1700" b="1" i="0" u="none" dirty="0">
-                <a:solidFill>
-                  <a:srgbClr val="0F172A"/>
-                </a:solidFill>
-                <a:latin typeface="Space Grotesk"/>
-              </a:rPr>
-              <a:t> </a:t>
-            </a:r>
-            <a:r>
-              <a:rPr sz="1700" b="1" i="0" u="none" dirty="0">
-                <a:solidFill>
-                  <a:srgbClr val="0F172A"/>
-                </a:solidFill>
-                <a:latin typeface="Space Grotesk"/>
-              </a:rPr>
-              <a:t>Refinement</a:t>
-            </a:r>
-          </a:p>
-        </p:txBody>
-      </p:sp>
-      <p:sp>
-        <p:nvSpPr>
-          <p:cNvPr id="36" name="TextBox 35"/>
-          <p:cNvSpPr txBox="1"/>
-          <p:nvPr/>
-        </p:nvSpPr>
-        <p:spPr>
-          <a:xfrm>
-            <a:off x="9220200" y="3535094"/>
-            <a:ext cx="2219325" cy="1035540"/>
-          </a:xfrm>
-          <a:prstGeom prst="rect">
-            <a:avLst/>
-          </a:prstGeom>
-          <a:noFill/>
-        </p:spPr>
-        <p:txBody>
-          <a:bodyPr wrap="square" lIns="0" tIns="0" rIns="0" bIns="0" anchor="t">
-            <a:spAutoFit/>
-          </a:bodyPr>
-          <a:lstStyle/>
-          <a:p>
-            <a:pPr algn="l">
-              <a:lnSpc>
-                <a:spcPts val="1575"/>
-              </a:lnSpc>
-            </a:pPr>
-            <a:r>
-              <a:rPr b="0" i="0" u="none" dirty="0">
-                <a:solidFill>
-                  <a:srgbClr val="475569"/>
-                </a:solidFill>
-                <a:latin typeface="Inter"/>
-              </a:rPr>
-              <a:t>Validates predicted matches using parent-child hierarchical checks and </a:t>
-            </a:r>
-            <a:r>
-              <a:rPr b="0" i="0" u="none" dirty="0" err="1">
-                <a:solidFill>
-                  <a:srgbClr val="475569"/>
-                </a:solidFill>
-                <a:latin typeface="Inter"/>
-              </a:rPr>
-              <a:t>bisimilarity</a:t>
-            </a:r>
-            <a:r>
-              <a:rPr b="0" i="0" u="none" dirty="0">
-                <a:solidFill>
-                  <a:srgbClr val="475569"/>
-                </a:solidFill>
-                <a:latin typeface="Inter"/>
-              </a:rPr>
-              <a:t> properties.</a:t>
+              <a:rPr sz="2000" b="0" i="0" u="none" dirty="0">
+                <a:solidFill>
+                  <a:srgbClr val="E2E8F0"/>
+                </a:solidFill>
+                <a:latin typeface="Inter"/>
+              </a:rPr>
+              <a:t>Investigate how </a:t>
+            </a:r>
+            <a:r>
+              <a:rPr sz="2000" b="1" i="0" u="none" dirty="0">
+                <a:solidFill>
+                  <a:srgbClr val="E2E8F0"/>
+                </a:solidFill>
+                <a:latin typeface="Inter"/>
+              </a:rPr>
+              <a:t>external retrieval</a:t>
+            </a:r>
+            <a:r>
+              <a:rPr sz="2000" b="0" i="0" u="none" dirty="0">
+                <a:solidFill>
+                  <a:srgbClr val="E2E8F0"/>
+                </a:solidFill>
+                <a:latin typeface="Inter"/>
+              </a:rPr>
+              <a:t>, </a:t>
+            </a:r>
+            <a:r>
+              <a:rPr sz="2000" b="1" i="0" u="none" dirty="0">
+                <a:solidFill>
+                  <a:srgbClr val="E2E8F0"/>
+                </a:solidFill>
+                <a:latin typeface="Inter"/>
+              </a:rPr>
+              <a:t>semantic context</a:t>
+            </a:r>
+            <a:r>
+              <a:rPr sz="2000" b="0" i="0" u="none" dirty="0">
+                <a:solidFill>
+                  <a:srgbClr val="E2E8F0"/>
+                </a:solidFill>
+                <a:latin typeface="Inter"/>
+              </a:rPr>
+              <a:t> and </a:t>
+            </a:r>
+            <a:r>
+              <a:rPr sz="2000" b="1" i="0" u="none" dirty="0">
+                <a:solidFill>
+                  <a:srgbClr val="E2E8F0"/>
+                </a:solidFill>
+                <a:latin typeface="Inter"/>
+              </a:rPr>
+              <a:t>structural validation</a:t>
+            </a:r>
+            <a:r>
+              <a:rPr sz="2000" b="0" i="0" u="none" dirty="0">
+                <a:solidFill>
+                  <a:srgbClr val="E2E8F0"/>
+                </a:solidFill>
+                <a:latin typeface="Inter"/>
+              </a:rPr>
+              <a:t> refine LLM-based entity matching.</a:t>
             </a:r>
           </a:p>
         </p:txBody>
       </p:sp>
     </p:spTree>
+    <p:extLst>
+      <p:ext uri="{BB962C8B-B14F-4D97-AF65-F5344CB8AC3E}">
+        <p14:creationId xmlns:p14="http://schemas.microsoft.com/office/powerpoint/2010/main" val="506185629"/>
+      </p:ext>
+    </p:extLst>
   </p:cSld>
   <p:clrMapOvr>
     <a:masterClrMapping/>
@@ -5125,21 +4756,27 @@
       </p:grpSpPr>
       <p:sp>
         <p:nvSpPr>
-          <p:cNvPr id="2" name="Rectangle 1"/>
+          <p:cNvPr id="2" name="Rounded Rectangle 1"/>
           <p:cNvSpPr/>
           <p:nvPr/>
         </p:nvSpPr>
         <p:spPr>
           <a:xfrm>
-            <a:off x="609600" y="6076950"/>
-            <a:ext cx="10972800" cy="323850"/>
-          </a:xfrm>
-          <a:prstGeom prst="rect">
-            <a:avLst/>
-          </a:prstGeom>
-          <a:noFill/>
-          <a:ln>
-            <a:noFill/>
+            <a:off x="609600" y="5715000"/>
+            <a:ext cx="10972800" cy="685800"/>
+          </a:xfrm>
+          <a:prstGeom prst="roundRect">
+            <a:avLst>
+              <a:gd name="adj" fmla="val 13888"/>
+            </a:avLst>
+          </a:prstGeom>
+          <a:solidFill>
+            <a:srgbClr val="FFFBE0"/>
+          </a:solidFill>
+          <a:ln w="9525">
+            <a:solidFill>
+              <a:srgbClr val="FDE047"/>
+            </a:solidFill>
           </a:ln>
           <a:effectLst/>
         </p:spPr>
@@ -5168,26 +4805,26 @@
       </p:sp>
       <p:sp>
         <p:nvSpPr>
-          <p:cNvPr id="3" name="Rounded Rectangle 2"/>
+          <p:cNvPr id="4" name="Rounded Rectangle 3"/>
           <p:cNvSpPr/>
           <p:nvPr/>
         </p:nvSpPr>
         <p:spPr>
           <a:xfrm>
-            <a:off x="609600" y="2475607"/>
-            <a:ext cx="4690169" cy="2192535"/>
+            <a:off x="609600" y="2200275"/>
+            <a:ext cx="2600325" cy="3352800"/>
           </a:xfrm>
           <a:prstGeom prst="roundRect">
             <a:avLst>
-              <a:gd name="adj" fmla="val 6950"/>
+              <a:gd name="adj" fmla="val 4395"/>
             </a:avLst>
           </a:prstGeom>
           <a:solidFill>
-            <a:srgbClr val="F0F9FF"/>
+            <a:srgbClr val="F8FAFC"/>
           </a:solidFill>
           <a:ln w="9525">
             <a:solidFill>
-              <a:srgbClr val="BAE6FD"/>
+              <a:srgbClr val="E2E8F0"/>
             </a:solidFill>
           </a:ln>
           <a:effectLst/>
@@ -5217,23 +4854,27 @@
       </p:sp>
       <p:sp>
         <p:nvSpPr>
-          <p:cNvPr id="4" name="Rectangle 3"/>
+          <p:cNvPr id="5" name="Rounded Rectangle 4"/>
           <p:cNvSpPr/>
           <p:nvPr/>
         </p:nvSpPr>
         <p:spPr>
           <a:xfrm>
-            <a:off x="609600" y="6076950"/>
-            <a:ext cx="10972800" cy="9525"/>
-          </a:xfrm>
-          <a:prstGeom prst="rect">
-            <a:avLst/>
+            <a:off x="3400425" y="2200275"/>
+            <a:ext cx="2600325" cy="3352800"/>
+          </a:xfrm>
+          <a:prstGeom prst="roundRect">
+            <a:avLst>
+              <a:gd name="adj" fmla="val 4395"/>
+            </a:avLst>
           </a:prstGeom>
           <a:solidFill>
-            <a:srgbClr val="E2E8F0"/>
+            <a:srgbClr val="F8FAFC"/>
           </a:solidFill>
-          <a:ln>
-            <a:noFill/>
+          <a:ln w="9525">
+            <a:solidFill>
+              <a:srgbClr val="E2E8F0"/>
+            </a:solidFill>
           </a:ln>
           <a:effectLst/>
         </p:spPr>
@@ -5262,23 +4903,27 @@
       </p:sp>
       <p:sp>
         <p:nvSpPr>
-          <p:cNvPr id="5" name="Rectangle 4"/>
+          <p:cNvPr id="6" name="Rounded Rectangle 5"/>
           <p:cNvSpPr/>
           <p:nvPr/>
         </p:nvSpPr>
         <p:spPr>
           <a:xfrm>
-            <a:off x="5591249" y="1827752"/>
-            <a:ext cx="5977830" cy="1063942"/>
-          </a:xfrm>
-          <a:prstGeom prst="rect">
-            <a:avLst/>
+            <a:off x="6191250" y="2200275"/>
+            <a:ext cx="2600325" cy="3352800"/>
+          </a:xfrm>
+          <a:prstGeom prst="roundRect">
+            <a:avLst>
+              <a:gd name="adj" fmla="val 4395"/>
+            </a:avLst>
           </a:prstGeom>
           <a:solidFill>
             <a:srgbClr val="F8FAFC"/>
           </a:solidFill>
-          <a:ln>
-            <a:noFill/>
+          <a:ln w="9525">
+            <a:solidFill>
+              <a:srgbClr val="E2E8F0"/>
+            </a:solidFill>
           </a:ln>
           <a:effectLst/>
         </p:spPr>
@@ -5307,23 +4952,27 @@
       </p:sp>
       <p:sp>
         <p:nvSpPr>
-          <p:cNvPr id="6" name="Rectangle 5"/>
+          <p:cNvPr id="7" name="Rounded Rectangle 6"/>
           <p:cNvSpPr/>
           <p:nvPr/>
         </p:nvSpPr>
         <p:spPr>
           <a:xfrm>
-            <a:off x="5591250" y="3045998"/>
-            <a:ext cx="5977830" cy="1000126"/>
-          </a:xfrm>
-          <a:prstGeom prst="rect">
-            <a:avLst/>
+            <a:off x="8982075" y="2200275"/>
+            <a:ext cx="2600325" cy="3352800"/>
+          </a:xfrm>
+          <a:prstGeom prst="roundRect">
+            <a:avLst>
+              <a:gd name="adj" fmla="val 4395"/>
+            </a:avLst>
           </a:prstGeom>
           <a:solidFill>
             <a:srgbClr val="F8FAFC"/>
           </a:solidFill>
-          <a:ln>
-            <a:noFill/>
+          <a:ln w="9525">
+            <a:solidFill>
+              <a:srgbClr val="E2E8F0"/>
+            </a:solidFill>
           </a:ln>
           <a:effectLst/>
         </p:spPr>
@@ -5352,23 +5001,27 @@
       </p:sp>
       <p:sp>
         <p:nvSpPr>
-          <p:cNvPr id="7" name="Rectangle 6"/>
+          <p:cNvPr id="8" name="Rounded Rectangle 7"/>
           <p:cNvSpPr/>
           <p:nvPr/>
         </p:nvSpPr>
         <p:spPr>
           <a:xfrm>
-            <a:off x="5591250" y="4196619"/>
-            <a:ext cx="5977830" cy="1047750"/>
-          </a:xfrm>
-          <a:prstGeom prst="rect">
-            <a:avLst/>
+            <a:off x="847725" y="5122920"/>
+            <a:ext cx="2124075" cy="285750"/>
+          </a:xfrm>
+          <a:prstGeom prst="roundRect">
+            <a:avLst>
+              <a:gd name="adj" fmla="val 20000"/>
+            </a:avLst>
           </a:prstGeom>
           <a:solidFill>
-            <a:srgbClr val="FEF2F2"/>
+            <a:srgbClr val="FFFFFF"/>
           </a:solidFill>
-          <a:ln>
-            <a:noFill/>
+          <a:ln w="9525">
+            <a:solidFill>
+              <a:srgbClr val="E2E8F0"/>
+            </a:solidFill>
           </a:ln>
           <a:effectLst/>
         </p:spPr>
@@ -5397,23 +5050,27 @@
       </p:sp>
       <p:sp>
         <p:nvSpPr>
-          <p:cNvPr id="8" name="Rectangle 7"/>
+          <p:cNvPr id="9" name="Rounded Rectangle 8"/>
           <p:cNvSpPr/>
           <p:nvPr/>
         </p:nvSpPr>
         <p:spPr>
           <a:xfrm>
-            <a:off x="5591249" y="1827752"/>
-            <a:ext cx="38100" cy="895350"/>
-          </a:xfrm>
-          <a:prstGeom prst="rect">
-            <a:avLst/>
+            <a:off x="3638550" y="5122920"/>
+            <a:ext cx="2124075" cy="285750"/>
+          </a:xfrm>
+          <a:prstGeom prst="roundRect">
+            <a:avLst>
+              <a:gd name="adj" fmla="val 20000"/>
+            </a:avLst>
           </a:prstGeom>
           <a:solidFill>
-            <a:srgbClr val="0284C7"/>
+            <a:srgbClr val="FFFFFF"/>
           </a:solidFill>
-          <a:ln>
-            <a:noFill/>
+          <a:ln w="9525">
+            <a:solidFill>
+              <a:srgbClr val="E2E8F0"/>
+            </a:solidFill>
           </a:ln>
           <a:effectLst/>
         </p:spPr>
@@ -5442,23 +5099,27 @@
       </p:sp>
       <p:sp>
         <p:nvSpPr>
-          <p:cNvPr id="9" name="Rectangle 8"/>
+          <p:cNvPr id="10" name="Rounded Rectangle 9"/>
           <p:cNvSpPr/>
           <p:nvPr/>
         </p:nvSpPr>
         <p:spPr>
           <a:xfrm>
-            <a:off x="5591250" y="3029806"/>
-            <a:ext cx="38100" cy="895350"/>
-          </a:xfrm>
-          <a:prstGeom prst="rect">
-            <a:avLst/>
+            <a:off x="6429375" y="5122920"/>
+            <a:ext cx="2124075" cy="285750"/>
+          </a:xfrm>
+          <a:prstGeom prst="roundRect">
+            <a:avLst>
+              <a:gd name="adj" fmla="val 20000"/>
+            </a:avLst>
           </a:prstGeom>
           <a:solidFill>
-            <a:srgbClr val="0284C7"/>
+            <a:srgbClr val="FFFFFF"/>
           </a:solidFill>
-          <a:ln>
-            <a:noFill/>
+          <a:ln w="9525">
+            <a:solidFill>
+              <a:srgbClr val="E2E8F0"/>
+            </a:solidFill>
           </a:ln>
           <a:effectLst/>
         </p:spPr>
@@ -5487,23 +5148,27 @@
       </p:sp>
       <p:sp>
         <p:nvSpPr>
-          <p:cNvPr id="10" name="Rectangle 9"/>
+          <p:cNvPr id="11" name="Rounded Rectangle 10"/>
           <p:cNvSpPr/>
           <p:nvPr/>
         </p:nvSpPr>
         <p:spPr>
           <a:xfrm>
-            <a:off x="5591250" y="4196619"/>
-            <a:ext cx="38100" cy="895350"/>
-          </a:xfrm>
-          <a:prstGeom prst="rect">
-            <a:avLst/>
+            <a:off x="9220200" y="5122920"/>
+            <a:ext cx="2124075" cy="285750"/>
+          </a:xfrm>
+          <a:prstGeom prst="roundRect">
+            <a:avLst>
+              <a:gd name="adj" fmla="val 20000"/>
+            </a:avLst>
           </a:prstGeom>
           <a:solidFill>
-            <a:srgbClr val="EF4444"/>
+            <a:srgbClr val="FFFFFF"/>
           </a:solidFill>
-          <a:ln>
-            <a:noFill/>
+          <a:ln w="9525">
+            <a:solidFill>
+              <a:srgbClr val="E2E8F0"/>
+            </a:solidFill>
           </a:ln>
           <a:effectLst/>
         </p:spPr>
@@ -5530,230 +5195,232 @@
           </a:p>
         </p:txBody>
       </p:sp>
-      <p:sp>
-        <p:nvSpPr>
-          <p:cNvPr id="11" name="TextBox 10"/>
+      <p:pic>
+        <p:nvPicPr>
+          <p:cNvPr id="12" name="Picture 11" descr="image.png"/>
+          <p:cNvPicPr>
+            <a:picLocks noChangeAspect="1"/>
+          </p:cNvPicPr>
+          <p:nvPr/>
+        </p:nvPicPr>
+        <p:blipFill>
+          <a:blip r:embed="rId2"/>
+          <a:stretch>
+            <a:fillRect/>
+          </a:stretch>
+        </p:blipFill>
+        <p:spPr>
+          <a:xfrm>
+            <a:off x="847725" y="5962650"/>
+            <a:ext cx="142875" cy="190500"/>
+          </a:xfrm>
+          <a:prstGeom prst="rect">
+            <a:avLst/>
+          </a:prstGeom>
+        </p:spPr>
+      </p:pic>
+      <p:pic>
+        <p:nvPicPr>
+          <p:cNvPr id="13" name="Picture 12" descr="image.png"/>
+          <p:cNvPicPr>
+            <a:picLocks noChangeAspect="1"/>
+          </p:cNvPicPr>
+          <p:nvPr/>
+        </p:nvPicPr>
+        <p:blipFill>
+          <a:blip r:embed="rId3"/>
+          <a:stretch>
+            <a:fillRect/>
+          </a:stretch>
+        </p:blipFill>
+        <p:spPr>
+          <a:xfrm>
+            <a:off x="847725" y="2438400"/>
+            <a:ext cx="381000" cy="381000"/>
+          </a:xfrm>
+          <a:prstGeom prst="rect">
+            <a:avLst/>
+          </a:prstGeom>
+        </p:spPr>
+      </p:pic>
+      <p:pic>
+        <p:nvPicPr>
+          <p:cNvPr id="14" name="Picture 13" descr="image.png"/>
+          <p:cNvPicPr>
+            <a:picLocks noChangeAspect="1"/>
+          </p:cNvPicPr>
+          <p:nvPr/>
+        </p:nvPicPr>
+        <p:blipFill>
+          <a:blip r:embed="rId4"/>
+          <a:stretch>
+            <a:fillRect/>
+          </a:stretch>
+        </p:blipFill>
+        <p:spPr>
+          <a:xfrm>
+            <a:off x="3638550" y="2438400"/>
+            <a:ext cx="381000" cy="381000"/>
+          </a:xfrm>
+          <a:prstGeom prst="rect">
+            <a:avLst/>
+          </a:prstGeom>
+        </p:spPr>
+      </p:pic>
+      <p:pic>
+        <p:nvPicPr>
+          <p:cNvPr id="15" name="Picture 14" descr="image.png"/>
+          <p:cNvPicPr>
+            <a:picLocks noChangeAspect="1"/>
+          </p:cNvPicPr>
+          <p:nvPr/>
+        </p:nvPicPr>
+        <p:blipFill>
+          <a:blip r:embed="rId3"/>
+          <a:stretch>
+            <a:fillRect/>
+          </a:stretch>
+        </p:blipFill>
+        <p:spPr>
+          <a:xfrm>
+            <a:off x="6429375" y="2438400"/>
+            <a:ext cx="381000" cy="381000"/>
+          </a:xfrm>
+          <a:prstGeom prst="rect">
+            <a:avLst/>
+          </a:prstGeom>
+        </p:spPr>
+      </p:pic>
+      <p:pic>
+        <p:nvPicPr>
+          <p:cNvPr id="16" name="Picture 15" descr="image.png"/>
+          <p:cNvPicPr>
+            <a:picLocks noChangeAspect="1"/>
+          </p:cNvPicPr>
+          <p:nvPr/>
+        </p:nvPicPr>
+        <p:blipFill>
+          <a:blip r:embed="rId4"/>
+          <a:stretch>
+            <a:fillRect/>
+          </a:stretch>
+        </p:blipFill>
+        <p:spPr>
+          <a:xfrm>
+            <a:off x="9220200" y="2438400"/>
+            <a:ext cx="381000" cy="381000"/>
+          </a:xfrm>
+          <a:prstGeom prst="rect">
+            <a:avLst/>
+          </a:prstGeom>
+        </p:spPr>
+      </p:pic>
+      <p:pic>
+        <p:nvPicPr>
+          <p:cNvPr id="17" name="Picture 16" descr="image.png"/>
+          <p:cNvPicPr>
+            <a:picLocks noChangeAspect="1"/>
+          </p:cNvPicPr>
+          <p:nvPr/>
+        </p:nvPicPr>
+        <p:blipFill>
+          <a:blip r:embed="rId5"/>
+          <a:stretch>
+            <a:fillRect/>
+          </a:stretch>
+        </p:blipFill>
+        <p:spPr>
+          <a:xfrm>
+            <a:off x="962025" y="2543175"/>
+            <a:ext cx="152400" cy="171450"/>
+          </a:xfrm>
+          <a:prstGeom prst="rect">
+            <a:avLst/>
+          </a:prstGeom>
+        </p:spPr>
+      </p:pic>
+      <p:pic>
+        <p:nvPicPr>
+          <p:cNvPr id="18" name="Picture 17" descr="image.png"/>
+          <p:cNvPicPr>
+            <a:picLocks noChangeAspect="1"/>
+          </p:cNvPicPr>
+          <p:nvPr/>
+        </p:nvPicPr>
+        <p:blipFill>
+          <a:blip r:embed="rId6"/>
+          <a:stretch>
+            <a:fillRect/>
+          </a:stretch>
+        </p:blipFill>
+        <p:spPr>
+          <a:xfrm>
+            <a:off x="3733800" y="2543175"/>
+            <a:ext cx="190500" cy="171450"/>
+          </a:xfrm>
+          <a:prstGeom prst="rect">
+            <a:avLst/>
+          </a:prstGeom>
+        </p:spPr>
+      </p:pic>
+      <p:pic>
+        <p:nvPicPr>
+          <p:cNvPr id="19" name="Picture 18" descr="image.png"/>
+          <p:cNvPicPr>
+            <a:picLocks noChangeAspect="1"/>
+          </p:cNvPicPr>
+          <p:nvPr/>
+        </p:nvPicPr>
+        <p:blipFill>
+          <a:blip r:embed="rId7"/>
+          <a:stretch>
+            <a:fillRect/>
+          </a:stretch>
+        </p:blipFill>
+        <p:spPr>
+          <a:xfrm>
+            <a:off x="6534150" y="2543175"/>
+            <a:ext cx="171450" cy="171450"/>
+          </a:xfrm>
+          <a:prstGeom prst="rect">
+            <a:avLst/>
+          </a:prstGeom>
+        </p:spPr>
+      </p:pic>
+      <p:pic>
+        <p:nvPicPr>
+          <p:cNvPr id="20" name="Picture 19" descr="image.png"/>
+          <p:cNvPicPr>
+            <a:picLocks noChangeAspect="1"/>
+          </p:cNvPicPr>
+          <p:nvPr/>
+        </p:nvPicPr>
+        <p:blipFill>
+          <a:blip r:embed="rId8"/>
+          <a:stretch>
+            <a:fillRect/>
+          </a:stretch>
+        </p:blipFill>
+        <p:spPr>
+          <a:xfrm>
+            <a:off x="9315450" y="2543175"/>
+            <a:ext cx="190500" cy="171450"/>
+          </a:xfrm>
+          <a:prstGeom prst="rect">
+            <a:avLst/>
+          </a:prstGeom>
+        </p:spPr>
+      </p:pic>
+      <p:sp>
+        <p:nvSpPr>
+          <p:cNvPr id="22" name="TextBox 21"/>
           <p:cNvSpPr txBox="1"/>
           <p:nvPr/>
         </p:nvSpPr>
         <p:spPr>
           <a:xfrm>
-            <a:off x="609600" y="457200"/>
-            <a:ext cx="11582400" cy="171450"/>
-          </a:xfrm>
-          <a:prstGeom prst="rect">
-            <a:avLst/>
-          </a:prstGeom>
-          <a:noFill/>
-        </p:spPr>
-        <p:txBody>
-          <a:bodyPr wrap="none" lIns="0" tIns="0" rIns="0" bIns="0" anchor="t">
-            <a:spAutoFit/>
-          </a:bodyPr>
-          <a:lstStyle/>
-          <a:p>
-            <a:pPr algn="l"/>
-            <a:r>
-              <a:rPr sz="1050" b="1" i="0" u="none">
-                <a:solidFill>
-                  <a:srgbClr val="0284C7"/>
-                </a:solidFill>
-                <a:latin typeface="Space Grotesk"/>
-              </a:rPr>
-              <a:t>PAPER ANALYSIS • KEY FINDINGS</a:t>
-            </a:r>
-          </a:p>
-        </p:txBody>
-      </p:sp>
-      <p:sp>
-        <p:nvSpPr>
-          <p:cNvPr id="12" name="TextBox 11"/>
-          <p:cNvSpPr txBox="1"/>
-          <p:nvPr/>
-        </p:nvSpPr>
-        <p:spPr>
-          <a:xfrm>
-            <a:off x="609600" y="685800"/>
-            <a:ext cx="11582400" cy="381000"/>
-          </a:xfrm>
-          <a:prstGeom prst="rect">
-            <a:avLst/>
-          </a:prstGeom>
-          <a:noFill/>
-        </p:spPr>
-        <p:txBody>
-          <a:bodyPr wrap="none" lIns="0" tIns="0" rIns="0" bIns="0" anchor="t">
-            <a:spAutoFit/>
-          </a:bodyPr>
-          <a:lstStyle/>
-          <a:p>
-            <a:pPr algn="l"/>
-            <a:r>
-              <a:rPr sz="2400" b="1" i="0" u="none">
-                <a:solidFill>
-                  <a:srgbClr val="0F172A"/>
-                </a:solidFill>
-                <a:latin typeface="Space Grotesk"/>
-              </a:rPr>
-              <a:t>KROMA: Empirical Performance &amp; Insights</a:t>
-            </a:r>
-          </a:p>
-        </p:txBody>
-      </p:sp>
-      <p:sp>
-        <p:nvSpPr>
-          <p:cNvPr id="13" name="TextBox 12"/>
-          <p:cNvSpPr txBox="1"/>
-          <p:nvPr/>
-        </p:nvSpPr>
-        <p:spPr>
-          <a:xfrm>
-            <a:off x="609600" y="6238875"/>
-            <a:ext cx="4262437" cy="161925"/>
-          </a:xfrm>
-          <a:prstGeom prst="rect">
-            <a:avLst/>
-          </a:prstGeom>
-          <a:noFill/>
-        </p:spPr>
-        <p:txBody>
-          <a:bodyPr wrap="none" lIns="0" tIns="0" rIns="0" bIns="0" anchor="t">
-            <a:spAutoFit/>
-          </a:bodyPr>
-          <a:lstStyle/>
-          <a:p>
-            <a:pPr algn="l"/>
-            <a:r>
-              <a:rPr sz="1050" b="0" i="0" u="none" dirty="0">
-                <a:solidFill>
-                  <a:srgbClr val="64748B"/>
-                </a:solidFill>
-                <a:latin typeface="Inter"/>
-              </a:rPr>
-              <a:t>Source: Nguyen et al. (2025) experimental evaluations</a:t>
-            </a:r>
-          </a:p>
-        </p:txBody>
-      </p:sp>
-      <p:sp>
-        <p:nvSpPr>
-          <p:cNvPr id="14" name="TextBox 13"/>
-          <p:cNvSpPr txBox="1"/>
-          <p:nvPr/>
-        </p:nvSpPr>
-        <p:spPr>
-          <a:xfrm>
-            <a:off x="10125075" y="6238875"/>
-            <a:ext cx="1821656" cy="161925"/>
-          </a:xfrm>
-          <a:prstGeom prst="rect">
-            <a:avLst/>
-          </a:prstGeom>
-          <a:noFill/>
-        </p:spPr>
-        <p:txBody>
-          <a:bodyPr wrap="none" lIns="0" tIns="0" rIns="0" bIns="0" anchor="t">
-            <a:spAutoFit/>
-          </a:bodyPr>
-          <a:lstStyle/>
-          <a:p>
-            <a:pPr algn="l"/>
-            <a:r>
-              <a:rPr sz="1050" b="1" i="0" u="none">
-                <a:solidFill>
-                  <a:srgbClr val="0F172A"/>
-                </a:solidFill>
-                <a:latin typeface="Inter"/>
-              </a:rPr>
-              <a:t>OAEI Benchmark Suite</a:t>
-            </a:r>
-          </a:p>
-        </p:txBody>
-      </p:sp>
-      <p:sp>
-        <p:nvSpPr>
-          <p:cNvPr id="15" name="TextBox 14"/>
-          <p:cNvSpPr txBox="1"/>
-          <p:nvPr/>
-        </p:nvSpPr>
-        <p:spPr>
-          <a:xfrm>
-            <a:off x="463860" y="2828032"/>
-            <a:ext cx="4981649" cy="685800"/>
-          </a:xfrm>
-          <a:prstGeom prst="rect">
-            <a:avLst/>
-          </a:prstGeom>
-          <a:noFill/>
-        </p:spPr>
-        <p:txBody>
-          <a:bodyPr wrap="none" lIns="0" tIns="0" rIns="0" bIns="0" anchor="t">
-            <a:spAutoFit/>
-          </a:bodyPr>
-          <a:lstStyle/>
-          <a:p>
-            <a:pPr algn="ctr">
-              <a:lnSpc>
-                <a:spcPts val="5400"/>
-              </a:lnSpc>
-            </a:pPr>
-            <a:r>
-              <a:rPr sz="5400" b="1" i="0" u="none">
-                <a:solidFill>
-                  <a:srgbClr val="0284C7"/>
-                </a:solidFill>
-                <a:latin typeface="Space Grotesk"/>
-              </a:rPr>
-              <a:t>+10.95%</a:t>
-            </a:r>
-          </a:p>
-        </p:txBody>
-      </p:sp>
-      <p:sp>
-        <p:nvSpPr>
-          <p:cNvPr id="16" name="TextBox 15"/>
-          <p:cNvSpPr txBox="1"/>
-          <p:nvPr/>
-        </p:nvSpPr>
-        <p:spPr>
-          <a:xfrm>
-            <a:off x="1682733" y="3527732"/>
-            <a:ext cx="2543902" cy="276999"/>
-          </a:xfrm>
-          <a:prstGeom prst="rect">
-            <a:avLst/>
-          </a:prstGeom>
-          <a:noFill/>
-        </p:spPr>
-        <p:txBody>
-          <a:bodyPr wrap="none" lIns="0" tIns="0" rIns="0" bIns="0" anchor="t">
-            <a:spAutoFit/>
-          </a:bodyPr>
-          <a:lstStyle/>
-          <a:p>
-            <a:pPr algn="ctr"/>
-            <a:r>
-              <a:rPr b="1" i="0" u="none" dirty="0">
-                <a:solidFill>
-                  <a:srgbClr val="0F172A"/>
-                </a:solidFill>
-                <a:latin typeface="Inter"/>
-              </a:rPr>
-              <a:t>Average Performance Gain</a:t>
-            </a:r>
-          </a:p>
-        </p:txBody>
-      </p:sp>
-      <p:sp>
-        <p:nvSpPr>
-          <p:cNvPr id="17" name="TextBox 16"/>
-          <p:cNvSpPr txBox="1"/>
-          <p:nvPr/>
-        </p:nvSpPr>
-        <p:spPr>
-          <a:xfrm>
-            <a:off x="463860" y="3942457"/>
-            <a:ext cx="4981649" cy="397545"/>
+            <a:off x="1143000" y="5876925"/>
+            <a:ext cx="10296525" cy="361950"/>
           </a:xfrm>
           <a:prstGeom prst="rect">
             <a:avLst/>
@@ -5766,80 +5433,38 @@
           </a:bodyPr>
           <a:lstStyle/>
           <a:p>
-            <a:pPr algn="ctr">
-              <a:lnSpc>
-                <a:spcPts val="1470"/>
-              </a:lnSpc>
-            </a:pPr>
-            <a:r>
-              <a:rPr b="0" i="0" u="none" dirty="0">
-                <a:solidFill>
-                  <a:srgbClr val="475569"/>
-                </a:solidFill>
-                <a:latin typeface="Inter"/>
-              </a:rPr>
-              <a:t>Outperforms existing LLM-based matching frameworks on standard OAEI benchmarks.</a:t>
-            </a:r>
-          </a:p>
-        </p:txBody>
-      </p:sp>
-      <p:sp>
-        <p:nvSpPr>
-          <p:cNvPr id="25" name="TextBox 24">
-            <a:extLst>
-              <a:ext uri="{FF2B5EF4-FFF2-40B4-BE49-F238E27FC236}">
-                <a16:creationId xmlns:a16="http://schemas.microsoft.com/office/drawing/2014/main" id="{B8B7735F-1AA8-4A22-7D67-1D8E4861C585}"/>
-              </a:ext>
-            </a:extLst>
-          </p:cNvPr>
+            <a:pPr algn="l"/>
+            <a:r>
+              <a:rPr sz="1125" b="1" i="0" u="none">
+                <a:solidFill>
+                  <a:srgbClr val="854D0E"/>
+                </a:solidFill>
+                <a:latin typeface="Inter"/>
+              </a:rPr>
+              <a:t>Core Architecture Principle:</a:t>
+            </a:r>
+            <a:r>
+              <a:rPr sz="1125" b="0" i="0" u="none">
+                <a:solidFill>
+                  <a:srgbClr val="854D0E"/>
+                </a:solidFill>
+                <a:latin typeface="Inter"/>
+              </a:rPr>
+              <a:t> Embeddings isolate candidate search space; structural post-processing guarantees graph logic consistency without increasing LLM prompt overhead.</a:t>
+            </a:r>
+          </a:p>
+        </p:txBody>
+      </p:sp>
+      <p:sp>
+        <p:nvSpPr>
+          <p:cNvPr id="23" name="TextBox 22"/>
           <p:cNvSpPr txBox="1"/>
           <p:nvPr/>
         </p:nvSpPr>
         <p:spPr>
           <a:xfrm>
-            <a:off x="5736989" y="1989677"/>
-            <a:ext cx="2701702" cy="246221"/>
-          </a:xfrm>
-          <a:prstGeom prst="rect">
-            <a:avLst/>
-          </a:prstGeom>
-          <a:noFill/>
-        </p:spPr>
-        <p:txBody>
-          <a:bodyPr wrap="none" lIns="0" tIns="0" rIns="0" bIns="0" anchor="t">
-            <a:spAutoFit/>
-          </a:bodyPr>
-          <a:lstStyle/>
-          <a:p>
-            <a:pPr algn="l"/>
-            <a:r>
-              <a:rPr sz="1600" b="1" i="0" u="none" dirty="0">
-                <a:solidFill>
-                  <a:srgbClr val="1F2937"/>
-                </a:solidFill>
-                <a:latin typeface="Inter"/>
-              </a:rPr>
-              <a:t>Retrieval &amp; Refinement Synergy</a:t>
-            </a:r>
-          </a:p>
-        </p:txBody>
-      </p:sp>
-      <p:sp>
-        <p:nvSpPr>
-          <p:cNvPr id="27" name="TextBox 26">
-            <a:extLst>
-              <a:ext uri="{FF2B5EF4-FFF2-40B4-BE49-F238E27FC236}">
-                <a16:creationId xmlns:a16="http://schemas.microsoft.com/office/drawing/2014/main" id="{D2FCF090-1E96-13E2-310A-93311D82E09B}"/>
-              </a:ext>
-            </a:extLst>
-          </p:cNvPr>
-          <p:cNvSpPr txBox="1"/>
-          <p:nvPr/>
-        </p:nvSpPr>
-        <p:spPr>
-          <a:xfrm>
-            <a:off x="5736989" y="2227802"/>
-            <a:ext cx="4868167" cy="492443"/>
+            <a:off x="609600" y="625220"/>
+            <a:ext cx="10972800" cy="1231106"/>
           </a:xfrm>
           <a:prstGeom prst="rect">
             <a:avLst/>
@@ -5852,76 +5477,47 @@
           </a:bodyPr>
           <a:lstStyle/>
           <a:p>
-            <a:pPr algn="l"/>
-            <a:r>
-              <a:rPr sz="1600" b="0" i="0" u="none" dirty="0">
-                <a:solidFill>
-                  <a:srgbClr val="4B5563"/>
-                </a:solidFill>
-                <a:latin typeface="Inter"/>
-              </a:rPr>
-              <a:t>Both external knowledge integration and parent-child validation directly boost accuracy.</a:t>
-            </a:r>
-          </a:p>
-        </p:txBody>
-      </p:sp>
-      <p:sp>
-        <p:nvSpPr>
-          <p:cNvPr id="29" name="TextBox 28">
-            <a:extLst>
-              <a:ext uri="{FF2B5EF4-FFF2-40B4-BE49-F238E27FC236}">
-                <a16:creationId xmlns:a16="http://schemas.microsoft.com/office/drawing/2014/main" id="{76D345E1-30EC-6272-B38F-576EA0111FDF}"/>
-              </a:ext>
-            </a:extLst>
-          </p:cNvPr>
+            <a:pPr algn="ctr"/>
+            <a:r>
+              <a:rPr lang="en-US" sz="4000" b="1" i="0" u="none" dirty="0">
+                <a:solidFill>
+                  <a:srgbClr val="0284C7"/>
+                </a:solidFill>
+                <a:latin typeface="Space Grotesk"/>
+              </a:rPr>
+              <a:t>KROMA: Ontology Matching with Knowledge</a:t>
+            </a:r>
+          </a:p>
+          <a:p>
+            <a:pPr algn="ctr"/>
+            <a:r>
+              <a:rPr lang="en-US" sz="4000" b="1" i="0" u="none" dirty="0">
+                <a:solidFill>
+                  <a:srgbClr val="0284C7"/>
+                </a:solidFill>
+                <a:latin typeface="Space Grotesk"/>
+              </a:rPr>
+              <a:t>Retrieval and Large Language Models</a:t>
+            </a:r>
+            <a:endParaRPr sz="4000" b="1" i="0" u="none" dirty="0">
+              <a:solidFill>
+                <a:srgbClr val="0284C7"/>
+              </a:solidFill>
+              <a:latin typeface="Space Grotesk"/>
+            </a:endParaRPr>
+          </a:p>
+        </p:txBody>
+      </p:sp>
+      <p:sp>
+        <p:nvSpPr>
+          <p:cNvPr id="25" name="TextBox 24"/>
           <p:cNvSpPr txBox="1"/>
           <p:nvPr/>
         </p:nvSpPr>
         <p:spPr>
           <a:xfrm>
-            <a:off x="5736990" y="3196493"/>
-            <a:ext cx="2092239" cy="246221"/>
-          </a:xfrm>
-          <a:prstGeom prst="rect">
-            <a:avLst/>
-          </a:prstGeom>
-          <a:noFill/>
-        </p:spPr>
-        <p:txBody>
-          <a:bodyPr wrap="none" lIns="0" tIns="0" rIns="0" bIns="0" anchor="t">
-            <a:spAutoFit/>
-          </a:bodyPr>
-          <a:lstStyle/>
-          <a:p>
-            <a:pPr algn="l"/>
-            <a:r>
-              <a:rPr sz="1600" b="1" i="0" u="none" dirty="0">
-                <a:solidFill>
-                  <a:srgbClr val="1F2937"/>
-                </a:solidFill>
-                <a:latin typeface="Inter"/>
-              </a:rPr>
-              <a:t>Computational Trade-off</a:t>
-            </a:r>
-          </a:p>
-        </p:txBody>
-      </p:sp>
-      <p:sp>
-        <p:nvSpPr>
-          <p:cNvPr id="31" name="TextBox 30">
-            <a:extLst>
-              <a:ext uri="{FF2B5EF4-FFF2-40B4-BE49-F238E27FC236}">
-                <a16:creationId xmlns:a16="http://schemas.microsoft.com/office/drawing/2014/main" id="{57632D59-7239-3A32-FC14-184A641FC034}"/>
-              </a:ext>
-            </a:extLst>
-          </p:cNvPr>
-          <p:cNvSpPr txBox="1"/>
-          <p:nvPr/>
-        </p:nvSpPr>
-        <p:spPr>
-          <a:xfrm>
-            <a:off x="5736990" y="3434618"/>
-            <a:ext cx="4868167" cy="492443"/>
+            <a:off x="942975" y="5180070"/>
+            <a:ext cx="2028825" cy="215444"/>
           </a:xfrm>
           <a:prstGeom prst="rect">
             <a:avLst/>
@@ -5936,74 +5532,27 @@
           <a:p>
             <a:pPr algn="l"/>
             <a:r>
-              <a:rPr sz="1600" b="0" i="0" u="none">
-                <a:solidFill>
-                  <a:srgbClr val="4B5563"/>
-                </a:solidFill>
-                <a:latin typeface="Inter"/>
-              </a:rPr>
-              <a:t>Multi-agent debate and extended reasoning increase costs without guaranteeing accuracy gains.</a:t>
-            </a:r>
-          </a:p>
-        </p:txBody>
-      </p:sp>
-      <p:sp>
-        <p:nvSpPr>
-          <p:cNvPr id="33" name="TextBox 32">
-            <a:extLst>
-              <a:ext uri="{FF2B5EF4-FFF2-40B4-BE49-F238E27FC236}">
-                <a16:creationId xmlns:a16="http://schemas.microsoft.com/office/drawing/2014/main" id="{B1D73212-2E02-0B96-04EC-568296888ACB}"/>
-              </a:ext>
-            </a:extLst>
-          </p:cNvPr>
+              <a:rPr sz="1400" b="0" i="0" u="none" dirty="0">
+                <a:solidFill>
+                  <a:srgbClr val="0284C7"/>
+                </a:solidFill>
+                <a:latin typeface="JetBrains Mono"/>
+              </a:rPr>
+              <a:t>Context Enrichment</a:t>
+            </a:r>
+          </a:p>
+        </p:txBody>
+      </p:sp>
+      <p:sp>
+        <p:nvSpPr>
+          <p:cNvPr id="26" name="TextBox 25"/>
           <p:cNvSpPr txBox="1"/>
           <p:nvPr/>
         </p:nvSpPr>
         <p:spPr>
           <a:xfrm>
-            <a:off x="5736990" y="4358544"/>
-            <a:ext cx="2561920" cy="246221"/>
-          </a:xfrm>
-          <a:prstGeom prst="rect">
-            <a:avLst/>
-          </a:prstGeom>
-          <a:noFill/>
-        </p:spPr>
-        <p:txBody>
-          <a:bodyPr wrap="none" lIns="0" tIns="0" rIns="0" bIns="0" anchor="t">
-            <a:spAutoFit/>
-          </a:bodyPr>
-          <a:lstStyle/>
-          <a:p>
-            <a:pPr algn="l"/>
-            <a:r>
-              <a:rPr sz="1600" b="1" i="0" u="none">
-                <a:solidFill>
-                  <a:srgbClr val="1F2937"/>
-                </a:solidFill>
-                <a:latin typeface="Inter"/>
-              </a:rPr>
-              <a:t>Specialized Domain Limitation</a:t>
-            </a:r>
-          </a:p>
-        </p:txBody>
-      </p:sp>
-      <p:sp>
-        <p:nvSpPr>
-          <p:cNvPr id="35" name="TextBox 34">
-            <a:extLst>
-              <a:ext uri="{FF2B5EF4-FFF2-40B4-BE49-F238E27FC236}">
-                <a16:creationId xmlns:a16="http://schemas.microsoft.com/office/drawing/2014/main" id="{862F728A-CFB1-8FB9-BC00-F6EF774F92EA}"/>
-              </a:ext>
-            </a:extLst>
-          </p:cNvPr>
-          <p:cNvSpPr txBox="1"/>
-          <p:nvPr/>
-        </p:nvSpPr>
-        <p:spPr>
-          <a:xfrm>
-            <a:off x="5736990" y="4596669"/>
-            <a:ext cx="4868167" cy="492443"/>
+            <a:off x="3733800" y="5180070"/>
+            <a:ext cx="2028825" cy="215444"/>
           </a:xfrm>
           <a:prstGeom prst="rect">
             <a:avLst/>
@@ -6018,13 +5567,433 @@
           <a:p>
             <a:pPr algn="l"/>
             <a:r>
-              <a:rPr sz="1600" b="0" i="0" u="none" dirty="0">
-                <a:solidFill>
-                  <a:srgbClr val="4B5563"/>
-                </a:solidFill>
-                <a:latin typeface="Inter"/>
-              </a:rPr>
-              <a:t>Performance drops in sparse knowledge domains like materials science.</a:t>
+              <a:rPr sz="1400" b="0" i="0" u="none">
+                <a:solidFill>
+                  <a:srgbClr val="0284C7"/>
+                </a:solidFill>
+                <a:latin typeface="JetBrains Mono"/>
+              </a:rPr>
+              <a:t>Text + Graph Embeddings</a:t>
+            </a:r>
+          </a:p>
+        </p:txBody>
+      </p:sp>
+      <p:sp>
+        <p:nvSpPr>
+          <p:cNvPr id="27" name="TextBox 26"/>
+          <p:cNvSpPr txBox="1"/>
+          <p:nvPr/>
+        </p:nvSpPr>
+        <p:spPr>
+          <a:xfrm>
+            <a:off x="6524625" y="5180070"/>
+            <a:ext cx="2028825" cy="215444"/>
+          </a:xfrm>
+          <a:prstGeom prst="rect">
+            <a:avLst/>
+          </a:prstGeom>
+          <a:noFill/>
+        </p:spPr>
+        <p:txBody>
+          <a:bodyPr wrap="square" lIns="0" tIns="0" rIns="0" bIns="0" anchor="t">
+            <a:spAutoFit/>
+          </a:bodyPr>
+          <a:lstStyle/>
+          <a:p>
+            <a:pPr algn="l"/>
+            <a:r>
+              <a:rPr sz="1400" b="0" i="0" u="none">
+                <a:solidFill>
+                  <a:srgbClr val="0284C7"/>
+                </a:solidFill>
+                <a:latin typeface="JetBrains Mono"/>
+              </a:rPr>
+              <a:t>Semantic Reasoning</a:t>
+            </a:r>
+          </a:p>
+        </p:txBody>
+      </p:sp>
+      <p:sp>
+        <p:nvSpPr>
+          <p:cNvPr id="28" name="TextBox 27"/>
+          <p:cNvSpPr txBox="1"/>
+          <p:nvPr/>
+        </p:nvSpPr>
+        <p:spPr>
+          <a:xfrm>
+            <a:off x="9315450" y="5180070"/>
+            <a:ext cx="2028825" cy="215444"/>
+          </a:xfrm>
+          <a:prstGeom prst="rect">
+            <a:avLst/>
+          </a:prstGeom>
+          <a:noFill/>
+        </p:spPr>
+        <p:txBody>
+          <a:bodyPr wrap="square" lIns="0" tIns="0" rIns="0" bIns="0" anchor="t">
+            <a:spAutoFit/>
+          </a:bodyPr>
+          <a:lstStyle/>
+          <a:p>
+            <a:pPr algn="l"/>
+            <a:r>
+              <a:rPr sz="1400" b="0" i="0" u="none">
+                <a:solidFill>
+                  <a:srgbClr val="0284C7"/>
+                </a:solidFill>
+                <a:latin typeface="JetBrains Mono"/>
+              </a:rPr>
+              <a:t>Hierarchy Consistency</a:t>
+            </a:r>
+          </a:p>
+        </p:txBody>
+      </p:sp>
+      <p:sp>
+        <p:nvSpPr>
+          <p:cNvPr id="29" name="TextBox 28"/>
+          <p:cNvSpPr txBox="1"/>
+          <p:nvPr/>
+        </p:nvSpPr>
+        <p:spPr>
+          <a:xfrm>
+            <a:off x="847725" y="2933700"/>
+            <a:ext cx="2219325" cy="276999"/>
+          </a:xfrm>
+          <a:prstGeom prst="rect">
+            <a:avLst/>
+          </a:prstGeom>
+          <a:noFill/>
+        </p:spPr>
+        <p:txBody>
+          <a:bodyPr wrap="square" lIns="0" tIns="0" rIns="0" bIns="0" anchor="t">
+            <a:spAutoFit/>
+          </a:bodyPr>
+          <a:lstStyle/>
+          <a:p>
+            <a:pPr algn="l"/>
+            <a:r>
+              <a:rPr b="1" i="0" u="none" dirty="0">
+                <a:solidFill>
+                  <a:srgbClr val="0F172A"/>
+                </a:solidFill>
+                <a:latin typeface="Space Grotesk"/>
+              </a:rPr>
+              <a:t>1. Knowledge Retrieval</a:t>
+            </a:r>
+          </a:p>
+        </p:txBody>
+      </p:sp>
+      <p:sp>
+        <p:nvSpPr>
+          <p:cNvPr id="30" name="TextBox 29"/>
+          <p:cNvSpPr txBox="1"/>
+          <p:nvPr/>
+        </p:nvSpPr>
+        <p:spPr>
+          <a:xfrm>
+            <a:off x="919162" y="3541006"/>
+            <a:ext cx="2219325" cy="1240724"/>
+          </a:xfrm>
+          <a:prstGeom prst="rect">
+            <a:avLst/>
+          </a:prstGeom>
+          <a:noFill/>
+        </p:spPr>
+        <p:txBody>
+          <a:bodyPr wrap="square" lIns="0" tIns="0" rIns="0" bIns="0" anchor="t">
+            <a:spAutoFit/>
+          </a:bodyPr>
+          <a:lstStyle/>
+          <a:p>
+            <a:pPr algn="l">
+              <a:lnSpc>
+                <a:spcPts val="1575"/>
+              </a:lnSpc>
+            </a:pPr>
+            <a:r>
+              <a:rPr b="0" i="0" u="none" dirty="0">
+                <a:solidFill>
+                  <a:srgbClr val="475569"/>
+                </a:solidFill>
+                <a:latin typeface="Inter"/>
+              </a:rPr>
+              <a:t>Fetches definitions, synonyms</a:t>
+            </a:r>
+            <a:r>
+              <a:rPr lang="en-US" dirty="0">
+                <a:solidFill>
+                  <a:srgbClr val="475569"/>
+                </a:solidFill>
+                <a:latin typeface="Inter"/>
+              </a:rPr>
+              <a:t> </a:t>
+            </a:r>
+            <a:r>
+              <a:rPr b="0" i="0" u="none" dirty="0">
+                <a:solidFill>
+                  <a:srgbClr val="475569"/>
+                </a:solidFill>
+                <a:latin typeface="Inter"/>
+              </a:rPr>
+              <a:t>and domain contexts from external knowledge bases to enrich concept descriptions.</a:t>
+            </a:r>
+          </a:p>
+        </p:txBody>
+      </p:sp>
+      <p:sp>
+        <p:nvSpPr>
+          <p:cNvPr id="31" name="TextBox 30"/>
+          <p:cNvSpPr txBox="1"/>
+          <p:nvPr/>
+        </p:nvSpPr>
+        <p:spPr>
+          <a:xfrm>
+            <a:off x="3638550" y="2933700"/>
+            <a:ext cx="2219325" cy="276999"/>
+          </a:xfrm>
+          <a:prstGeom prst="rect">
+            <a:avLst/>
+          </a:prstGeom>
+          <a:noFill/>
+        </p:spPr>
+        <p:txBody>
+          <a:bodyPr wrap="square" lIns="0" tIns="0" rIns="0" bIns="0" anchor="t">
+            <a:spAutoFit/>
+          </a:bodyPr>
+          <a:lstStyle/>
+          <a:p>
+            <a:pPr algn="l"/>
+            <a:r>
+              <a:rPr b="1" i="0" u="none" dirty="0">
+                <a:solidFill>
+                  <a:srgbClr val="0F172A"/>
+                </a:solidFill>
+                <a:latin typeface="Space Grotesk"/>
+              </a:rPr>
+              <a:t>2. Candidate Selection</a:t>
+            </a:r>
+          </a:p>
+        </p:txBody>
+      </p:sp>
+      <p:sp>
+        <p:nvSpPr>
+          <p:cNvPr id="32" name="TextBox 31"/>
+          <p:cNvSpPr txBox="1"/>
+          <p:nvPr/>
+        </p:nvSpPr>
+        <p:spPr>
+          <a:xfrm>
+            <a:off x="3638549" y="3541006"/>
+            <a:ext cx="2219325" cy="830356"/>
+          </a:xfrm>
+          <a:prstGeom prst="rect">
+            <a:avLst/>
+          </a:prstGeom>
+          <a:noFill/>
+        </p:spPr>
+        <p:txBody>
+          <a:bodyPr wrap="square" lIns="0" tIns="0" rIns="0" bIns="0" anchor="t">
+            <a:spAutoFit/>
+          </a:bodyPr>
+          <a:lstStyle/>
+          <a:p>
+            <a:pPr algn="l">
+              <a:lnSpc>
+                <a:spcPts val="1575"/>
+              </a:lnSpc>
+            </a:pPr>
+            <a:r>
+              <a:rPr b="0" i="0" u="none" dirty="0">
+                <a:solidFill>
+                  <a:srgbClr val="475569"/>
+                </a:solidFill>
+                <a:latin typeface="Inter"/>
+              </a:rPr>
+              <a:t>Fuses text embeddings with graph embeddings to prune non-matching pairs efficiently.</a:t>
+            </a:r>
+          </a:p>
+        </p:txBody>
+      </p:sp>
+      <p:sp>
+        <p:nvSpPr>
+          <p:cNvPr id="33" name="TextBox 32"/>
+          <p:cNvSpPr txBox="1"/>
+          <p:nvPr/>
+        </p:nvSpPr>
+        <p:spPr>
+          <a:xfrm>
+            <a:off x="6429375" y="2933700"/>
+            <a:ext cx="2219325" cy="276999"/>
+          </a:xfrm>
+          <a:prstGeom prst="rect">
+            <a:avLst/>
+          </a:prstGeom>
+          <a:noFill/>
+        </p:spPr>
+        <p:txBody>
+          <a:bodyPr wrap="square" lIns="0" tIns="0" rIns="0" bIns="0" anchor="t">
+            <a:spAutoFit/>
+          </a:bodyPr>
+          <a:lstStyle/>
+          <a:p>
+            <a:pPr algn="l"/>
+            <a:r>
+              <a:rPr b="1" i="0" u="none" dirty="0">
+                <a:solidFill>
+                  <a:srgbClr val="0F172A"/>
+                </a:solidFill>
+                <a:latin typeface="Space Grotesk"/>
+              </a:rPr>
+              <a:t>3. LLM Verification</a:t>
+            </a:r>
+          </a:p>
+        </p:txBody>
+      </p:sp>
+      <p:sp>
+        <p:nvSpPr>
+          <p:cNvPr id="34" name="TextBox 33"/>
+          <p:cNvSpPr txBox="1"/>
+          <p:nvPr/>
+        </p:nvSpPr>
+        <p:spPr>
+          <a:xfrm>
+            <a:off x="6429375" y="3539446"/>
+            <a:ext cx="2219325" cy="830356"/>
+          </a:xfrm>
+          <a:prstGeom prst="rect">
+            <a:avLst/>
+          </a:prstGeom>
+          <a:noFill/>
+        </p:spPr>
+        <p:txBody>
+          <a:bodyPr wrap="square" lIns="0" tIns="0" rIns="0" bIns="0" anchor="t">
+            <a:spAutoFit/>
+          </a:bodyPr>
+          <a:lstStyle/>
+          <a:p>
+            <a:pPr algn="l">
+              <a:lnSpc>
+                <a:spcPts val="1575"/>
+              </a:lnSpc>
+            </a:pPr>
+            <a:r>
+              <a:rPr b="0" i="0" u="none" dirty="0">
+                <a:solidFill>
+                  <a:srgbClr val="475569"/>
+                </a:solidFill>
+                <a:latin typeface="Inter"/>
+              </a:rPr>
+              <a:t>Evaluates candidate pairs through deep contextual reasoning using LLMs.</a:t>
+            </a:r>
+          </a:p>
+        </p:txBody>
+      </p:sp>
+      <p:sp>
+        <p:nvSpPr>
+          <p:cNvPr id="35" name="TextBox 34"/>
+          <p:cNvSpPr txBox="1"/>
+          <p:nvPr/>
+        </p:nvSpPr>
+        <p:spPr>
+          <a:xfrm>
+            <a:off x="9220200" y="2933700"/>
+            <a:ext cx="2219325" cy="261610"/>
+          </a:xfrm>
+          <a:prstGeom prst="rect">
+            <a:avLst/>
+          </a:prstGeom>
+          <a:noFill/>
+        </p:spPr>
+        <p:txBody>
+          <a:bodyPr wrap="square" lIns="0" tIns="0" rIns="0" bIns="0" anchor="t">
+            <a:spAutoFit/>
+          </a:bodyPr>
+          <a:lstStyle/>
+          <a:p>
+            <a:pPr algn="l"/>
+            <a:r>
+              <a:rPr sz="1700" b="1" i="0" u="none" dirty="0">
+                <a:solidFill>
+                  <a:srgbClr val="0F172A"/>
+                </a:solidFill>
+                <a:latin typeface="Space Grotesk"/>
+              </a:rPr>
+              <a:t>4. Structural</a:t>
+            </a:r>
+            <a:r>
+              <a:rPr lang="en-US" sz="1700" b="1" i="0" u="none" dirty="0">
+                <a:solidFill>
+                  <a:srgbClr val="0F172A"/>
+                </a:solidFill>
+                <a:latin typeface="Space Grotesk"/>
+              </a:rPr>
+              <a:t> </a:t>
+            </a:r>
+            <a:r>
+              <a:rPr sz="1700" b="1" i="0" u="none" dirty="0">
+                <a:solidFill>
+                  <a:srgbClr val="0F172A"/>
+                </a:solidFill>
+                <a:latin typeface="Space Grotesk"/>
+              </a:rPr>
+              <a:t>Refinement</a:t>
+            </a:r>
+          </a:p>
+        </p:txBody>
+      </p:sp>
+      <p:sp>
+        <p:nvSpPr>
+          <p:cNvPr id="36" name="TextBox 35"/>
+          <p:cNvSpPr txBox="1"/>
+          <p:nvPr/>
+        </p:nvSpPr>
+        <p:spPr>
+          <a:xfrm>
+            <a:off x="9220200" y="3535094"/>
+            <a:ext cx="2219325" cy="1035540"/>
+          </a:xfrm>
+          <a:prstGeom prst="rect">
+            <a:avLst/>
+          </a:prstGeom>
+          <a:noFill/>
+        </p:spPr>
+        <p:txBody>
+          <a:bodyPr wrap="square" lIns="0" tIns="0" rIns="0" bIns="0" anchor="t">
+            <a:spAutoFit/>
+          </a:bodyPr>
+          <a:lstStyle/>
+          <a:p>
+            <a:pPr algn="l">
+              <a:lnSpc>
+                <a:spcPts val="1575"/>
+              </a:lnSpc>
+            </a:pPr>
+            <a:r>
+              <a:rPr b="0" i="0" u="none" dirty="0">
+                <a:solidFill>
+                  <a:srgbClr val="475569"/>
+                </a:solidFill>
+                <a:latin typeface="Inter"/>
+              </a:rPr>
+              <a:t>Validates predicted matches using parent-child hierarchical checks and </a:t>
+            </a:r>
+            <a:r>
+              <a:rPr b="0" i="0" u="none" dirty="0" err="1">
+                <a:solidFill>
+                  <a:srgbClr val="475569"/>
+                </a:solidFill>
+                <a:latin typeface="Inter"/>
+              </a:rPr>
+              <a:t>bisimilarity</a:t>
+            </a:r>
+            <a:r>
+              <a:rPr b="0" i="0" u="none" dirty="0">
+                <a:solidFill>
+                  <a:srgbClr val="475569"/>
+                </a:solidFill>
+                <a:latin typeface="Inter"/>
+              </a:rPr>
+              <a:t> properties.</a:t>
             </a:r>
           </a:p>
         </p:txBody>
@@ -6064,6 +6033,945 @@
       </p:grpSpPr>
       <p:sp>
         <p:nvSpPr>
+          <p:cNvPr id="2" name="Rectangle 1"/>
+          <p:cNvSpPr/>
+          <p:nvPr/>
+        </p:nvSpPr>
+        <p:spPr>
+          <a:xfrm>
+            <a:off x="609600" y="6076950"/>
+            <a:ext cx="10972800" cy="323850"/>
+          </a:xfrm>
+          <a:prstGeom prst="rect">
+            <a:avLst/>
+          </a:prstGeom>
+          <a:noFill/>
+          <a:ln>
+            <a:noFill/>
+          </a:ln>
+          <a:effectLst/>
+        </p:spPr>
+        <p:style>
+          <a:lnRef idx="1">
+            <a:schemeClr val="accent1"/>
+          </a:lnRef>
+          <a:fillRef idx="3">
+            <a:schemeClr val="accent1"/>
+          </a:fillRef>
+          <a:effectRef idx="2">
+            <a:schemeClr val="accent1"/>
+          </a:effectRef>
+          <a:fontRef idx="minor">
+            <a:schemeClr val="lt1"/>
+          </a:fontRef>
+        </p:style>
+        <p:txBody>
+          <a:bodyPr rtlCol="0" anchor="ctr"/>
+          <a:lstStyle/>
+          <a:p>
+            <a:pPr algn="ctr"/>
+            <a:endParaRPr/>
+          </a:p>
+        </p:txBody>
+      </p:sp>
+      <p:sp>
+        <p:nvSpPr>
+          <p:cNvPr id="3" name="Rounded Rectangle 2"/>
+          <p:cNvSpPr/>
+          <p:nvPr/>
+        </p:nvSpPr>
+        <p:spPr>
+          <a:xfrm>
+            <a:off x="609600" y="2475607"/>
+            <a:ext cx="4690169" cy="2192535"/>
+          </a:xfrm>
+          <a:prstGeom prst="roundRect">
+            <a:avLst>
+              <a:gd name="adj" fmla="val 6950"/>
+            </a:avLst>
+          </a:prstGeom>
+          <a:solidFill>
+            <a:srgbClr val="F0F9FF"/>
+          </a:solidFill>
+          <a:ln w="9525">
+            <a:solidFill>
+              <a:srgbClr val="BAE6FD"/>
+            </a:solidFill>
+          </a:ln>
+          <a:effectLst/>
+        </p:spPr>
+        <p:style>
+          <a:lnRef idx="1">
+            <a:schemeClr val="accent1"/>
+          </a:lnRef>
+          <a:fillRef idx="3">
+            <a:schemeClr val="accent1"/>
+          </a:fillRef>
+          <a:effectRef idx="2">
+            <a:schemeClr val="accent1"/>
+          </a:effectRef>
+          <a:fontRef idx="minor">
+            <a:schemeClr val="lt1"/>
+          </a:fontRef>
+        </p:style>
+        <p:txBody>
+          <a:bodyPr rtlCol="0" anchor="ctr"/>
+          <a:lstStyle/>
+          <a:p>
+            <a:pPr algn="ctr"/>
+            <a:endParaRPr/>
+          </a:p>
+        </p:txBody>
+      </p:sp>
+      <p:sp>
+        <p:nvSpPr>
+          <p:cNvPr id="4" name="Rectangle 3"/>
+          <p:cNvSpPr/>
+          <p:nvPr/>
+        </p:nvSpPr>
+        <p:spPr>
+          <a:xfrm>
+            <a:off x="609600" y="6076950"/>
+            <a:ext cx="10972800" cy="9525"/>
+          </a:xfrm>
+          <a:prstGeom prst="rect">
+            <a:avLst/>
+          </a:prstGeom>
+          <a:solidFill>
+            <a:srgbClr val="E2E8F0"/>
+          </a:solidFill>
+          <a:ln>
+            <a:noFill/>
+          </a:ln>
+          <a:effectLst/>
+        </p:spPr>
+        <p:style>
+          <a:lnRef idx="1">
+            <a:schemeClr val="accent1"/>
+          </a:lnRef>
+          <a:fillRef idx="3">
+            <a:schemeClr val="accent1"/>
+          </a:fillRef>
+          <a:effectRef idx="2">
+            <a:schemeClr val="accent1"/>
+          </a:effectRef>
+          <a:fontRef idx="minor">
+            <a:schemeClr val="lt1"/>
+          </a:fontRef>
+        </p:style>
+        <p:txBody>
+          <a:bodyPr rtlCol="0" anchor="ctr"/>
+          <a:lstStyle/>
+          <a:p>
+            <a:pPr algn="ctr"/>
+            <a:endParaRPr/>
+          </a:p>
+        </p:txBody>
+      </p:sp>
+      <p:sp>
+        <p:nvSpPr>
+          <p:cNvPr id="5" name="Rectangle 4"/>
+          <p:cNvSpPr/>
+          <p:nvPr/>
+        </p:nvSpPr>
+        <p:spPr>
+          <a:xfrm>
+            <a:off x="5591249" y="1827752"/>
+            <a:ext cx="5977830" cy="1063942"/>
+          </a:xfrm>
+          <a:prstGeom prst="rect">
+            <a:avLst/>
+          </a:prstGeom>
+          <a:solidFill>
+            <a:srgbClr val="F8FAFC"/>
+          </a:solidFill>
+          <a:ln>
+            <a:noFill/>
+          </a:ln>
+          <a:effectLst/>
+        </p:spPr>
+        <p:style>
+          <a:lnRef idx="1">
+            <a:schemeClr val="accent1"/>
+          </a:lnRef>
+          <a:fillRef idx="3">
+            <a:schemeClr val="accent1"/>
+          </a:fillRef>
+          <a:effectRef idx="2">
+            <a:schemeClr val="accent1"/>
+          </a:effectRef>
+          <a:fontRef idx="minor">
+            <a:schemeClr val="lt1"/>
+          </a:fontRef>
+        </p:style>
+        <p:txBody>
+          <a:bodyPr rtlCol="0" anchor="ctr"/>
+          <a:lstStyle/>
+          <a:p>
+            <a:pPr algn="ctr"/>
+            <a:endParaRPr/>
+          </a:p>
+        </p:txBody>
+      </p:sp>
+      <p:sp>
+        <p:nvSpPr>
+          <p:cNvPr id="6" name="Rectangle 5"/>
+          <p:cNvSpPr/>
+          <p:nvPr/>
+        </p:nvSpPr>
+        <p:spPr>
+          <a:xfrm>
+            <a:off x="5591250" y="3045998"/>
+            <a:ext cx="5977830" cy="1000126"/>
+          </a:xfrm>
+          <a:prstGeom prst="rect">
+            <a:avLst/>
+          </a:prstGeom>
+          <a:solidFill>
+            <a:srgbClr val="F8FAFC"/>
+          </a:solidFill>
+          <a:ln>
+            <a:noFill/>
+          </a:ln>
+          <a:effectLst/>
+        </p:spPr>
+        <p:style>
+          <a:lnRef idx="1">
+            <a:schemeClr val="accent1"/>
+          </a:lnRef>
+          <a:fillRef idx="3">
+            <a:schemeClr val="accent1"/>
+          </a:fillRef>
+          <a:effectRef idx="2">
+            <a:schemeClr val="accent1"/>
+          </a:effectRef>
+          <a:fontRef idx="minor">
+            <a:schemeClr val="lt1"/>
+          </a:fontRef>
+        </p:style>
+        <p:txBody>
+          <a:bodyPr rtlCol="0" anchor="ctr"/>
+          <a:lstStyle/>
+          <a:p>
+            <a:pPr algn="ctr"/>
+            <a:endParaRPr/>
+          </a:p>
+        </p:txBody>
+      </p:sp>
+      <p:sp>
+        <p:nvSpPr>
+          <p:cNvPr id="7" name="Rectangle 6"/>
+          <p:cNvSpPr/>
+          <p:nvPr/>
+        </p:nvSpPr>
+        <p:spPr>
+          <a:xfrm>
+            <a:off x="5591250" y="4196619"/>
+            <a:ext cx="5977830" cy="1047750"/>
+          </a:xfrm>
+          <a:prstGeom prst="rect">
+            <a:avLst/>
+          </a:prstGeom>
+          <a:solidFill>
+            <a:srgbClr val="FEF2F2"/>
+          </a:solidFill>
+          <a:ln>
+            <a:noFill/>
+          </a:ln>
+          <a:effectLst/>
+        </p:spPr>
+        <p:style>
+          <a:lnRef idx="1">
+            <a:schemeClr val="accent1"/>
+          </a:lnRef>
+          <a:fillRef idx="3">
+            <a:schemeClr val="accent1"/>
+          </a:fillRef>
+          <a:effectRef idx="2">
+            <a:schemeClr val="accent1"/>
+          </a:effectRef>
+          <a:fontRef idx="minor">
+            <a:schemeClr val="lt1"/>
+          </a:fontRef>
+        </p:style>
+        <p:txBody>
+          <a:bodyPr rtlCol="0" anchor="ctr"/>
+          <a:lstStyle/>
+          <a:p>
+            <a:pPr algn="ctr"/>
+            <a:endParaRPr/>
+          </a:p>
+        </p:txBody>
+      </p:sp>
+      <p:sp>
+        <p:nvSpPr>
+          <p:cNvPr id="8" name="Rectangle 7"/>
+          <p:cNvSpPr/>
+          <p:nvPr/>
+        </p:nvSpPr>
+        <p:spPr>
+          <a:xfrm>
+            <a:off x="5591249" y="1827752"/>
+            <a:ext cx="38100" cy="895350"/>
+          </a:xfrm>
+          <a:prstGeom prst="rect">
+            <a:avLst/>
+          </a:prstGeom>
+          <a:solidFill>
+            <a:srgbClr val="0284C7"/>
+          </a:solidFill>
+          <a:ln>
+            <a:noFill/>
+          </a:ln>
+          <a:effectLst/>
+        </p:spPr>
+        <p:style>
+          <a:lnRef idx="1">
+            <a:schemeClr val="accent1"/>
+          </a:lnRef>
+          <a:fillRef idx="3">
+            <a:schemeClr val="accent1"/>
+          </a:fillRef>
+          <a:effectRef idx="2">
+            <a:schemeClr val="accent1"/>
+          </a:effectRef>
+          <a:fontRef idx="minor">
+            <a:schemeClr val="lt1"/>
+          </a:fontRef>
+        </p:style>
+        <p:txBody>
+          <a:bodyPr rtlCol="0" anchor="ctr"/>
+          <a:lstStyle/>
+          <a:p>
+            <a:pPr algn="ctr"/>
+            <a:endParaRPr/>
+          </a:p>
+        </p:txBody>
+      </p:sp>
+      <p:sp>
+        <p:nvSpPr>
+          <p:cNvPr id="9" name="Rectangle 8"/>
+          <p:cNvSpPr/>
+          <p:nvPr/>
+        </p:nvSpPr>
+        <p:spPr>
+          <a:xfrm>
+            <a:off x="5591250" y="3029806"/>
+            <a:ext cx="38100" cy="895350"/>
+          </a:xfrm>
+          <a:prstGeom prst="rect">
+            <a:avLst/>
+          </a:prstGeom>
+          <a:solidFill>
+            <a:srgbClr val="0284C7"/>
+          </a:solidFill>
+          <a:ln>
+            <a:noFill/>
+          </a:ln>
+          <a:effectLst/>
+        </p:spPr>
+        <p:style>
+          <a:lnRef idx="1">
+            <a:schemeClr val="accent1"/>
+          </a:lnRef>
+          <a:fillRef idx="3">
+            <a:schemeClr val="accent1"/>
+          </a:fillRef>
+          <a:effectRef idx="2">
+            <a:schemeClr val="accent1"/>
+          </a:effectRef>
+          <a:fontRef idx="minor">
+            <a:schemeClr val="lt1"/>
+          </a:fontRef>
+        </p:style>
+        <p:txBody>
+          <a:bodyPr rtlCol="0" anchor="ctr"/>
+          <a:lstStyle/>
+          <a:p>
+            <a:pPr algn="ctr"/>
+            <a:endParaRPr/>
+          </a:p>
+        </p:txBody>
+      </p:sp>
+      <p:sp>
+        <p:nvSpPr>
+          <p:cNvPr id="10" name="Rectangle 9"/>
+          <p:cNvSpPr/>
+          <p:nvPr/>
+        </p:nvSpPr>
+        <p:spPr>
+          <a:xfrm>
+            <a:off x="5591250" y="4196619"/>
+            <a:ext cx="38100" cy="895350"/>
+          </a:xfrm>
+          <a:prstGeom prst="rect">
+            <a:avLst/>
+          </a:prstGeom>
+          <a:solidFill>
+            <a:srgbClr val="EF4444"/>
+          </a:solidFill>
+          <a:ln>
+            <a:noFill/>
+          </a:ln>
+          <a:effectLst/>
+        </p:spPr>
+        <p:style>
+          <a:lnRef idx="1">
+            <a:schemeClr val="accent1"/>
+          </a:lnRef>
+          <a:fillRef idx="3">
+            <a:schemeClr val="accent1"/>
+          </a:fillRef>
+          <a:effectRef idx="2">
+            <a:schemeClr val="accent1"/>
+          </a:effectRef>
+          <a:fontRef idx="minor">
+            <a:schemeClr val="lt1"/>
+          </a:fontRef>
+        </p:style>
+        <p:txBody>
+          <a:bodyPr rtlCol="0" anchor="ctr"/>
+          <a:lstStyle/>
+          <a:p>
+            <a:pPr algn="ctr"/>
+            <a:endParaRPr/>
+          </a:p>
+        </p:txBody>
+      </p:sp>
+      <p:sp>
+        <p:nvSpPr>
+          <p:cNvPr id="11" name="TextBox 10"/>
+          <p:cNvSpPr txBox="1"/>
+          <p:nvPr/>
+        </p:nvSpPr>
+        <p:spPr>
+          <a:xfrm>
+            <a:off x="609600" y="457200"/>
+            <a:ext cx="11582400" cy="171450"/>
+          </a:xfrm>
+          <a:prstGeom prst="rect">
+            <a:avLst/>
+          </a:prstGeom>
+          <a:noFill/>
+        </p:spPr>
+        <p:txBody>
+          <a:bodyPr wrap="none" lIns="0" tIns="0" rIns="0" bIns="0" anchor="t">
+            <a:spAutoFit/>
+          </a:bodyPr>
+          <a:lstStyle/>
+          <a:p>
+            <a:pPr algn="l"/>
+            <a:r>
+              <a:rPr sz="1050" b="1" i="0" u="none">
+                <a:solidFill>
+                  <a:srgbClr val="0284C7"/>
+                </a:solidFill>
+                <a:latin typeface="Space Grotesk"/>
+              </a:rPr>
+              <a:t>PAPER ANALYSIS • KEY FINDINGS</a:t>
+            </a:r>
+          </a:p>
+        </p:txBody>
+      </p:sp>
+      <p:sp>
+        <p:nvSpPr>
+          <p:cNvPr id="12" name="TextBox 11"/>
+          <p:cNvSpPr txBox="1"/>
+          <p:nvPr/>
+        </p:nvSpPr>
+        <p:spPr>
+          <a:xfrm>
+            <a:off x="609600" y="685800"/>
+            <a:ext cx="11582400" cy="381000"/>
+          </a:xfrm>
+          <a:prstGeom prst="rect">
+            <a:avLst/>
+          </a:prstGeom>
+          <a:noFill/>
+        </p:spPr>
+        <p:txBody>
+          <a:bodyPr wrap="none" lIns="0" tIns="0" rIns="0" bIns="0" anchor="t">
+            <a:spAutoFit/>
+          </a:bodyPr>
+          <a:lstStyle/>
+          <a:p>
+            <a:pPr algn="l"/>
+            <a:r>
+              <a:rPr sz="2400" b="1" i="0" u="none">
+                <a:solidFill>
+                  <a:srgbClr val="0F172A"/>
+                </a:solidFill>
+                <a:latin typeface="Space Grotesk"/>
+              </a:rPr>
+              <a:t>KROMA: Empirical Performance &amp; Insights</a:t>
+            </a:r>
+          </a:p>
+        </p:txBody>
+      </p:sp>
+      <p:sp>
+        <p:nvSpPr>
+          <p:cNvPr id="13" name="TextBox 12"/>
+          <p:cNvSpPr txBox="1"/>
+          <p:nvPr/>
+        </p:nvSpPr>
+        <p:spPr>
+          <a:xfrm>
+            <a:off x="609600" y="6238875"/>
+            <a:ext cx="4262437" cy="161925"/>
+          </a:xfrm>
+          <a:prstGeom prst="rect">
+            <a:avLst/>
+          </a:prstGeom>
+          <a:noFill/>
+        </p:spPr>
+        <p:txBody>
+          <a:bodyPr wrap="none" lIns="0" tIns="0" rIns="0" bIns="0" anchor="t">
+            <a:spAutoFit/>
+          </a:bodyPr>
+          <a:lstStyle/>
+          <a:p>
+            <a:pPr algn="l"/>
+            <a:r>
+              <a:rPr sz="1050" b="0" i="0" u="none" dirty="0">
+                <a:solidFill>
+                  <a:srgbClr val="64748B"/>
+                </a:solidFill>
+                <a:latin typeface="Inter"/>
+              </a:rPr>
+              <a:t>Source: Nguyen et al. (2025) experimental evaluations</a:t>
+            </a:r>
+          </a:p>
+        </p:txBody>
+      </p:sp>
+      <p:sp>
+        <p:nvSpPr>
+          <p:cNvPr id="14" name="TextBox 13"/>
+          <p:cNvSpPr txBox="1"/>
+          <p:nvPr/>
+        </p:nvSpPr>
+        <p:spPr>
+          <a:xfrm>
+            <a:off x="10125075" y="6238875"/>
+            <a:ext cx="1821656" cy="161925"/>
+          </a:xfrm>
+          <a:prstGeom prst="rect">
+            <a:avLst/>
+          </a:prstGeom>
+          <a:noFill/>
+        </p:spPr>
+        <p:txBody>
+          <a:bodyPr wrap="none" lIns="0" tIns="0" rIns="0" bIns="0" anchor="t">
+            <a:spAutoFit/>
+          </a:bodyPr>
+          <a:lstStyle/>
+          <a:p>
+            <a:pPr algn="l"/>
+            <a:r>
+              <a:rPr sz="1050" b="1" i="0" u="none">
+                <a:solidFill>
+                  <a:srgbClr val="0F172A"/>
+                </a:solidFill>
+                <a:latin typeface="Inter"/>
+              </a:rPr>
+              <a:t>OAEI Benchmark Suite</a:t>
+            </a:r>
+          </a:p>
+        </p:txBody>
+      </p:sp>
+      <p:sp>
+        <p:nvSpPr>
+          <p:cNvPr id="15" name="TextBox 14"/>
+          <p:cNvSpPr txBox="1"/>
+          <p:nvPr/>
+        </p:nvSpPr>
+        <p:spPr>
+          <a:xfrm>
+            <a:off x="463860" y="2828032"/>
+            <a:ext cx="4981649" cy="685800"/>
+          </a:xfrm>
+          <a:prstGeom prst="rect">
+            <a:avLst/>
+          </a:prstGeom>
+          <a:noFill/>
+        </p:spPr>
+        <p:txBody>
+          <a:bodyPr wrap="none" lIns="0" tIns="0" rIns="0" bIns="0" anchor="t">
+            <a:spAutoFit/>
+          </a:bodyPr>
+          <a:lstStyle/>
+          <a:p>
+            <a:pPr algn="ctr">
+              <a:lnSpc>
+                <a:spcPts val="5400"/>
+              </a:lnSpc>
+            </a:pPr>
+            <a:r>
+              <a:rPr sz="5400" b="1" i="0" u="none">
+                <a:solidFill>
+                  <a:srgbClr val="0284C7"/>
+                </a:solidFill>
+                <a:latin typeface="Space Grotesk"/>
+              </a:rPr>
+              <a:t>+10.95%</a:t>
+            </a:r>
+          </a:p>
+        </p:txBody>
+      </p:sp>
+      <p:sp>
+        <p:nvSpPr>
+          <p:cNvPr id="16" name="TextBox 15"/>
+          <p:cNvSpPr txBox="1"/>
+          <p:nvPr/>
+        </p:nvSpPr>
+        <p:spPr>
+          <a:xfrm>
+            <a:off x="1682733" y="3527732"/>
+            <a:ext cx="2543902" cy="276999"/>
+          </a:xfrm>
+          <a:prstGeom prst="rect">
+            <a:avLst/>
+          </a:prstGeom>
+          <a:noFill/>
+        </p:spPr>
+        <p:txBody>
+          <a:bodyPr wrap="none" lIns="0" tIns="0" rIns="0" bIns="0" anchor="t">
+            <a:spAutoFit/>
+          </a:bodyPr>
+          <a:lstStyle/>
+          <a:p>
+            <a:pPr algn="ctr"/>
+            <a:r>
+              <a:rPr b="1" i="0" u="none" dirty="0">
+                <a:solidFill>
+                  <a:srgbClr val="0F172A"/>
+                </a:solidFill>
+                <a:latin typeface="Inter"/>
+              </a:rPr>
+              <a:t>Average Performance Gain</a:t>
+            </a:r>
+          </a:p>
+        </p:txBody>
+      </p:sp>
+      <p:sp>
+        <p:nvSpPr>
+          <p:cNvPr id="17" name="TextBox 16"/>
+          <p:cNvSpPr txBox="1"/>
+          <p:nvPr/>
+        </p:nvSpPr>
+        <p:spPr>
+          <a:xfrm>
+            <a:off x="463860" y="3942457"/>
+            <a:ext cx="4981649" cy="397545"/>
+          </a:xfrm>
+          <a:prstGeom prst="rect">
+            <a:avLst/>
+          </a:prstGeom>
+          <a:noFill/>
+        </p:spPr>
+        <p:txBody>
+          <a:bodyPr wrap="square" lIns="0" tIns="0" rIns="0" bIns="0" anchor="t">
+            <a:spAutoFit/>
+          </a:bodyPr>
+          <a:lstStyle/>
+          <a:p>
+            <a:pPr algn="ctr">
+              <a:lnSpc>
+                <a:spcPts val="1470"/>
+              </a:lnSpc>
+            </a:pPr>
+            <a:r>
+              <a:rPr b="0" i="0" u="none" dirty="0">
+                <a:solidFill>
+                  <a:srgbClr val="475569"/>
+                </a:solidFill>
+                <a:latin typeface="Inter"/>
+              </a:rPr>
+              <a:t>Outperforms existing LLM-based matching frameworks on standard OAEI benchmarks.</a:t>
+            </a:r>
+          </a:p>
+        </p:txBody>
+      </p:sp>
+      <p:sp>
+        <p:nvSpPr>
+          <p:cNvPr id="25" name="TextBox 24">
+            <a:extLst>
+              <a:ext uri="{FF2B5EF4-FFF2-40B4-BE49-F238E27FC236}">
+                <a16:creationId xmlns:a16="http://schemas.microsoft.com/office/drawing/2014/main" id="{B8B7735F-1AA8-4A22-7D67-1D8E4861C585}"/>
+              </a:ext>
+            </a:extLst>
+          </p:cNvPr>
+          <p:cNvSpPr txBox="1"/>
+          <p:nvPr/>
+        </p:nvSpPr>
+        <p:spPr>
+          <a:xfrm>
+            <a:off x="5736989" y="1989677"/>
+            <a:ext cx="2701702" cy="246221"/>
+          </a:xfrm>
+          <a:prstGeom prst="rect">
+            <a:avLst/>
+          </a:prstGeom>
+          <a:noFill/>
+        </p:spPr>
+        <p:txBody>
+          <a:bodyPr wrap="none" lIns="0" tIns="0" rIns="0" bIns="0" anchor="t">
+            <a:spAutoFit/>
+          </a:bodyPr>
+          <a:lstStyle/>
+          <a:p>
+            <a:pPr algn="l"/>
+            <a:r>
+              <a:rPr sz="1600" b="1" i="0" u="none" dirty="0">
+                <a:solidFill>
+                  <a:srgbClr val="1F2937"/>
+                </a:solidFill>
+                <a:latin typeface="Inter"/>
+              </a:rPr>
+              <a:t>Retrieval &amp; Refinement Synergy</a:t>
+            </a:r>
+          </a:p>
+        </p:txBody>
+      </p:sp>
+      <p:sp>
+        <p:nvSpPr>
+          <p:cNvPr id="27" name="TextBox 26">
+            <a:extLst>
+              <a:ext uri="{FF2B5EF4-FFF2-40B4-BE49-F238E27FC236}">
+                <a16:creationId xmlns:a16="http://schemas.microsoft.com/office/drawing/2014/main" id="{D2FCF090-1E96-13E2-310A-93311D82E09B}"/>
+              </a:ext>
+            </a:extLst>
+          </p:cNvPr>
+          <p:cNvSpPr txBox="1"/>
+          <p:nvPr/>
+        </p:nvSpPr>
+        <p:spPr>
+          <a:xfrm>
+            <a:off x="5736989" y="2227802"/>
+            <a:ext cx="4868167" cy="492443"/>
+          </a:xfrm>
+          <a:prstGeom prst="rect">
+            <a:avLst/>
+          </a:prstGeom>
+          <a:noFill/>
+        </p:spPr>
+        <p:txBody>
+          <a:bodyPr wrap="square" lIns="0" tIns="0" rIns="0" bIns="0" anchor="t">
+            <a:spAutoFit/>
+          </a:bodyPr>
+          <a:lstStyle/>
+          <a:p>
+            <a:pPr algn="l"/>
+            <a:r>
+              <a:rPr sz="1600" b="0" i="0" u="none" dirty="0">
+                <a:solidFill>
+                  <a:srgbClr val="4B5563"/>
+                </a:solidFill>
+                <a:latin typeface="Inter"/>
+              </a:rPr>
+              <a:t>Both external knowledge integration and parent-child validation directly boost accuracy.</a:t>
+            </a:r>
+          </a:p>
+        </p:txBody>
+      </p:sp>
+      <p:sp>
+        <p:nvSpPr>
+          <p:cNvPr id="29" name="TextBox 28">
+            <a:extLst>
+              <a:ext uri="{FF2B5EF4-FFF2-40B4-BE49-F238E27FC236}">
+                <a16:creationId xmlns:a16="http://schemas.microsoft.com/office/drawing/2014/main" id="{76D345E1-30EC-6272-B38F-576EA0111FDF}"/>
+              </a:ext>
+            </a:extLst>
+          </p:cNvPr>
+          <p:cNvSpPr txBox="1"/>
+          <p:nvPr/>
+        </p:nvSpPr>
+        <p:spPr>
+          <a:xfrm>
+            <a:off x="5736990" y="3196493"/>
+            <a:ext cx="2092239" cy="246221"/>
+          </a:xfrm>
+          <a:prstGeom prst="rect">
+            <a:avLst/>
+          </a:prstGeom>
+          <a:noFill/>
+        </p:spPr>
+        <p:txBody>
+          <a:bodyPr wrap="none" lIns="0" tIns="0" rIns="0" bIns="0" anchor="t">
+            <a:spAutoFit/>
+          </a:bodyPr>
+          <a:lstStyle/>
+          <a:p>
+            <a:pPr algn="l"/>
+            <a:r>
+              <a:rPr sz="1600" b="1" i="0" u="none" dirty="0">
+                <a:solidFill>
+                  <a:srgbClr val="1F2937"/>
+                </a:solidFill>
+                <a:latin typeface="Inter"/>
+              </a:rPr>
+              <a:t>Computational Trade-off</a:t>
+            </a:r>
+          </a:p>
+        </p:txBody>
+      </p:sp>
+      <p:sp>
+        <p:nvSpPr>
+          <p:cNvPr id="31" name="TextBox 30">
+            <a:extLst>
+              <a:ext uri="{FF2B5EF4-FFF2-40B4-BE49-F238E27FC236}">
+                <a16:creationId xmlns:a16="http://schemas.microsoft.com/office/drawing/2014/main" id="{57632D59-7239-3A32-FC14-184A641FC034}"/>
+              </a:ext>
+            </a:extLst>
+          </p:cNvPr>
+          <p:cNvSpPr txBox="1"/>
+          <p:nvPr/>
+        </p:nvSpPr>
+        <p:spPr>
+          <a:xfrm>
+            <a:off x="5736990" y="3434618"/>
+            <a:ext cx="4868167" cy="492443"/>
+          </a:xfrm>
+          <a:prstGeom prst="rect">
+            <a:avLst/>
+          </a:prstGeom>
+          <a:noFill/>
+        </p:spPr>
+        <p:txBody>
+          <a:bodyPr wrap="square" lIns="0" tIns="0" rIns="0" bIns="0" anchor="t">
+            <a:spAutoFit/>
+          </a:bodyPr>
+          <a:lstStyle/>
+          <a:p>
+            <a:pPr algn="l"/>
+            <a:r>
+              <a:rPr sz="1600" b="0" i="0" u="none">
+                <a:solidFill>
+                  <a:srgbClr val="4B5563"/>
+                </a:solidFill>
+                <a:latin typeface="Inter"/>
+              </a:rPr>
+              <a:t>Multi-agent debate and extended reasoning increase costs without guaranteeing accuracy gains.</a:t>
+            </a:r>
+          </a:p>
+        </p:txBody>
+      </p:sp>
+      <p:sp>
+        <p:nvSpPr>
+          <p:cNvPr id="33" name="TextBox 32">
+            <a:extLst>
+              <a:ext uri="{FF2B5EF4-FFF2-40B4-BE49-F238E27FC236}">
+                <a16:creationId xmlns:a16="http://schemas.microsoft.com/office/drawing/2014/main" id="{B1D73212-2E02-0B96-04EC-568296888ACB}"/>
+              </a:ext>
+            </a:extLst>
+          </p:cNvPr>
+          <p:cNvSpPr txBox="1"/>
+          <p:nvPr/>
+        </p:nvSpPr>
+        <p:spPr>
+          <a:xfrm>
+            <a:off x="5736990" y="4358544"/>
+            <a:ext cx="2561920" cy="246221"/>
+          </a:xfrm>
+          <a:prstGeom prst="rect">
+            <a:avLst/>
+          </a:prstGeom>
+          <a:noFill/>
+        </p:spPr>
+        <p:txBody>
+          <a:bodyPr wrap="none" lIns="0" tIns="0" rIns="0" bIns="0" anchor="t">
+            <a:spAutoFit/>
+          </a:bodyPr>
+          <a:lstStyle/>
+          <a:p>
+            <a:pPr algn="l"/>
+            <a:r>
+              <a:rPr sz="1600" b="1" i="0" u="none">
+                <a:solidFill>
+                  <a:srgbClr val="1F2937"/>
+                </a:solidFill>
+                <a:latin typeface="Inter"/>
+              </a:rPr>
+              <a:t>Specialized Domain Limitation</a:t>
+            </a:r>
+          </a:p>
+        </p:txBody>
+      </p:sp>
+      <p:sp>
+        <p:nvSpPr>
+          <p:cNvPr id="35" name="TextBox 34">
+            <a:extLst>
+              <a:ext uri="{FF2B5EF4-FFF2-40B4-BE49-F238E27FC236}">
+                <a16:creationId xmlns:a16="http://schemas.microsoft.com/office/drawing/2014/main" id="{862F728A-CFB1-8FB9-BC00-F6EF774F92EA}"/>
+              </a:ext>
+            </a:extLst>
+          </p:cNvPr>
+          <p:cNvSpPr txBox="1"/>
+          <p:nvPr/>
+        </p:nvSpPr>
+        <p:spPr>
+          <a:xfrm>
+            <a:off x="5736990" y="4596669"/>
+            <a:ext cx="4868167" cy="492443"/>
+          </a:xfrm>
+          <a:prstGeom prst="rect">
+            <a:avLst/>
+          </a:prstGeom>
+          <a:noFill/>
+        </p:spPr>
+        <p:txBody>
+          <a:bodyPr wrap="square" lIns="0" tIns="0" rIns="0" bIns="0" anchor="t">
+            <a:spAutoFit/>
+          </a:bodyPr>
+          <a:lstStyle/>
+          <a:p>
+            <a:pPr algn="l"/>
+            <a:r>
+              <a:rPr sz="1600" b="0" i="0" u="none" dirty="0">
+                <a:solidFill>
+                  <a:srgbClr val="4B5563"/>
+                </a:solidFill>
+                <a:latin typeface="Inter"/>
+              </a:rPr>
+              <a:t>Performance drops in sparse knowledge domains like materials science.</a:t>
+            </a:r>
+          </a:p>
+        </p:txBody>
+      </p:sp>
+    </p:spTree>
+  </p:cSld>
+  <p:clrMapOvr>
+    <a:masterClrMapping/>
+  </p:clrMapOvr>
+</p:sld>
+</file>
+
+<file path=ppt/slides/slide5.xml><?xml version="1.0" encoding="utf-8"?>
+<p:sld xmlns:a="http://schemas.openxmlformats.org/drawingml/2006/main" xmlns:r="http://schemas.openxmlformats.org/officeDocument/2006/relationships" xmlns:p="http://schemas.openxmlformats.org/presentationml/2006/main">
+  <p:cSld>
+    <p:bg>
+      <p:bgPr>
+        <a:solidFill>
+          <a:srgbClr val="FFFFFF"/>
+        </a:solidFill>
+        <a:effectLst/>
+      </p:bgPr>
+    </p:bg>
+    <p:spTree>
+      <p:nvGrpSpPr>
+        <p:cNvPr id="1" name=""/>
+        <p:cNvGrpSpPr/>
+        <p:nvPr/>
+      </p:nvGrpSpPr>
+      <p:grpSpPr>
+        <a:xfrm>
+          <a:off x="0" y="0"/>
+          <a:ext cx="0" cy="0"/>
+          <a:chOff x="0" y="0"/>
+          <a:chExt cx="0" cy="0"/>
+        </a:xfrm>
+      </p:grpSpPr>
+      <p:sp>
+        <p:nvSpPr>
           <p:cNvPr id="2" name="Rounded Rectangle 1"/>
           <p:cNvSpPr/>
           <p:nvPr/>
@@ -7311,7 +8219,7 @@
 </p:sld>
 </file>
 
-<file path=ppt/slides/slide5.xml><?xml version="1.0" encoding="utf-8"?>
+<file path=ppt/slides/slide6.xml><?xml version="1.0" encoding="utf-8"?>
 <p:sld xmlns:a="http://schemas.openxmlformats.org/drawingml/2006/main" xmlns:r="http://schemas.openxmlformats.org/officeDocument/2006/relationships" xmlns:p="http://schemas.openxmlformats.org/presentationml/2006/main">
   <p:cSld>
     <p:bg>
@@ -8308,7 +9216,7 @@
 </p:sld>
 </file>
 
-<file path=ppt/slides/slide6.xml><?xml version="1.0" encoding="utf-8"?>
+<file path=ppt/slides/slide7.xml><?xml version="1.0" encoding="utf-8"?>
 <p:sld xmlns:a="http://schemas.openxmlformats.org/drawingml/2006/main" xmlns:r="http://schemas.openxmlformats.org/officeDocument/2006/relationships" xmlns:p="http://schemas.openxmlformats.org/presentationml/2006/main">
   <p:cSld>
     <p:bg>
@@ -9321,7 +10229,7 @@
 </p:sld>
 </file>
 
-<file path=ppt/slides/slide7.xml><?xml version="1.0" encoding="utf-8"?>
+<file path=ppt/slides/slide8.xml><?xml version="1.0" encoding="utf-8"?>
 <p:sld xmlns:a="http://schemas.openxmlformats.org/drawingml/2006/main" xmlns:r="http://schemas.openxmlformats.org/officeDocument/2006/relationships" xmlns:p="http://schemas.openxmlformats.org/presentationml/2006/main">
   <p:cSld>
     <p:bg>

</xml_diff>

<commit_message>
Commit: ACL RR1 Presentation Update
</commit_message>
<xml_diff>
--- a/Year2_Semester1_ApplicationComputationalLinguistics/RR1_Presentation_Week2/Todoran_RR1.pptx
+++ b/Year2_Semester1_ApplicationComputationalLinguistics/RR1_Presentation_Week2/Todoran_RR1.pptx
@@ -6082,7 +6082,7 @@
         </p:nvSpPr>
         <p:spPr>
           <a:xfrm>
-            <a:off x="609600" y="2475607"/>
+            <a:off x="609600" y="3737371"/>
             <a:ext cx="4690169" cy="2192535"/>
           </a:xfrm>
           <a:prstGeom prst="roundRect">
@@ -6170,14 +6170,14 @@
       </p:sp>
       <p:sp>
         <p:nvSpPr>
-          <p:cNvPr id="5" name="Rectangle 4"/>
+          <p:cNvPr id="6" name="Rectangle 5"/>
           <p:cNvSpPr/>
           <p:nvPr/>
         </p:nvSpPr>
         <p:spPr>
           <a:xfrm>
-            <a:off x="5591249" y="1827752"/>
-            <a:ext cx="5977830" cy="1063942"/>
+            <a:off x="5569685" y="3737381"/>
+            <a:ext cx="5977830" cy="1000126"/>
           </a:xfrm>
           <a:prstGeom prst="rect">
             <a:avLst/>
@@ -6215,58 +6215,13 @@
       </p:sp>
       <p:sp>
         <p:nvSpPr>
-          <p:cNvPr id="6" name="Rectangle 5"/>
-          <p:cNvSpPr/>
-          <p:nvPr/>
-        </p:nvSpPr>
-        <p:spPr>
-          <a:xfrm>
-            <a:off x="5591250" y="3045998"/>
-            <a:ext cx="5977830" cy="1000126"/>
-          </a:xfrm>
-          <a:prstGeom prst="rect">
-            <a:avLst/>
-          </a:prstGeom>
-          <a:solidFill>
-            <a:srgbClr val="F8FAFC"/>
-          </a:solidFill>
-          <a:ln>
-            <a:noFill/>
-          </a:ln>
-          <a:effectLst/>
-        </p:spPr>
-        <p:style>
-          <a:lnRef idx="1">
-            <a:schemeClr val="accent1"/>
-          </a:lnRef>
-          <a:fillRef idx="3">
-            <a:schemeClr val="accent1"/>
-          </a:fillRef>
-          <a:effectRef idx="2">
-            <a:schemeClr val="accent1"/>
-          </a:effectRef>
-          <a:fontRef idx="minor">
-            <a:schemeClr val="lt1"/>
-          </a:fontRef>
-        </p:style>
-        <p:txBody>
-          <a:bodyPr rtlCol="0" anchor="ctr"/>
-          <a:lstStyle/>
-          <a:p>
-            <a:pPr algn="ctr"/>
-            <a:endParaRPr/>
-          </a:p>
-        </p:txBody>
-      </p:sp>
-      <p:sp>
-        <p:nvSpPr>
           <p:cNvPr id="7" name="Rectangle 6"/>
           <p:cNvSpPr/>
           <p:nvPr/>
         </p:nvSpPr>
         <p:spPr>
           <a:xfrm>
-            <a:off x="5591250" y="4196619"/>
+            <a:off x="5569685" y="4888002"/>
             <a:ext cx="5977830" cy="1047750"/>
           </a:xfrm>
           <a:prstGeom prst="rect">
@@ -6305,13 +6260,13 @@
       </p:sp>
       <p:sp>
         <p:nvSpPr>
-          <p:cNvPr id="8" name="Rectangle 7"/>
+          <p:cNvPr id="9" name="Rectangle 8"/>
           <p:cNvSpPr/>
           <p:nvPr/>
         </p:nvSpPr>
         <p:spPr>
           <a:xfrm>
-            <a:off x="5591249" y="1827752"/>
+            <a:off x="5569685" y="3721189"/>
             <a:ext cx="38100" cy="895350"/>
           </a:xfrm>
           <a:prstGeom prst="rect">
@@ -6350,58 +6305,13 @@
       </p:sp>
       <p:sp>
         <p:nvSpPr>
-          <p:cNvPr id="9" name="Rectangle 8"/>
-          <p:cNvSpPr/>
-          <p:nvPr/>
-        </p:nvSpPr>
-        <p:spPr>
-          <a:xfrm>
-            <a:off x="5591250" y="3029806"/>
-            <a:ext cx="38100" cy="895350"/>
-          </a:xfrm>
-          <a:prstGeom prst="rect">
-            <a:avLst/>
-          </a:prstGeom>
-          <a:solidFill>
-            <a:srgbClr val="0284C7"/>
-          </a:solidFill>
-          <a:ln>
-            <a:noFill/>
-          </a:ln>
-          <a:effectLst/>
-        </p:spPr>
-        <p:style>
-          <a:lnRef idx="1">
-            <a:schemeClr val="accent1"/>
-          </a:lnRef>
-          <a:fillRef idx="3">
-            <a:schemeClr val="accent1"/>
-          </a:fillRef>
-          <a:effectRef idx="2">
-            <a:schemeClr val="accent1"/>
-          </a:effectRef>
-          <a:fontRef idx="minor">
-            <a:schemeClr val="lt1"/>
-          </a:fontRef>
-        </p:style>
-        <p:txBody>
-          <a:bodyPr rtlCol="0" anchor="ctr"/>
-          <a:lstStyle/>
-          <a:p>
-            <a:pPr algn="ctr"/>
-            <a:endParaRPr/>
-          </a:p>
-        </p:txBody>
-      </p:sp>
-      <p:sp>
-        <p:nvSpPr>
           <p:cNvPr id="10" name="Rectangle 9"/>
           <p:cNvSpPr/>
           <p:nvPr/>
         </p:nvSpPr>
         <p:spPr>
           <a:xfrm>
-            <a:off x="5591250" y="4196619"/>
+            <a:off x="5569685" y="4888002"/>
             <a:ext cx="38100" cy="895350"/>
           </a:xfrm>
           <a:prstGeom prst="rect">
@@ -6586,7 +6496,7 @@
         </p:nvSpPr>
         <p:spPr>
           <a:xfrm>
-            <a:off x="463860" y="2828032"/>
+            <a:off x="463860" y="4089796"/>
             <a:ext cx="4981649" cy="685800"/>
           </a:xfrm>
           <a:prstGeom prst="rect">
@@ -6625,7 +6535,7 @@
         </p:nvSpPr>
         <p:spPr>
           <a:xfrm>
-            <a:off x="1682733" y="3527732"/>
+            <a:off x="1682733" y="4789496"/>
             <a:ext cx="2543902" cy="276999"/>
           </a:xfrm>
           <a:prstGeom prst="rect">
@@ -6660,7 +6570,7 @@
         </p:nvSpPr>
         <p:spPr>
           <a:xfrm>
-            <a:off x="463860" y="3942457"/>
+            <a:off x="463860" y="5204221"/>
             <a:ext cx="4981649" cy="397545"/>
           </a:xfrm>
           <a:prstGeom prst="rect">
@@ -6687,88 +6597,6 @@
                 <a:latin typeface="Inter"/>
               </a:rPr>
               <a:t>Outperforms existing LLM-based matching frameworks on standard OAEI benchmarks.</a:t>
-            </a:r>
-          </a:p>
-        </p:txBody>
-      </p:sp>
-      <p:sp>
-        <p:nvSpPr>
-          <p:cNvPr id="25" name="TextBox 24">
-            <a:extLst>
-              <a:ext uri="{FF2B5EF4-FFF2-40B4-BE49-F238E27FC236}">
-                <a16:creationId xmlns:a16="http://schemas.microsoft.com/office/drawing/2014/main" id="{B8B7735F-1AA8-4A22-7D67-1D8E4861C585}"/>
-              </a:ext>
-            </a:extLst>
-          </p:cNvPr>
-          <p:cNvSpPr txBox="1"/>
-          <p:nvPr/>
-        </p:nvSpPr>
-        <p:spPr>
-          <a:xfrm>
-            <a:off x="5736989" y="1989677"/>
-            <a:ext cx="2701702" cy="246221"/>
-          </a:xfrm>
-          <a:prstGeom prst="rect">
-            <a:avLst/>
-          </a:prstGeom>
-          <a:noFill/>
-        </p:spPr>
-        <p:txBody>
-          <a:bodyPr wrap="none" lIns="0" tIns="0" rIns="0" bIns="0" anchor="t">
-            <a:spAutoFit/>
-          </a:bodyPr>
-          <a:lstStyle/>
-          <a:p>
-            <a:pPr algn="l"/>
-            <a:r>
-              <a:rPr sz="1600" b="1" i="0" u="none" dirty="0">
-                <a:solidFill>
-                  <a:srgbClr val="1F2937"/>
-                </a:solidFill>
-                <a:latin typeface="Inter"/>
-              </a:rPr>
-              <a:t>Retrieval &amp; Refinement Synergy</a:t>
-            </a:r>
-          </a:p>
-        </p:txBody>
-      </p:sp>
-      <p:sp>
-        <p:nvSpPr>
-          <p:cNvPr id="27" name="TextBox 26">
-            <a:extLst>
-              <a:ext uri="{FF2B5EF4-FFF2-40B4-BE49-F238E27FC236}">
-                <a16:creationId xmlns:a16="http://schemas.microsoft.com/office/drawing/2014/main" id="{D2FCF090-1E96-13E2-310A-93311D82E09B}"/>
-              </a:ext>
-            </a:extLst>
-          </p:cNvPr>
-          <p:cNvSpPr txBox="1"/>
-          <p:nvPr/>
-        </p:nvSpPr>
-        <p:spPr>
-          <a:xfrm>
-            <a:off x="5736989" y="2227802"/>
-            <a:ext cx="4868167" cy="492443"/>
-          </a:xfrm>
-          <a:prstGeom prst="rect">
-            <a:avLst/>
-          </a:prstGeom>
-          <a:noFill/>
-        </p:spPr>
-        <p:txBody>
-          <a:bodyPr wrap="square" lIns="0" tIns="0" rIns="0" bIns="0" anchor="t">
-            <a:spAutoFit/>
-          </a:bodyPr>
-          <a:lstStyle/>
-          <a:p>
-            <a:pPr algn="l"/>
-            <a:r>
-              <a:rPr sz="1600" b="0" i="0" u="none" dirty="0">
-                <a:solidFill>
-                  <a:srgbClr val="4B5563"/>
-                </a:solidFill>
-                <a:latin typeface="Inter"/>
-              </a:rPr>
-              <a:t>Both external knowledge integration and parent-child validation directly boost accuracy.</a:t>
             </a:r>
           </a:p>
         </p:txBody>
@@ -6787,7 +6615,7 @@
         </p:nvSpPr>
         <p:spPr>
           <a:xfrm>
-            <a:off x="5736990" y="3196493"/>
+            <a:off x="5715425" y="3887876"/>
             <a:ext cx="2092239" cy="246221"/>
           </a:xfrm>
           <a:prstGeom prst="rect">
@@ -6828,7 +6656,7 @@
         </p:nvSpPr>
         <p:spPr>
           <a:xfrm>
-            <a:off x="5736990" y="3434618"/>
+            <a:off x="5715425" y="4126001"/>
             <a:ext cx="4868167" cy="492443"/>
           </a:xfrm>
           <a:prstGeom prst="rect">
@@ -6869,7 +6697,7 @@
         </p:nvSpPr>
         <p:spPr>
           <a:xfrm>
-            <a:off x="5736990" y="4358544"/>
+            <a:off x="5715425" y="5049927"/>
             <a:ext cx="2561920" cy="246221"/>
           </a:xfrm>
           <a:prstGeom prst="rect">
@@ -6910,7 +6738,7 @@
         </p:nvSpPr>
         <p:spPr>
           <a:xfrm>
-            <a:off x="5736990" y="4596669"/>
+            <a:off x="5715425" y="5288052"/>
             <a:ext cx="4868167" cy="492443"/>
           </a:xfrm>
           <a:prstGeom prst="rect">
@@ -6937,6 +6765,66 @@
           </a:p>
         </p:txBody>
       </p:sp>
+      <p:pic>
+        <p:nvPicPr>
+          <p:cNvPr id="19" name="Picture 18">
+            <a:extLst>
+              <a:ext uri="{FF2B5EF4-FFF2-40B4-BE49-F238E27FC236}">
+                <a16:creationId xmlns:a16="http://schemas.microsoft.com/office/drawing/2014/main" id="{6C9DD0A7-74E2-4265-850E-883DD53C7C39}"/>
+              </a:ext>
+            </a:extLst>
+          </p:cNvPr>
+          <p:cNvPicPr>
+            <a:picLocks noChangeAspect="1"/>
+          </p:cNvPicPr>
+          <p:nvPr/>
+        </p:nvPicPr>
+        <p:blipFill>
+          <a:blip r:embed="rId2"/>
+          <a:stretch>
+            <a:fillRect/>
+          </a:stretch>
+        </p:blipFill>
+        <p:spPr>
+          <a:xfrm>
+            <a:off x="758488" y="1123950"/>
+            <a:ext cx="4711392" cy="2613421"/>
+          </a:xfrm>
+          <a:prstGeom prst="rect">
+            <a:avLst/>
+          </a:prstGeom>
+        </p:spPr>
+      </p:pic>
+      <p:pic>
+        <p:nvPicPr>
+          <p:cNvPr id="23" name="Picture 22">
+            <a:extLst>
+              <a:ext uri="{FF2B5EF4-FFF2-40B4-BE49-F238E27FC236}">
+                <a16:creationId xmlns:a16="http://schemas.microsoft.com/office/drawing/2014/main" id="{64A53131-A6E2-8E69-6189-1A10B9A2B480}"/>
+              </a:ext>
+            </a:extLst>
+          </p:cNvPr>
+          <p:cNvPicPr>
+            <a:picLocks noChangeAspect="1"/>
+          </p:cNvPicPr>
+          <p:nvPr/>
+        </p:nvPicPr>
+        <p:blipFill>
+          <a:blip r:embed="rId3"/>
+          <a:stretch>
+            <a:fillRect/>
+          </a:stretch>
+        </p:blipFill>
+        <p:spPr>
+          <a:xfrm>
+            <a:off x="5964958" y="1119688"/>
+            <a:ext cx="5342083" cy="2568163"/>
+          </a:xfrm>
+          <a:prstGeom prst="rect">
+            <a:avLst/>
+          </a:prstGeom>
+        </p:spPr>
+      </p:pic>
     </p:spTree>
   </p:cSld>
   <p:clrMapOvr>
@@ -7076,7 +6964,7 @@
         </p:nvSpPr>
         <p:spPr>
           <a:xfrm>
-            <a:off x="4561135" y="2571750"/>
+            <a:off x="4561135" y="1938337"/>
             <a:ext cx="3069728" cy="1876425"/>
           </a:xfrm>
           <a:prstGeom prst="roundRect">
@@ -7180,7 +7068,7 @@
         </p:blipFill>
         <p:spPr>
           <a:xfrm>
-            <a:off x="4827835" y="2838450"/>
+            <a:off x="4827835" y="2205037"/>
             <a:ext cx="2536328" cy="304800"/>
           </a:xfrm>
           <a:prstGeom prst="rect">
@@ -7336,7 +7224,7 @@
         </p:nvSpPr>
         <p:spPr>
           <a:xfrm>
-            <a:off x="4431534" y="3257550"/>
+            <a:off x="4431534" y="2624137"/>
             <a:ext cx="3328931" cy="247650"/>
           </a:xfrm>
           <a:prstGeom prst="rect">
@@ -8211,6 +8099,36 @@
           </a:p>
         </p:txBody>
       </p:sp>
+      <p:pic>
+        <p:nvPicPr>
+          <p:cNvPr id="12" name="Picture 11">
+            <a:extLst>
+              <a:ext uri="{FF2B5EF4-FFF2-40B4-BE49-F238E27FC236}">
+                <a16:creationId xmlns:a16="http://schemas.microsoft.com/office/drawing/2014/main" id="{1B92BE97-0C7B-F635-44A1-196FB4F97F4C}"/>
+              </a:ext>
+            </a:extLst>
+          </p:cNvPr>
+          <p:cNvPicPr>
+            <a:picLocks noChangeAspect="1"/>
+          </p:cNvPicPr>
+          <p:nvPr/>
+        </p:nvPicPr>
+        <p:blipFill>
+          <a:blip r:embed="rId7"/>
+          <a:stretch>
+            <a:fillRect/>
+          </a:stretch>
+        </p:blipFill>
+        <p:spPr>
+          <a:xfrm>
+            <a:off x="4384186" y="2871787"/>
+            <a:ext cx="3441079" cy="3038400"/>
+          </a:xfrm>
+          <a:prstGeom prst="rect">
+            <a:avLst/>
+          </a:prstGeom>
+        </p:spPr>
+      </p:pic>
     </p:spTree>
   </p:cSld>
   <p:clrMapOvr>

</xml_diff>